<commit_message>
docs: regenerate SIH26083 presentation aligning with references 1, 2, 3, 4 winning format
</commit_message>
<xml_diff>
--- a/docs/sih/SIH2026_IDEA_Presentation_SIH26083_Official.pptx
+++ b/docs/sih/SIH2026_IDEA_Presentation_SIH26083_Official.pptx
@@ -3109,7 +3109,7 @@
         </p:nvSpPr>
         <p:spPr>
           <a:xfrm>
-            <a:off x="731520" y="365760"/>
+            <a:off x="731520" y="320040"/>
             <a:ext cx="8686800" cy="548640"/>
           </a:xfrm>
           <a:prstGeom prst="rect">
@@ -3145,7 +3145,7 @@
         </p:nvSpPr>
         <p:spPr>
           <a:xfrm>
-            <a:off x="9601200" y="320040"/>
+            <a:off x="9601200" y="274320"/>
             <a:ext cx="2011680" cy="731520"/>
           </a:xfrm>
           <a:prstGeom prst="roundRect">
@@ -3211,7 +3211,7 @@
         </p:nvSpPr>
         <p:spPr>
           <a:xfrm>
-            <a:off x="731520" y="1097280"/>
+            <a:off x="731520" y="1051560"/>
             <a:ext cx="10728655" cy="731520"/>
           </a:xfrm>
           <a:prstGeom prst="rect">
@@ -3247,8 +3247,8 @@
         </p:nvSpPr>
         <p:spPr>
           <a:xfrm>
-            <a:off x="731520" y="1920240"/>
-            <a:ext cx="6217920" cy="4297680"/>
+            <a:off x="731520" y="1874519"/>
+            <a:ext cx="6217920" cy="4389120"/>
           </a:xfrm>
           <a:prstGeom prst="rect">
             <a:avLst/>
@@ -3262,7 +3262,7 @@
           <a:lstStyle/>
           <a:p>
             <a:pPr>
-              <a:defRPr sz="1200" b="1" u="sng">
+              <a:defRPr sz="1150" b="1" u="sng">
                 <a:solidFill>
                   <a:srgbClr val="0F172A"/>
                 </a:solidFill>
@@ -3284,9 +3284,9 @@
           <a:p>
             <a:pPr>
               <a:spcBef>
-                <a:spcPts val="800"/>
+                <a:spcPts val="700"/>
               </a:spcBef>
-              <a:defRPr sz="1200" b="1" u="sng">
+              <a:defRPr sz="1150" b="1" u="sng">
                 <a:solidFill>
                   <a:srgbClr val="0F172A"/>
                 </a:solidFill>
@@ -3308,9 +3308,9 @@
           <a:p>
             <a:pPr>
               <a:spcBef>
-                <a:spcPts val="800"/>
+                <a:spcPts val="700"/>
               </a:spcBef>
-              <a:defRPr sz="1200" b="1" u="sng">
+              <a:defRPr sz="1150" b="1" u="sng">
                 <a:solidFill>
                   <a:srgbClr val="0F172A"/>
                 </a:solidFill>
@@ -3332,9 +3332,9 @@
           <a:p>
             <a:pPr>
               <a:spcBef>
-                <a:spcPts val="800"/>
+                <a:spcPts val="700"/>
               </a:spcBef>
-              <a:defRPr sz="1200" b="1" u="sng">
+              <a:defRPr sz="1150" b="1" u="sng">
                 <a:solidFill>
                   <a:srgbClr val="0F172A"/>
                 </a:solidFill>
@@ -3356,9 +3356,9 @@
           <a:p>
             <a:pPr>
               <a:spcBef>
-                <a:spcPts val="800"/>
+                <a:spcPts val="700"/>
               </a:spcBef>
-              <a:defRPr sz="1200" b="1" u="sng">
+              <a:defRPr sz="1150" b="1" u="sng">
                 <a:solidFill>
                   <a:srgbClr val="0F172A"/>
                 </a:solidFill>
@@ -3380,9 +3380,9 @@
           <a:p>
             <a:pPr>
               <a:spcBef>
-                <a:spcPts val="800"/>
+                <a:spcPts val="700"/>
               </a:spcBef>
-              <a:defRPr sz="1200" b="1" u="sng">
+              <a:defRPr sz="1150" b="1" u="sng">
                 <a:solidFill>
                   <a:srgbClr val="0F172A"/>
                 </a:solidFill>
@@ -3404,9 +3404,9 @@
           <a:p>
             <a:pPr>
               <a:spcBef>
-                <a:spcPts val="800"/>
+                <a:spcPts val="700"/>
               </a:spcBef>
-              <a:defRPr sz="1200" b="1" u="sng">
+              <a:defRPr sz="1150" b="1" u="sng">
                 <a:solidFill>
                   <a:srgbClr val="0F172A"/>
                 </a:solidFill>
@@ -3435,8 +3435,8 @@
         </p:nvSpPr>
         <p:spPr>
           <a:xfrm>
-            <a:off x="7132320" y="1920240"/>
-            <a:ext cx="4480560" cy="4206240"/>
+            <a:off x="7132320" y="1874519"/>
+            <a:ext cx="4480560" cy="4297680"/>
           </a:xfrm>
           <a:prstGeom prst="roundRect">
             <a:avLst/>
@@ -3469,89 +3469,129 @@
           <a:lstStyle/>
           <a:p>
             <a:pPr algn="ctr">
-              <a:defRPr sz="1300" b="1">
+              <a:defRPr sz="1200" b="1">
                 <a:solidFill>
                   <a:srgbClr val="0F2C59"/>
                 </a:solidFill>
               </a:defRPr>
             </a:pPr>
             <a:r>
-              <a:t>CORE MISSION &amp; SCOPE</a:t>
+              <a:t>CORE SYSTEM CAPABILITIES</a:t>
             </a:r>
           </a:p>
           <a:p>
             <a:pPr>
               <a:spcBef>
-                <a:spcPts val="800"/>
+                <a:spcPts val="600"/>
               </a:spcBef>
-              <a:defRPr sz="1050" b="1">
+              <a:defRPr sz="1000" b="1">
+                <a:solidFill>
+                  <a:srgbClr val="0F2C59"/>
+                </a:solidFill>
+              </a:defRPr>
+            </a:pPr>
+            <a:r>
+              <a:t>✓  From Weather to Health: </a:t>
+            </a:r>
+            <a:r>
+              <a:rPr b="0">
                 <a:solidFill>
                   <a:srgbClr val="0F172A"/>
                 </a:solidFill>
-              </a:defRPr>
-            </a:pPr>
-            <a:r>
-              <a:t>✓  From Weather Forecasts → Human Thermal Stress → Localized Action</a:t>
+              </a:rPr>
+              <a:t>Translates raw atmospheric metrics into physiological human thermal stress.</a:t>
             </a:r>
           </a:p>
           <a:p>
             <a:pPr>
               <a:spcBef>
-                <a:spcPts val="800"/>
+                <a:spcPts val="600"/>
               </a:spcBef>
-              <a:defRPr sz="1050" b="1">
+              <a:defRPr sz="1000" b="1">
+                <a:solidFill>
+                  <a:srgbClr val="0F2C59"/>
+                </a:solidFill>
+              </a:defRPr>
+            </a:pPr>
+            <a:r>
+              <a:t>✓  Multi-Metric Engine: </a:t>
+            </a:r>
+            <a:r>
+              <a:rPr b="0">
                 <a:solidFill>
                   <a:srgbClr val="0F172A"/>
                 </a:solidFill>
-              </a:defRPr>
-            </a:pPr>
-            <a:r>
-              <a:t>✓  Universal Thermal Climate Index (UTCI) + ISO 7243 WBGT Core</a:t>
+              </a:rPr>
+              <a:t>Universal Thermal Climate Index (UTCI) + ISO 7243 WBGT + NOAA Heat Index.</a:t>
             </a:r>
           </a:p>
           <a:p>
             <a:pPr>
               <a:spcBef>
-                <a:spcPts val="800"/>
+                <a:spcPts val="600"/>
               </a:spcBef>
-              <a:defRPr sz="1050" b="1">
+              <a:defRPr sz="1000" b="1">
+                <a:solidFill>
+                  <a:srgbClr val="0F2C59"/>
+                </a:solidFill>
+              </a:defRPr>
+            </a:pPr>
+            <a:r>
+              <a:t>✓  Hyper-Local Ward GIS: </a:t>
+            </a:r>
+            <a:r>
+              <a:rPr b="0">
                 <a:solidFill>
                   <a:srgbClr val="0F172A"/>
                 </a:solidFill>
-              </a:defRPr>
-            </a:pPr>
-            <a:r>
-              <a:t>✓  Census 2011 PCA Demographic Vulnerability Mapping (HVI)</a:t>
+              </a:rPr>
+              <a:t>Census 2011 PCA demographic overlay (slums, elderly, gig workers).</a:t>
             </a:r>
           </a:p>
           <a:p>
             <a:pPr>
               <a:spcBef>
-                <a:spcPts val="800"/>
+                <a:spcPts val="600"/>
               </a:spcBef>
-              <a:defRPr sz="1050" b="1">
+              <a:defRPr sz="1000" b="1">
+                <a:solidFill>
+                  <a:srgbClr val="0F2C59"/>
+                </a:solidFill>
+              </a:defRPr>
+            </a:pPr>
+            <a:r>
+              <a:t>✓  Automated Triggers: </a:t>
+            </a:r>
+            <a:r>
+              <a:rPr b="0">
                 <a:solidFill>
                   <a:srgbClr val="0F172A"/>
                 </a:solidFill>
-              </a:defRPr>
-            </a:pPr>
-            <a:r>
-              <a:t>✓  Automated Bilingual NDMA Action Playbooks &amp; Hospital Triggers</a:t>
+              </a:rPr>
+              <a:t>Bilingual NDMA playbooks, hospital cooling surge alerts &amp; NIOSH labor halts.</a:t>
             </a:r>
           </a:p>
           <a:p>
             <a:pPr>
               <a:spcBef>
-                <a:spcPts val="800"/>
+                <a:spcPts val="600"/>
               </a:spcBef>
-              <a:defRPr sz="1050" b="1">
+              <a:defRPr sz="1000" b="1">
+                <a:solidFill>
+                  <a:srgbClr val="0F2C59"/>
+                </a:solidFill>
+              </a:defRPr>
+            </a:pPr>
+            <a:r>
+              <a:t>✓  3–5 Day Lead Time: </a:t>
+            </a:r>
+            <a:r>
+              <a:rPr b="0">
                 <a:solidFill>
                   <a:srgbClr val="0F172A"/>
                 </a:solidFill>
-              </a:defRPr>
-            </a:pPr>
-            <a:r>
-              <a:t>✓  3–5 Day (72h–120h) Pre-Emptive Forecast &amp; Intervention Engine</a:t>
+              </a:rPr>
+              <a:t>Enables 72h–120h pre-emptive municipal water and emergency resource staging.</a:t>
             </a:r>
           </a:p>
         </p:txBody>
@@ -3704,7 +3744,7 @@
         </p:nvSpPr>
         <p:spPr>
           <a:xfrm>
-            <a:off x="548640" y="228600"/>
+            <a:off x="548640" y="182880"/>
             <a:ext cx="2011680" cy="502920"/>
           </a:xfrm>
           <a:prstGeom prst="roundRect">
@@ -3742,6 +3782,7 @@
                 <a:solidFill>
                   <a:srgbClr val="6D28D9"/>
                 </a:solidFill>
+                <a:latin typeface="Arial"/>
               </a:defRPr>
             </a:pPr>
             <a:r>
@@ -3758,8 +3799,8 @@
         </p:nvSpPr>
         <p:spPr>
           <a:xfrm>
-            <a:off x="2743200" y="182880"/>
-            <a:ext cx="6705295" cy="594360"/>
+            <a:off x="2651760" y="164592"/>
+            <a:ext cx="6858000" cy="548640"/>
           </a:xfrm>
           <a:prstGeom prst="rect">
             <a:avLst/>
@@ -3773,7 +3814,7 @@
           <a:lstStyle/>
           <a:p>
             <a:pPr algn="ctr">
-              <a:defRPr sz="1800" b="1">
+              <a:defRPr sz="1700" b="1">
                 <a:solidFill>
                   <a:srgbClr val="0F172A"/>
                 </a:solidFill>
@@ -3794,7 +3835,7 @@
         </p:nvSpPr>
         <p:spPr>
           <a:xfrm>
-            <a:off x="9601200" y="182880"/>
+            <a:off x="9601200" y="137160"/>
             <a:ext cx="2011680" cy="594360"/>
           </a:xfrm>
           <a:prstGeom prst="roundRect">
@@ -3832,6 +3873,7 @@
                 <a:solidFill>
                   <a:srgbClr val="0F2C59"/>
                 </a:solidFill>
+                <a:latin typeface="Arial"/>
               </a:defRPr>
             </a:pPr>
             <a:r>
@@ -3844,6 +3886,7 @@
                 <a:solidFill>
                   <a:srgbClr val="EA580C"/>
                 </a:solidFill>
+                <a:latin typeface="Arial"/>
               </a:defRPr>
             </a:pPr>
             <a:r>
@@ -3854,14 +3897,113 @@
       </p:sp>
       <p:sp>
         <p:nvSpPr>
-          <p:cNvPr id="5" name="TextBox 4"/>
+          <p:cNvPr id="5" name="Rounded Rectangle 4"/>
+          <p:cNvSpPr/>
+          <p:nvPr/>
+        </p:nvSpPr>
+        <p:spPr>
+          <a:xfrm>
+            <a:off x="731520" y="960120"/>
+            <a:ext cx="3429000" cy="4892040"/>
+          </a:xfrm>
+          <a:prstGeom prst="roundRect">
+            <a:avLst/>
+          </a:prstGeom>
+          <a:solidFill>
+            <a:srgbClr val="FFFFFF"/>
+          </a:solidFill>
+          <a:ln w="19050">
+            <a:solidFill>
+              <a:srgbClr val="0284C7"/>
+            </a:solidFill>
+          </a:ln>
+        </p:spPr>
+        <p:style>
+          <a:lnRef idx="1">
+            <a:schemeClr val="accent1"/>
+          </a:lnRef>
+          <a:fillRef idx="3">
+            <a:schemeClr val="accent1"/>
+          </a:fillRef>
+          <a:effectRef idx="2">
+            <a:schemeClr val="accent1"/>
+          </a:effectRef>
+          <a:fontRef idx="minor">
+            <a:schemeClr val="lt1"/>
+          </a:fontRef>
+        </p:style>
+        <p:txBody>
+          <a:bodyPr rtlCol="0" anchor="ctr"/>
+          <a:lstStyle/>
+          <a:p>
+            <a:pPr algn="ctr"/>
+          </a:p>
+        </p:txBody>
+      </p:sp>
+      <p:sp>
+        <p:nvSpPr>
+          <p:cNvPr id="6" name="Rounded Rectangle 5"/>
+          <p:cNvSpPr/>
+          <p:nvPr/>
+        </p:nvSpPr>
+        <p:spPr>
+          <a:xfrm>
+            <a:off x="804672" y="1051560"/>
+            <a:ext cx="3282696" cy="411480"/>
+          </a:xfrm>
+          <a:prstGeom prst="roundRect">
+            <a:avLst/>
+          </a:prstGeom>
+          <a:solidFill>
+            <a:srgbClr val="F0F9FF"/>
+          </a:solidFill>
+          <a:ln w="12700">
+            <a:solidFill>
+              <a:srgbClr val="0284C7"/>
+            </a:solidFill>
+          </a:ln>
+        </p:spPr>
+        <p:style>
+          <a:lnRef idx="1">
+            <a:schemeClr val="accent1"/>
+          </a:lnRef>
+          <a:fillRef idx="3">
+            <a:schemeClr val="accent1"/>
+          </a:fillRef>
+          <a:effectRef idx="2">
+            <a:schemeClr val="accent1"/>
+          </a:effectRef>
+          <a:fontRef idx="minor">
+            <a:schemeClr val="lt1"/>
+          </a:fontRef>
+        </p:style>
+        <p:txBody>
+          <a:bodyPr rtlCol="0" anchor="ctr"/>
+          <a:lstStyle/>
+          <a:p>
+            <a:pPr algn="ctr">
+              <a:defRPr sz="1050" b="1">
+                <a:solidFill>
+                  <a:srgbClr val="0F2C59"/>
+                </a:solidFill>
+              </a:defRPr>
+            </a:pPr>
+            <a:r>
+              <a:t>1. Proposed Solution Architecture</a:t>
+            </a:r>
+          </a:p>
+        </p:txBody>
+      </p:sp>
+      <p:sp>
+        <p:nvSpPr>
+          <p:cNvPr id="7" name="TextBox 6"/>
           <p:cNvSpPr txBox="1"/>
           <p:nvPr/>
         </p:nvSpPr>
         <p:spPr>
           <a:xfrm>
-            <a:off x="731520" y="1051560"/>
-            <a:ext cx="10728655" cy="5212080"/>
+            <a:off x="868680" y="1554480"/>
+            <a:ext cx="3154680" cy="4206240"/>
           </a:xfrm>
           <a:prstGeom prst="rect">
             <a:avLst/>
@@ -3873,6 +4015,26 @@
             <a:spAutoFit/>
           </a:bodyPr>
           <a:lstStyle/>
+          <a:p>
+            <a:pPr>
+              <a:defRPr sz="950" b="1">
+                <a:solidFill>
+                  <a:srgbClr val="0F2C59"/>
+                </a:solidFill>
+              </a:defRPr>
+            </a:pPr>
+            <a:r>
+              <a:t>❖  Dual-Branch Ingestion: </a:t>
+            </a:r>
+            <a:r>
+              <a:rPr b="0">
+                <a:solidFill>
+                  <a:srgbClr val="0F172A"/>
+                </a:solidFill>
+              </a:rPr>
+              <a:t>Simultaneously processes 5-Day NWP forecasts (temperature, humidity, wind, radiation) and Census demographic vulnerability layers.</a:t>
+            </a:r>
+          </a:p>
           <a:p>
             <a:pPr>
               <a:spcBef>
@@ -3885,7 +4047,7 @@
               </a:defRPr>
             </a:pPr>
             <a:r>
-              <a:t>❖  Dual-Branch Biometeorological Model: </a:t>
+              <a:t>❖  UTCI Physiological Engine: </a:t>
             </a:r>
             <a:r>
               <a:rPr b="0">
@@ -3893,7 +4055,7 @@
                   <a:srgbClr val="0F172A"/>
                 </a:solidFill>
               </a:rPr>
-              <a:t>System utilizes two parallel analytical pipelines: one for Atmospheric Dynamics (NWP temperature, humidity, wind velocity, solar radiation) and one for Demographic Vulnerability (Census 2011 PCA elderly density, slum households, outdoor labor concentration, canopy deficit). Mathematical algorithms extract physiological heat stress indicators while GIS spatial models calculate ward-level vulnerability.</a:t>
+              <a:t>6th-order polynomial based on Fiala 187-node human body model. Accurately calculates real sweat evaporation efficiency.</a:t>
             </a:r>
           </a:p>
           <a:p>
@@ -3908,7 +4070,7 @@
               </a:defRPr>
             </a:pPr>
             <a:r>
-              <a:t>❖  Universal Thermal Stress Engine: </a:t>
+              <a:t>❖  ISO 7243 WBGT: </a:t>
             </a:r>
             <a:r>
               <a:rPr b="0">
@@ -3916,7 +4078,7 @@
                   <a:srgbClr val="0F172A"/>
                 </a:solidFill>
               </a:rPr>
-              <a:t>Thermal stress is computed using the Universal Thermal Climate Index (UTCI, 6th-order polynomial based on the Fiala 187-node human thermoregulation model) and ISO 7243 Outdoor WBGT (Stull wet-bulb + Liljegren radiation model). Accurately models human sweat evaporation breakdown where 40°C with high humidity turns lethal.</a:t>
+              <a:t>Natural wet bulb (Stull) and globe temperature (Liljegren) for occupational and outdoor worker heat stress.</a:t>
             </a:r>
           </a:p>
           <a:p>
@@ -3931,7 +4093,7 @@
               </a:defRPr>
             </a:pPr>
             <a:r>
-              <a:t>❖  Multi-Day Heat Persistence &amp; Nighttime Penalty: </a:t>
+              <a:t>❖  Multi-Day Persistence Penalty: </a:t>
             </a:r>
             <a:r>
               <a:rPr b="0">
@@ -3939,7 +4101,149 @@
                   <a:srgbClr val="0F172A"/>
                 </a:solidFill>
               </a:rPr>
-              <a:t>Calculates cumulative thermal accumulation via exponential persistence duration multiplier (Dmult). Accounts for uncooled nocturnal minimum temperatures (Tmin &gt; 28°C) that prevent physiological recovery and double cardiovascular stress.</a:t>
+              <a:t>Applies exponential multiplier (Dmult) for prolonged heatwaves and uncooled night minimums (Tmin &gt; 28°C).</a:t>
+            </a:r>
+          </a:p>
+        </p:txBody>
+      </p:sp>
+      <p:sp>
+        <p:nvSpPr>
+          <p:cNvPr id="8" name="Rounded Rectangle 7"/>
+          <p:cNvSpPr/>
+          <p:nvPr/>
+        </p:nvSpPr>
+        <p:spPr>
+          <a:xfrm>
+            <a:off x="4379976" y="960120"/>
+            <a:ext cx="3429000" cy="4892040"/>
+          </a:xfrm>
+          <a:prstGeom prst="roundRect">
+            <a:avLst/>
+          </a:prstGeom>
+          <a:solidFill>
+            <a:srgbClr val="FFFFFF"/>
+          </a:solidFill>
+          <a:ln w="19050">
+            <a:solidFill>
+              <a:srgbClr val="16A34A"/>
+            </a:solidFill>
+          </a:ln>
+        </p:spPr>
+        <p:style>
+          <a:lnRef idx="1">
+            <a:schemeClr val="accent1"/>
+          </a:lnRef>
+          <a:fillRef idx="3">
+            <a:schemeClr val="accent1"/>
+          </a:fillRef>
+          <a:effectRef idx="2">
+            <a:schemeClr val="accent1"/>
+          </a:effectRef>
+          <a:fontRef idx="minor">
+            <a:schemeClr val="lt1"/>
+          </a:fontRef>
+        </p:style>
+        <p:txBody>
+          <a:bodyPr rtlCol="0" anchor="ctr"/>
+          <a:lstStyle/>
+          <a:p>
+            <a:pPr algn="ctr"/>
+          </a:p>
+        </p:txBody>
+      </p:sp>
+      <p:sp>
+        <p:nvSpPr>
+          <p:cNvPr id="9" name="Rounded Rectangle 8"/>
+          <p:cNvSpPr/>
+          <p:nvPr/>
+        </p:nvSpPr>
+        <p:spPr>
+          <a:xfrm>
+            <a:off x="4453128" y="1051560"/>
+            <a:ext cx="3282696" cy="411480"/>
+          </a:xfrm>
+          <a:prstGeom prst="roundRect">
+            <a:avLst/>
+          </a:prstGeom>
+          <a:solidFill>
+            <a:srgbClr val="F0FDF4"/>
+          </a:solidFill>
+          <a:ln w="12700">
+            <a:solidFill>
+              <a:srgbClr val="16A34A"/>
+            </a:solidFill>
+          </a:ln>
+        </p:spPr>
+        <p:style>
+          <a:lnRef idx="1">
+            <a:schemeClr val="accent1"/>
+          </a:lnRef>
+          <a:fillRef idx="3">
+            <a:schemeClr val="accent1"/>
+          </a:fillRef>
+          <a:effectRef idx="2">
+            <a:schemeClr val="accent1"/>
+          </a:effectRef>
+          <a:fontRef idx="minor">
+            <a:schemeClr val="lt1"/>
+          </a:fontRef>
+        </p:style>
+        <p:txBody>
+          <a:bodyPr rtlCol="0" anchor="ctr"/>
+          <a:lstStyle/>
+          <a:p>
+            <a:pPr algn="ctr">
+              <a:defRPr sz="1050" b="1">
+                <a:solidFill>
+                  <a:srgbClr val="0F2C59"/>
+                </a:solidFill>
+              </a:defRPr>
+            </a:pPr>
+            <a:r>
+              <a:t>2. How It Addresses The Problem?</a:t>
+            </a:r>
+          </a:p>
+        </p:txBody>
+      </p:sp>
+      <p:sp>
+        <p:nvSpPr>
+          <p:cNvPr id="10" name="TextBox 9"/>
+          <p:cNvSpPr txBox="1"/>
+          <p:nvPr/>
+        </p:nvSpPr>
+        <p:spPr>
+          <a:xfrm>
+            <a:off x="4517136" y="1554480"/>
+            <a:ext cx="3154680" cy="4206240"/>
+          </a:xfrm>
+          <a:prstGeom prst="rect">
+            <a:avLst/>
+          </a:prstGeom>
+          <a:noFill/>
+        </p:spPr>
+        <p:txBody>
+          <a:bodyPr wrap="square" lIns="0" tIns="0" rIns="0" bIns="0">
+            <a:spAutoFit/>
+          </a:bodyPr>
+          <a:lstStyle/>
+          <a:p>
+            <a:pPr>
+              <a:defRPr sz="950" b="1">
+                <a:solidFill>
+                  <a:srgbClr val="0F2C59"/>
+                </a:solidFill>
+              </a:defRPr>
+            </a:pPr>
+            <a:r>
+              <a:t>❖  Weather vs Physiological Impact: </a:t>
+            </a:r>
+            <a:r>
+              <a:rPr b="0">
+                <a:solidFill>
+                  <a:srgbClr val="0F172A"/>
+                </a:solidFill>
+              </a:rPr>
+              <a:t>Overcomes the critical limitation of dry-bulb warnings where 40°C with high humidity turns lethal.</a:t>
             </a:r>
           </a:p>
           <a:p>
@@ -3954,7 +4258,7 @@
               </a:defRPr>
             </a:pPr>
             <a:r>
-              <a:t>❖  AI Health Risk Model &amp; Multi-Factor Loss Optimization: </a:t>
+              <a:t>❖  Hyper-Local Ward Stratification: </a:t>
             </a:r>
             <a:r>
               <a:rPr b="0">
@@ -3962,76 +4266,7 @@
                   <a:srgbClr val="0F172A"/>
                 </a:solidFill>
               </a:rPr>
-              <a:t>The model synthesizes atmospheric hazard with local socio-economic vulnerability into a normalized 0–100 Human Heat-Health Risk Score:</a:t>
-            </a:r>
-          </a:p>
-          <a:p>
-            <a:pPr>
-              <a:spcBef>
-                <a:spcPts val="200"/>
-              </a:spcBef>
-              <a:defRPr sz="900" b="1">
-                <a:solidFill>
-                  <a:srgbClr val="EA580C"/>
-                </a:solidFill>
-              </a:defRPr>
-            </a:pPr>
-            <a:r>
-              <a:t>     ■  Relative Health Risk Loss: </a:t>
-            </a:r>
-            <a:r>
-              <a:rPr b="0">
-                <a:solidFill>
-                  <a:srgbClr val="0F172A"/>
-                </a:solidFill>
-              </a:rPr>
-              <a:t>Calibrated against empirical epidemiological benchmarks (Azhar et al. 2014 &amp; Mazdiyasni et al. 2017).</a:t>
-            </a:r>
-          </a:p>
-          <a:p>
-            <a:pPr>
-              <a:spcBef>
-                <a:spcPts val="200"/>
-              </a:spcBef>
-              <a:defRPr sz="900" b="1">
-                <a:solidFill>
-                  <a:srgbClr val="EA580C"/>
-                </a:solidFill>
-              </a:defRPr>
-            </a:pPr>
-            <a:r>
-              <a:t>     ■  Monotonicity Constraint: </a:t>
-            </a:r>
-            <a:r>
-              <a:rPr b="0">
-                <a:solidFill>
-                  <a:srgbClr val="0F172A"/>
-                </a:solidFill>
-              </a:rPr>
-              <a:t>Guarantees mathematically that higher humidity/temperature strictly escalates risk scores.</a:t>
-            </a:r>
-          </a:p>
-          <a:p>
-            <a:pPr>
-              <a:spcBef>
-                <a:spcPts val="200"/>
-              </a:spcBef>
-              <a:defRPr sz="900" b="1">
-                <a:solidFill>
-                  <a:srgbClr val="EA580C"/>
-                </a:solidFill>
-              </a:defRPr>
-            </a:pPr>
-            <a:r>
-              <a:t>     ■  Ward Spatial Allocation Loss: </a:t>
-            </a:r>
-            <a:r>
-              <a:rPr b="0">
-                <a:solidFill>
-                  <a:srgbClr val="0F172A"/>
-                </a:solidFill>
-              </a:rPr>
-              <a:t>Ensures hyper-local resource allocation is prioritized toward high-vulnerability informal settlements.</a:t>
+              <a:t>Differentiates shaded affluent residential zones from densely built informal settlements with tin roofs.</a:t>
             </a:r>
           </a:p>
           <a:p>
@@ -4046,7 +4281,7 @@
               </a:defRPr>
             </a:pPr>
             <a:r>
-              <a:t>❖  Automated Action Engine &amp; Multi-Sector Dispatch: </a:t>
+              <a:t>❖  Epidemiological Grounding: </a:t>
             </a:r>
             <a:r>
               <a:rPr b="0">
@@ -4054,7 +4289,7 @@
                   <a:srgbClr val="0F172A"/>
                 </a:solidFill>
               </a:rPr>
-              <a:t>Converts risk calculations directly into sector-specific automated triggers: Municipal water tanker routing, emergency hospital cooling ward surge beds, gig-worker NIOSH work-rest cycles (labor halts 11 AM–4 PM), and bilingual NDMA SMS/WhatsApp broadcasts.</a:t>
+              <a:t>Risk scoring calibrated against peer-reviewed Indian empirical studies (Azhar et al. 2014 &amp; Mazdiyasni et al. 2017).</a:t>
             </a:r>
           </a:p>
           <a:p>
@@ -4069,7 +4304,7 @@
               </a:defRPr>
             </a:pPr>
             <a:r>
-              <a:t>❖  Final Output &amp; Evaluation Metrics: </a:t>
+              <a:t>❖  Automated Impact-to-Action: </a:t>
             </a:r>
             <a:r>
               <a:rPr b="0">
@@ -4077,14 +4312,279 @@
                   <a:srgbClr val="0F172A"/>
                 </a:solidFill>
               </a:rPr>
-              <a:t>Delivers real-time interactive Leaflet GIS choropleths, 25 high-speed REST APIs, and automated multi-channel alert dispatch with validated sub-second execution.</a:t>
-            </a:r>
-          </a:p>
-        </p:txBody>
-      </p:sp>
-      <p:sp>
-        <p:nvSpPr>
-          <p:cNvPr id="6" name="Rectangle 5"/>
+              <a:t>Translates raw risk directly into automated NDMA advisories, hospital beds, and labor work-rest cycles.</a:t>
+            </a:r>
+          </a:p>
+        </p:txBody>
+      </p:sp>
+      <p:sp>
+        <p:nvSpPr>
+          <p:cNvPr id="11" name="Rounded Rectangle 10"/>
+          <p:cNvSpPr/>
+          <p:nvPr/>
+        </p:nvSpPr>
+        <p:spPr>
+          <a:xfrm>
+            <a:off x="8028432" y="960120"/>
+            <a:ext cx="3429000" cy="4892040"/>
+          </a:xfrm>
+          <a:prstGeom prst="roundRect">
+            <a:avLst/>
+          </a:prstGeom>
+          <a:solidFill>
+            <a:srgbClr val="FFFFFF"/>
+          </a:solidFill>
+          <a:ln w="19050">
+            <a:solidFill>
+              <a:srgbClr val="EA580C"/>
+            </a:solidFill>
+          </a:ln>
+        </p:spPr>
+        <p:style>
+          <a:lnRef idx="1">
+            <a:schemeClr val="accent1"/>
+          </a:lnRef>
+          <a:fillRef idx="3">
+            <a:schemeClr val="accent1"/>
+          </a:fillRef>
+          <a:effectRef idx="2">
+            <a:schemeClr val="accent1"/>
+          </a:effectRef>
+          <a:fontRef idx="minor">
+            <a:schemeClr val="lt1"/>
+          </a:fontRef>
+        </p:style>
+        <p:txBody>
+          <a:bodyPr rtlCol="0" anchor="ctr"/>
+          <a:lstStyle/>
+          <a:p>
+            <a:pPr algn="ctr"/>
+          </a:p>
+        </p:txBody>
+      </p:sp>
+      <p:sp>
+        <p:nvSpPr>
+          <p:cNvPr id="12" name="Rounded Rectangle 11"/>
+          <p:cNvSpPr/>
+          <p:nvPr/>
+        </p:nvSpPr>
+        <p:spPr>
+          <a:xfrm>
+            <a:off x="8101584" y="1051560"/>
+            <a:ext cx="3282696" cy="411480"/>
+          </a:xfrm>
+          <a:prstGeom prst="roundRect">
+            <a:avLst/>
+          </a:prstGeom>
+          <a:solidFill>
+            <a:srgbClr val="FEF3C7"/>
+          </a:solidFill>
+          <a:ln w="12700">
+            <a:solidFill>
+              <a:srgbClr val="EA580C"/>
+            </a:solidFill>
+          </a:ln>
+        </p:spPr>
+        <p:style>
+          <a:lnRef idx="1">
+            <a:schemeClr val="accent1"/>
+          </a:lnRef>
+          <a:fillRef idx="3">
+            <a:schemeClr val="accent1"/>
+          </a:fillRef>
+          <a:effectRef idx="2">
+            <a:schemeClr val="accent1"/>
+          </a:effectRef>
+          <a:fontRef idx="minor">
+            <a:schemeClr val="lt1"/>
+          </a:fontRef>
+        </p:style>
+        <p:txBody>
+          <a:bodyPr rtlCol="0" anchor="ctr"/>
+          <a:lstStyle/>
+          <a:p>
+            <a:pPr algn="ctr">
+              <a:defRPr sz="1050" b="1">
+                <a:solidFill>
+                  <a:srgbClr val="0F2C59"/>
+                </a:solidFill>
+              </a:defRPr>
+            </a:pPr>
+            <a:r>
+              <a:t>3. Key Differentiators &amp; Impact</a:t>
+            </a:r>
+          </a:p>
+        </p:txBody>
+      </p:sp>
+      <p:sp>
+        <p:nvSpPr>
+          <p:cNvPr id="13" name="TextBox 12"/>
+          <p:cNvSpPr txBox="1"/>
+          <p:nvPr/>
+        </p:nvSpPr>
+        <p:spPr>
+          <a:xfrm>
+            <a:off x="8165592" y="1554480"/>
+            <a:ext cx="3154680" cy="4206240"/>
+          </a:xfrm>
+          <a:prstGeom prst="rect">
+            <a:avLst/>
+          </a:prstGeom>
+          <a:noFill/>
+        </p:spPr>
+        <p:txBody>
+          <a:bodyPr wrap="square" lIns="0" tIns="0" rIns="0" bIns="0">
+            <a:spAutoFit/>
+          </a:bodyPr>
+          <a:lstStyle/>
+          <a:p>
+            <a:pPr>
+              <a:defRPr sz="950" b="1">
+                <a:solidFill>
+                  <a:srgbClr val="0F2C59"/>
+                </a:solidFill>
+              </a:defRPr>
+            </a:pPr>
+            <a:r>
+              <a:t>❖  3–5 Day Pre-Emptive Window: </a:t>
+            </a:r>
+            <a:r>
+              <a:rPr b="0">
+                <a:solidFill>
+                  <a:srgbClr val="0F172A"/>
+                </a:solidFill>
+              </a:rPr>
+              <a:t>Provides 72h–120h lead time for municipal water tanker routing and cooling shelter deployment.</a:t>
+            </a:r>
+          </a:p>
+          <a:p>
+            <a:pPr>
+              <a:spcBef>
+                <a:spcPts val="400"/>
+              </a:spcBef>
+              <a:defRPr sz="950" b="1">
+                <a:solidFill>
+                  <a:srgbClr val="0F2C59"/>
+                </a:solidFill>
+              </a:defRPr>
+            </a:pPr>
+            <a:r>
+              <a:t>❖  Sector-Specific Automation: </a:t>
+            </a:r>
+            <a:r>
+              <a:rPr b="0">
+                <a:solidFill>
+                  <a:srgbClr val="0F172A"/>
+                </a:solidFill>
+              </a:rPr>
+              <a:t>Delivers tailored feeds for gig delivery platforms (Zomato/Swiggy), construction, and DISCOMs.</a:t>
+            </a:r>
+          </a:p>
+          <a:p>
+            <a:pPr>
+              <a:spcBef>
+                <a:spcPts val="400"/>
+              </a:spcBef>
+              <a:defRPr sz="950" b="1">
+                <a:solidFill>
+                  <a:srgbClr val="0F2C59"/>
+                </a:solidFill>
+              </a:defRPr>
+            </a:pPr>
+            <a:r>
+              <a:t>❖  Bilingual Vernacular Alerts: </a:t>
+            </a:r>
+            <a:r>
+              <a:rPr b="0">
+                <a:solidFill>
+                  <a:srgbClr val="0F172A"/>
+                </a:solidFill>
+              </a:rPr>
+              <a:t>Automated Hindi &amp; English public alerts sent via WhatsApp/Telegram to avoid technical jargon.</a:t>
+            </a:r>
+          </a:p>
+          <a:p>
+            <a:pPr>
+              <a:spcBef>
+                <a:spcPts val="400"/>
+              </a:spcBef>
+              <a:defRPr sz="950" b="1">
+                <a:solidFill>
+                  <a:srgbClr val="0F2C59"/>
+                </a:solidFill>
+              </a:defRPr>
+            </a:pPr>
+            <a:r>
+              <a:t>❖  High-Performance Open Stack: </a:t>
+            </a:r>
+            <a:r>
+              <a:rPr b="0">
+                <a:solidFill>
+                  <a:srgbClr val="0F172A"/>
+                </a:solidFill>
+              </a:rPr>
+              <a:t>25 production REST API endpoints with sub-second response times and zero licensing fees.</a:t>
+            </a:r>
+          </a:p>
+        </p:txBody>
+      </p:sp>
+      <p:sp>
+        <p:nvSpPr>
+          <p:cNvPr id="14" name="Rounded Rectangle 13"/>
+          <p:cNvSpPr/>
+          <p:nvPr/>
+        </p:nvSpPr>
+        <p:spPr>
+          <a:xfrm>
+            <a:off x="731520" y="5897880"/>
+            <a:ext cx="10728655" cy="457200"/>
+          </a:xfrm>
+          <a:prstGeom prst="roundRect">
+            <a:avLst/>
+          </a:prstGeom>
+          <a:solidFill>
+            <a:srgbClr val="F0F9FF"/>
+          </a:solidFill>
+          <a:ln w="15240">
+            <a:solidFill>
+              <a:srgbClr val="0284C7"/>
+            </a:solidFill>
+          </a:ln>
+        </p:spPr>
+        <p:style>
+          <a:lnRef idx="1">
+            <a:schemeClr val="accent1"/>
+          </a:lnRef>
+          <a:fillRef idx="3">
+            <a:schemeClr val="accent1"/>
+          </a:fillRef>
+          <a:effectRef idx="2">
+            <a:schemeClr val="accent1"/>
+          </a:effectRef>
+          <a:fontRef idx="minor">
+            <a:schemeClr val="lt1"/>
+          </a:fontRef>
+        </p:style>
+        <p:txBody>
+          <a:bodyPr rtlCol="0" anchor="ctr"/>
+          <a:lstStyle/>
+          <a:p>
+            <a:pPr algn="ctr">
+              <a:defRPr sz="1000" b="1">
+                <a:solidFill>
+                  <a:srgbClr val="0F2C59"/>
+                </a:solidFill>
+              </a:defRPr>
+            </a:pPr>
+            <a:r>
+              <a:t>KEY USP: Not another static heat map — an automated, end-to-end impact-to-action intelligence OS for heatwave resilience.</a:t>
+            </a:r>
+          </a:p>
+        </p:txBody>
+      </p:sp>
+      <p:sp>
+        <p:nvSpPr>
+          <p:cNvPr id="15" name="Rectangle 14"/>
           <p:cNvSpPr/>
           <p:nvPr/>
         </p:nvSpPr>
@@ -4127,7 +4627,7 @@
       </p:sp>
       <p:sp>
         <p:nvSpPr>
-          <p:cNvPr id="7" name="TextBox 6"/>
+          <p:cNvPr id="16" name="TextBox 15"/>
           <p:cNvSpPr txBox="1"/>
           <p:nvPr/>
         </p:nvSpPr>
@@ -4163,7 +4663,7 @@
       </p:sp>
       <p:sp>
         <p:nvSpPr>
-          <p:cNvPr id="8" name="TextBox 7"/>
+          <p:cNvPr id="17" name="TextBox 16"/>
           <p:cNvSpPr txBox="1"/>
           <p:nvPr/>
         </p:nvSpPr>
@@ -4230,7 +4730,7 @@
         </p:nvSpPr>
         <p:spPr>
           <a:xfrm>
-            <a:off x="548640" y="228600"/>
+            <a:off x="548640" y="182880"/>
             <a:ext cx="2011680" cy="502920"/>
           </a:xfrm>
           <a:prstGeom prst="roundRect">
@@ -4268,6 +4768,7 @@
                 <a:solidFill>
                   <a:srgbClr val="6D28D9"/>
                 </a:solidFill>
+                <a:latin typeface="Arial"/>
               </a:defRPr>
             </a:pPr>
             <a:r>
@@ -4284,8 +4785,8 @@
         </p:nvSpPr>
         <p:spPr>
           <a:xfrm>
-            <a:off x="2743200" y="182880"/>
-            <a:ext cx="6705295" cy="594360"/>
+            <a:off x="2651760" y="164592"/>
+            <a:ext cx="6858000" cy="548640"/>
           </a:xfrm>
           <a:prstGeom prst="rect">
             <a:avLst/>
@@ -4299,7 +4800,7 @@
           <a:lstStyle/>
           <a:p>
             <a:pPr algn="ctr">
-              <a:defRPr sz="1800" b="1">
+              <a:defRPr sz="1700" b="1">
                 <a:solidFill>
                   <a:srgbClr val="0F172A"/>
                 </a:solidFill>
@@ -4320,7 +4821,7 @@
         </p:nvSpPr>
         <p:spPr>
           <a:xfrm>
-            <a:off x="9601200" y="182880"/>
+            <a:off x="9601200" y="137160"/>
             <a:ext cx="2011680" cy="594360"/>
           </a:xfrm>
           <a:prstGeom prst="roundRect">
@@ -4358,6 +4859,7 @@
                 <a:solidFill>
                   <a:srgbClr val="0F2C59"/>
                 </a:solidFill>
+                <a:latin typeface="Arial"/>
               </a:defRPr>
             </a:pPr>
             <a:r>
@@ -4370,6 +4872,7 @@
                 <a:solidFill>
                   <a:srgbClr val="EA580C"/>
                 </a:solidFill>
+                <a:latin typeface="Arial"/>
               </a:defRPr>
             </a:pPr>
             <a:r>
@@ -4386,8 +4889,8 @@
         </p:nvSpPr>
         <p:spPr>
           <a:xfrm>
-            <a:off x="2743200" y="960120"/>
-            <a:ext cx="6705295" cy="320040"/>
+            <a:off x="2560320" y="868680"/>
+            <a:ext cx="7071055" cy="320040"/>
           </a:xfrm>
           <a:prstGeom prst="rect">
             <a:avLst/>
@@ -4427,7 +4930,7 @@
               </a:defRPr>
             </a:pPr>
             <a:r>
-              <a:t>ThermoShield Biometeorological &amp; Action Model: Implementation Architecture</a:t>
+              <a:t>End-to-End Biometeorological &amp; Action Pipeline : Implementation Process Flow</a:t>
             </a:r>
           </a:p>
         </p:txBody>
@@ -4440,8 +4943,635 @@
         </p:nvSpPr>
         <p:spPr>
           <a:xfrm>
-            <a:off x="731520" y="1417320"/>
-            <a:ext cx="2011680" cy="3474720"/>
+            <a:off x="731520" y="1280160"/>
+            <a:ext cx="2542032" cy="3383280"/>
+          </a:xfrm>
+          <a:prstGeom prst="roundRect">
+            <a:avLst/>
+          </a:prstGeom>
+          <a:solidFill>
+            <a:srgbClr val="FFFFFF"/>
+          </a:solidFill>
+          <a:ln w="19050">
+            <a:solidFill>
+              <a:srgbClr val="EA580C"/>
+            </a:solidFill>
+          </a:ln>
+        </p:spPr>
+        <p:style>
+          <a:lnRef idx="1">
+            <a:schemeClr val="accent1"/>
+          </a:lnRef>
+          <a:fillRef idx="3">
+            <a:schemeClr val="accent1"/>
+          </a:fillRef>
+          <a:effectRef idx="2">
+            <a:schemeClr val="accent1"/>
+          </a:effectRef>
+          <a:fontRef idx="minor">
+            <a:schemeClr val="lt1"/>
+          </a:fontRef>
+        </p:style>
+        <p:txBody>
+          <a:bodyPr rtlCol="0" anchor="ctr"/>
+          <a:lstStyle/>
+          <a:p>
+            <a:pPr algn="ctr"/>
+          </a:p>
+        </p:txBody>
+      </p:sp>
+      <p:sp>
+        <p:nvSpPr>
+          <p:cNvPr id="7" name="Rounded Rectangle 6"/>
+          <p:cNvSpPr/>
+          <p:nvPr/>
+        </p:nvSpPr>
+        <p:spPr>
+          <a:xfrm>
+            <a:off x="804672" y="1353312"/>
+            <a:ext cx="2395728" cy="365760"/>
+          </a:xfrm>
+          <a:prstGeom prst="roundRect">
+            <a:avLst/>
+          </a:prstGeom>
+          <a:solidFill>
+            <a:srgbClr val="FEF3C7"/>
+          </a:solidFill>
+          <a:ln w="12700">
+            <a:solidFill>
+              <a:srgbClr val="EA580C"/>
+            </a:solidFill>
+          </a:ln>
+        </p:spPr>
+        <p:style>
+          <a:lnRef idx="1">
+            <a:schemeClr val="accent1"/>
+          </a:lnRef>
+          <a:fillRef idx="3">
+            <a:schemeClr val="accent1"/>
+          </a:fillRef>
+          <a:effectRef idx="2">
+            <a:schemeClr val="accent1"/>
+          </a:effectRef>
+          <a:fontRef idx="minor">
+            <a:schemeClr val="lt1"/>
+          </a:fontRef>
+        </p:style>
+        <p:txBody>
+          <a:bodyPr rtlCol="0" anchor="ctr"/>
+          <a:lstStyle/>
+          <a:p>
+            <a:pPr algn="ctr">
+              <a:defRPr sz="1000" b="1">
+                <a:solidFill>
+                  <a:srgbClr val="EA580C"/>
+                </a:solidFill>
+              </a:defRPr>
+            </a:pPr>
+            <a:r>
+              <a:t>1. INGESTION</a:t>
+            </a:r>
+          </a:p>
+        </p:txBody>
+      </p:sp>
+      <p:sp>
+        <p:nvSpPr>
+          <p:cNvPr id="8" name="TextBox 7"/>
+          <p:cNvSpPr txBox="1"/>
+          <p:nvPr/>
+        </p:nvSpPr>
+        <p:spPr>
+          <a:xfrm>
+            <a:off x="841248" y="1783080"/>
+            <a:ext cx="2322576" cy="2743200"/>
+          </a:xfrm>
+          <a:prstGeom prst="rect">
+            <a:avLst/>
+          </a:prstGeom>
+          <a:noFill/>
+        </p:spPr>
+        <p:txBody>
+          <a:bodyPr wrap="square" lIns="0" tIns="0" rIns="0" bIns="0">
+            <a:spAutoFit/>
+          </a:bodyPr>
+          <a:lstStyle/>
+          <a:p>
+            <a:pPr>
+              <a:defRPr sz="900" b="1">
+                <a:solidFill>
+                  <a:srgbClr val="0F2C59"/>
+                </a:solidFill>
+              </a:defRPr>
+            </a:pPr>
+            <a:r>
+              <a:t>Open-Meteo 0.1° NWP 5-Day Forecasts</a:t>
+            </a:r>
+          </a:p>
+          <a:p>
+            <a:pPr>
+              <a:spcBef>
+                <a:spcPts val="300"/>
+              </a:spcBef>
+              <a:defRPr sz="900">
+                <a:solidFill>
+                  <a:srgbClr val="0F172A"/>
+                </a:solidFill>
+              </a:defRPr>
+            </a:pPr>
+            <a:r>
+              <a:t>• Hourly T, RH, Wind, Radiation</a:t>
+            </a:r>
+          </a:p>
+          <a:p>
+            <a:pPr>
+              <a:spcBef>
+                <a:spcPts val="300"/>
+              </a:spcBef>
+              <a:defRPr sz="900">
+                <a:solidFill>
+                  <a:srgbClr val="0F172A"/>
+                </a:solidFill>
+              </a:defRPr>
+            </a:pPr>
+            <a:r>
+              <a:t>• NASA POWER 40-Yr Normal</a:t>
+            </a:r>
+          </a:p>
+          <a:p>
+            <a:pPr>
+              <a:spcBef>
+                <a:spcPts val="300"/>
+              </a:spcBef>
+              <a:defRPr sz="900">
+                <a:solidFill>
+                  <a:srgbClr val="0F172A"/>
+                </a:solidFill>
+              </a:defRPr>
+            </a:pPr>
+            <a:r>
+              <a:t>• Census 2011 Ward PCA Data</a:t>
+            </a:r>
+          </a:p>
+          <a:p>
+            <a:pPr>
+              <a:spcBef>
+                <a:spcPts val="300"/>
+              </a:spcBef>
+              <a:defRPr sz="900">
+                <a:solidFill>
+                  <a:srgbClr val="0F172A"/>
+                </a:solidFill>
+              </a:defRPr>
+            </a:pPr>
+            <a:r>
+              <a:t>• Satellite LST / NDVI Surface Grid</a:t>
+            </a:r>
+          </a:p>
+        </p:txBody>
+      </p:sp>
+      <p:sp>
+        <p:nvSpPr>
+          <p:cNvPr id="9" name="Rounded Rectangle 8"/>
+          <p:cNvSpPr/>
+          <p:nvPr/>
+        </p:nvSpPr>
+        <p:spPr>
+          <a:xfrm>
+            <a:off x="3456432" y="1280160"/>
+            <a:ext cx="2542032" cy="3383280"/>
+          </a:xfrm>
+          <a:prstGeom prst="roundRect">
+            <a:avLst/>
+          </a:prstGeom>
+          <a:solidFill>
+            <a:srgbClr val="FFFFFF"/>
+          </a:solidFill>
+          <a:ln w="19050">
+            <a:solidFill>
+              <a:srgbClr val="16A34A"/>
+            </a:solidFill>
+          </a:ln>
+        </p:spPr>
+        <p:style>
+          <a:lnRef idx="1">
+            <a:schemeClr val="accent1"/>
+          </a:lnRef>
+          <a:fillRef idx="3">
+            <a:schemeClr val="accent1"/>
+          </a:fillRef>
+          <a:effectRef idx="2">
+            <a:schemeClr val="accent1"/>
+          </a:effectRef>
+          <a:fontRef idx="minor">
+            <a:schemeClr val="lt1"/>
+          </a:fontRef>
+        </p:style>
+        <p:txBody>
+          <a:bodyPr rtlCol="0" anchor="ctr"/>
+          <a:lstStyle/>
+          <a:p>
+            <a:pPr algn="ctr"/>
+          </a:p>
+        </p:txBody>
+      </p:sp>
+      <p:sp>
+        <p:nvSpPr>
+          <p:cNvPr id="10" name="Rounded Rectangle 9"/>
+          <p:cNvSpPr/>
+          <p:nvPr/>
+        </p:nvSpPr>
+        <p:spPr>
+          <a:xfrm>
+            <a:off x="3529584" y="1353312"/>
+            <a:ext cx="2395728" cy="365760"/>
+          </a:xfrm>
+          <a:prstGeom prst="roundRect">
+            <a:avLst/>
+          </a:prstGeom>
+          <a:solidFill>
+            <a:srgbClr val="F0FDF4"/>
+          </a:solidFill>
+          <a:ln w="12700">
+            <a:solidFill>
+              <a:srgbClr val="16A34A"/>
+            </a:solidFill>
+          </a:ln>
+        </p:spPr>
+        <p:style>
+          <a:lnRef idx="1">
+            <a:schemeClr val="accent1"/>
+          </a:lnRef>
+          <a:fillRef idx="3">
+            <a:schemeClr val="accent1"/>
+          </a:fillRef>
+          <a:effectRef idx="2">
+            <a:schemeClr val="accent1"/>
+          </a:effectRef>
+          <a:fontRef idx="minor">
+            <a:schemeClr val="lt1"/>
+          </a:fontRef>
+        </p:style>
+        <p:txBody>
+          <a:bodyPr rtlCol="0" anchor="ctr"/>
+          <a:lstStyle/>
+          <a:p>
+            <a:pPr algn="ctr">
+              <a:defRPr sz="1000" b="1">
+                <a:solidFill>
+                  <a:srgbClr val="16A34A"/>
+                </a:solidFill>
+              </a:defRPr>
+            </a:pPr>
+            <a:r>
+              <a:t>2. THERMAL ENGINE</a:t>
+            </a:r>
+          </a:p>
+        </p:txBody>
+      </p:sp>
+      <p:sp>
+        <p:nvSpPr>
+          <p:cNvPr id="11" name="TextBox 10"/>
+          <p:cNvSpPr txBox="1"/>
+          <p:nvPr/>
+        </p:nvSpPr>
+        <p:spPr>
+          <a:xfrm>
+            <a:off x="3566160" y="1783080"/>
+            <a:ext cx="2322576" cy="2743200"/>
+          </a:xfrm>
+          <a:prstGeom prst="rect">
+            <a:avLst/>
+          </a:prstGeom>
+          <a:noFill/>
+        </p:spPr>
+        <p:txBody>
+          <a:bodyPr wrap="square" lIns="0" tIns="0" rIns="0" bIns="0">
+            <a:spAutoFit/>
+          </a:bodyPr>
+          <a:lstStyle/>
+          <a:p>
+            <a:pPr>
+              <a:defRPr sz="900" b="1">
+                <a:solidFill>
+                  <a:srgbClr val="0F2C59"/>
+                </a:solidFill>
+              </a:defRPr>
+            </a:pPr>
+            <a:r>
+              <a:t>UTCI 6th-Order Polynomial</a:t>
+            </a:r>
+          </a:p>
+          <a:p>
+            <a:pPr>
+              <a:spcBef>
+                <a:spcPts val="300"/>
+              </a:spcBef>
+              <a:defRPr sz="900">
+                <a:solidFill>
+                  <a:srgbClr val="0F172A"/>
+                </a:solidFill>
+              </a:defRPr>
+            </a:pPr>
+            <a:r>
+              <a:t>• Fiala 187-Node Human Model</a:t>
+            </a:r>
+          </a:p>
+          <a:p>
+            <a:pPr>
+              <a:spcBef>
+                <a:spcPts val="300"/>
+              </a:spcBef>
+              <a:defRPr sz="900">
+                <a:solidFill>
+                  <a:srgbClr val="0F172A"/>
+                </a:solidFill>
+              </a:defRPr>
+            </a:pPr>
+            <a:r>
+              <a:t>• ISO 7243 WBGT Psychrometrics</a:t>
+            </a:r>
+          </a:p>
+          <a:p>
+            <a:pPr>
+              <a:spcBef>
+                <a:spcPts val="300"/>
+              </a:spcBef>
+              <a:defRPr sz="900">
+                <a:solidFill>
+                  <a:srgbClr val="0F172A"/>
+                </a:solidFill>
+              </a:defRPr>
+            </a:pPr>
+            <a:r>
+              <a:t>• Stull Tw &amp; Liljegren Tg Models</a:t>
+            </a:r>
+          </a:p>
+          <a:p>
+            <a:pPr>
+              <a:spcBef>
+                <a:spcPts val="300"/>
+              </a:spcBef>
+              <a:defRPr sz="900">
+                <a:solidFill>
+                  <a:srgbClr val="0F172A"/>
+                </a:solidFill>
+              </a:defRPr>
+            </a:pPr>
+            <a:r>
+              <a:t>• Cumulative Multi-Day Dmult</a:t>
+            </a:r>
+          </a:p>
+        </p:txBody>
+      </p:sp>
+      <p:sp>
+        <p:nvSpPr>
+          <p:cNvPr id="12" name="Rounded Rectangle 11"/>
+          <p:cNvSpPr/>
+          <p:nvPr/>
+        </p:nvSpPr>
+        <p:spPr>
+          <a:xfrm>
+            <a:off x="6181344" y="1280160"/>
+            <a:ext cx="2542032" cy="3383280"/>
+          </a:xfrm>
+          <a:prstGeom prst="roundRect">
+            <a:avLst/>
+          </a:prstGeom>
+          <a:solidFill>
+            <a:srgbClr val="FFFFFF"/>
+          </a:solidFill>
+          <a:ln w="19050">
+            <a:solidFill>
+              <a:srgbClr val="DC2626"/>
+            </a:solidFill>
+          </a:ln>
+        </p:spPr>
+        <p:style>
+          <a:lnRef idx="1">
+            <a:schemeClr val="accent1"/>
+          </a:lnRef>
+          <a:fillRef idx="3">
+            <a:schemeClr val="accent1"/>
+          </a:fillRef>
+          <a:effectRef idx="2">
+            <a:schemeClr val="accent1"/>
+          </a:effectRef>
+          <a:fontRef idx="minor">
+            <a:schemeClr val="lt1"/>
+          </a:fontRef>
+        </p:style>
+        <p:txBody>
+          <a:bodyPr rtlCol="0" anchor="ctr"/>
+          <a:lstStyle/>
+          <a:p>
+            <a:pPr algn="ctr"/>
+          </a:p>
+        </p:txBody>
+      </p:sp>
+      <p:sp>
+        <p:nvSpPr>
+          <p:cNvPr id="13" name="Rounded Rectangle 12"/>
+          <p:cNvSpPr/>
+          <p:nvPr/>
+        </p:nvSpPr>
+        <p:spPr>
+          <a:xfrm>
+            <a:off x="6254496" y="1353312"/>
+            <a:ext cx="2395728" cy="365760"/>
+          </a:xfrm>
+          <a:prstGeom prst="roundRect">
+            <a:avLst/>
+          </a:prstGeom>
+          <a:solidFill>
+            <a:srgbClr val="FEF2F2"/>
+          </a:solidFill>
+          <a:ln w="12700">
+            <a:solidFill>
+              <a:srgbClr val="DC2626"/>
+            </a:solidFill>
+          </a:ln>
+        </p:spPr>
+        <p:style>
+          <a:lnRef idx="1">
+            <a:schemeClr val="accent1"/>
+          </a:lnRef>
+          <a:fillRef idx="3">
+            <a:schemeClr val="accent1"/>
+          </a:fillRef>
+          <a:effectRef idx="2">
+            <a:schemeClr val="accent1"/>
+          </a:effectRef>
+          <a:fontRef idx="minor">
+            <a:schemeClr val="lt1"/>
+          </a:fontRef>
+        </p:style>
+        <p:txBody>
+          <a:bodyPr rtlCol="0" anchor="ctr"/>
+          <a:lstStyle/>
+          <a:p>
+            <a:pPr algn="ctr">
+              <a:defRPr sz="1000" b="1">
+                <a:solidFill>
+                  <a:srgbClr val="DC2626"/>
+                </a:solidFill>
+              </a:defRPr>
+            </a:pPr>
+            <a:r>
+              <a:t>3. AI &amp; HVI MODEL</a:t>
+            </a:r>
+          </a:p>
+        </p:txBody>
+      </p:sp>
+      <p:sp>
+        <p:nvSpPr>
+          <p:cNvPr id="14" name="TextBox 13"/>
+          <p:cNvSpPr txBox="1"/>
+          <p:nvPr/>
+        </p:nvSpPr>
+        <p:spPr>
+          <a:xfrm>
+            <a:off x="6291072" y="1783080"/>
+            <a:ext cx="2322576" cy="2743200"/>
+          </a:xfrm>
+          <a:prstGeom prst="rect">
+            <a:avLst/>
+          </a:prstGeom>
+          <a:noFill/>
+        </p:spPr>
+        <p:txBody>
+          <a:bodyPr wrap="square" lIns="0" tIns="0" rIns="0" bIns="0">
+            <a:spAutoFit/>
+          </a:bodyPr>
+          <a:lstStyle/>
+          <a:p>
+            <a:pPr>
+              <a:defRPr sz="900" b="1">
+                <a:solidFill>
+                  <a:srgbClr val="0F2C59"/>
+                </a:solidFill>
+              </a:defRPr>
+            </a:pPr>
+            <a:r>
+              <a:t>Census Demographic Vulnerability</a:t>
+            </a:r>
+          </a:p>
+          <a:p>
+            <a:pPr>
+              <a:spcBef>
+                <a:spcPts val="300"/>
+              </a:spcBef>
+              <a:defRPr sz="900">
+                <a:solidFill>
+                  <a:srgbClr val="0F172A"/>
+                </a:solidFill>
+              </a:defRPr>
+            </a:pPr>
+            <a:r>
+              <a:t>• Elderly Density &amp; Slum Ratio</a:t>
+            </a:r>
+          </a:p>
+          <a:p>
+            <a:pPr>
+              <a:spcBef>
+                <a:spcPts val="300"/>
+              </a:spcBef>
+              <a:defRPr sz="900">
+                <a:solidFill>
+                  <a:srgbClr val="0F172A"/>
+                </a:solidFill>
+              </a:defRPr>
+            </a:pPr>
+            <a:r>
+              <a:t>• Outdoor Labor Concentration</a:t>
+            </a:r>
+          </a:p>
+          <a:p>
+            <a:pPr>
+              <a:spcBef>
+                <a:spcPts val="300"/>
+              </a:spcBef>
+              <a:defRPr sz="900">
+                <a:solidFill>
+                  <a:srgbClr val="0F172A"/>
+                </a:solidFill>
+              </a:defRPr>
+            </a:pPr>
+            <a:r>
+              <a:t>• Tree Canopy Deficit Index</a:t>
+            </a:r>
+          </a:p>
+          <a:p>
+            <a:pPr>
+              <a:spcBef>
+                <a:spcPts val="300"/>
+              </a:spcBef>
+              <a:defRPr sz="900">
+                <a:solidFill>
+                  <a:srgbClr val="0F172A"/>
+                </a:solidFill>
+              </a:defRPr>
+            </a:pPr>
+            <a:r>
+              <a:t>• Relative Heat-Health Score</a:t>
+            </a:r>
+          </a:p>
+        </p:txBody>
+      </p:sp>
+      <p:sp>
+        <p:nvSpPr>
+          <p:cNvPr id="15" name="Rounded Rectangle 14"/>
+          <p:cNvSpPr/>
+          <p:nvPr/>
+        </p:nvSpPr>
+        <p:spPr>
+          <a:xfrm>
+            <a:off x="8906256" y="1280160"/>
+            <a:ext cx="2542032" cy="3383280"/>
+          </a:xfrm>
+          <a:prstGeom prst="roundRect">
+            <a:avLst/>
+          </a:prstGeom>
+          <a:solidFill>
+            <a:srgbClr val="FFFFFF"/>
+          </a:solidFill>
+          <a:ln w="19050">
+            <a:solidFill>
+              <a:srgbClr val="0F2C59"/>
+            </a:solidFill>
+          </a:ln>
+        </p:spPr>
+        <p:style>
+          <a:lnRef idx="1">
+            <a:schemeClr val="accent1"/>
+          </a:lnRef>
+          <a:fillRef idx="3">
+            <a:schemeClr val="accent1"/>
+          </a:fillRef>
+          <a:effectRef idx="2">
+            <a:schemeClr val="accent1"/>
+          </a:effectRef>
+          <a:fontRef idx="minor">
+            <a:schemeClr val="lt1"/>
+          </a:fontRef>
+        </p:style>
+        <p:txBody>
+          <a:bodyPr rtlCol="0" anchor="ctr"/>
+          <a:lstStyle/>
+          <a:p>
+            <a:pPr algn="ctr"/>
+          </a:p>
+        </p:txBody>
+      </p:sp>
+      <p:sp>
+        <p:nvSpPr>
+          <p:cNvPr id="16" name="Rounded Rectangle 15"/>
+          <p:cNvSpPr/>
+          <p:nvPr/>
+        </p:nvSpPr>
+        <p:spPr>
+          <a:xfrm>
+            <a:off x="8979408" y="1353312"/>
+            <a:ext cx="2395728" cy="365760"/>
           </a:xfrm>
           <a:prstGeom prst="roundRect">
             <a:avLst/>
@@ -4449,9 +5579,9 @@
           <a:solidFill>
             <a:srgbClr val="F0F9FF"/>
           </a:solidFill>
-          <a:ln w="19050">
+          <a:ln w="12700">
             <a:solidFill>
-              <a:srgbClr val="EA580C"/>
+              <a:srgbClr val="0F2C59"/>
             </a:solidFill>
           </a:ln>
         </p:spPr>
@@ -4474,491 +5604,123 @@
           <a:lstStyle/>
           <a:p>
             <a:pPr algn="ctr">
-              <a:defRPr sz="1050" b="1">
-                <a:solidFill>
-                  <a:srgbClr val="EA580C"/>
-                </a:solidFill>
-              </a:defRPr>
-            </a:pPr>
-            <a:r>
-              <a:t>1. MULTI-INPUT</a:t>
-            </a:r>
-            <a:br/>
-            <a:r>
-              <a:t>INGESTION</a:t>
+              <a:defRPr sz="1000" b="1">
+                <a:solidFill>
+                  <a:srgbClr val="0F2C59"/>
+                </a:solidFill>
+              </a:defRPr>
+            </a:pPr>
+            <a:r>
+              <a:t>4. ACTION &amp; GIS</a:t>
+            </a:r>
+          </a:p>
+        </p:txBody>
+      </p:sp>
+      <p:sp>
+        <p:nvSpPr>
+          <p:cNvPr id="17" name="TextBox 16"/>
+          <p:cNvSpPr txBox="1"/>
+          <p:nvPr/>
+        </p:nvSpPr>
+        <p:spPr>
+          <a:xfrm>
+            <a:off x="9015984" y="1783080"/>
+            <a:ext cx="2322576" cy="2743200"/>
+          </a:xfrm>
+          <a:prstGeom prst="rect">
+            <a:avLst/>
+          </a:prstGeom>
+          <a:noFill/>
+        </p:spPr>
+        <p:txBody>
+          <a:bodyPr wrap="square" lIns="0" tIns="0" rIns="0" bIns="0">
+            <a:spAutoFit/>
+          </a:bodyPr>
+          <a:lstStyle/>
+          <a:p>
+            <a:pPr>
+              <a:defRPr sz="900" b="1">
+                <a:solidFill>
+                  <a:srgbClr val="0F2C59"/>
+                </a:solidFill>
+              </a:defRPr>
+            </a:pPr>
+            <a:r>
+              <a:t>Interactive Leaflet GIS Map</a:t>
             </a:r>
           </a:p>
           <a:p>
             <a:pPr>
               <a:spcBef>
-                <a:spcPts val="400"/>
+                <a:spcPts val="300"/>
               </a:spcBef>
-              <a:defRPr sz="850">
+              <a:defRPr sz="900">
                 <a:solidFill>
                   <a:srgbClr val="0F172A"/>
                 </a:solidFill>
               </a:defRPr>
             </a:pPr>
             <a:r>
-              <a:t>• NWP 5-Day Hourly Weather (0.1° Grid)</a:t>
+              <a:t>• 25 REST Production APIs</a:t>
             </a:r>
           </a:p>
           <a:p>
             <a:pPr>
               <a:spcBef>
-                <a:spcPts val="400"/>
+                <a:spcPts val="300"/>
               </a:spcBef>
-              <a:defRPr sz="850">
+              <a:defRPr sz="900">
                 <a:solidFill>
                   <a:srgbClr val="0F172A"/>
                 </a:solidFill>
               </a:defRPr>
             </a:pPr>
             <a:r>
-              <a:t>• NASA POWER 40-Yr Climatology Normal</a:t>
+              <a:t>• Automated NDMA Playbooks</a:t>
             </a:r>
           </a:p>
           <a:p>
             <a:pPr>
               <a:spcBef>
-                <a:spcPts val="400"/>
+                <a:spcPts val="300"/>
               </a:spcBef>
-              <a:defRPr sz="850">
+              <a:defRPr sz="900">
                 <a:solidFill>
                   <a:srgbClr val="0F172A"/>
                 </a:solidFill>
               </a:defRPr>
             </a:pPr>
             <a:r>
-              <a:t>• Census 2011 PCA Ward Demographics</a:t>
+              <a:t>• Hospital Surge Bed Triggers</a:t>
             </a:r>
           </a:p>
           <a:p>
             <a:pPr>
               <a:spcBef>
-                <a:spcPts val="400"/>
+                <a:spcPts val="300"/>
               </a:spcBef>
-              <a:defRPr sz="850">
+              <a:defRPr sz="900">
                 <a:solidFill>
                   <a:srgbClr val="0F172A"/>
                 </a:solidFill>
               </a:defRPr>
             </a:pPr>
             <a:r>
-              <a:t>• Satellite LST &amp; NDVI Land Cover</a:t>
-            </a:r>
-          </a:p>
-        </p:txBody>
-      </p:sp>
-      <p:sp>
-        <p:nvSpPr>
-          <p:cNvPr id="7" name="Rounded Rectangle 6"/>
+              <a:t>• NIOSH Labor Halt Alerts</a:t>
+            </a:r>
+          </a:p>
+        </p:txBody>
+      </p:sp>
+      <p:sp>
+        <p:nvSpPr>
+          <p:cNvPr id="18" name="Rounded Rectangle 17"/>
           <p:cNvSpPr/>
           <p:nvPr/>
         </p:nvSpPr>
         <p:spPr>
           <a:xfrm>
-            <a:off x="2926080" y="1417320"/>
-            <a:ext cx="2926080" cy="3474720"/>
-          </a:xfrm>
-          <a:prstGeom prst="roundRect">
-            <a:avLst/>
-          </a:prstGeom>
-          <a:solidFill>
-            <a:srgbClr val="F0FDF4"/>
-          </a:solidFill>
-          <a:ln w="19050">
-            <a:solidFill>
-              <a:srgbClr val="16A34A"/>
-            </a:solidFill>
-          </a:ln>
-        </p:spPr>
-        <p:style>
-          <a:lnRef idx="1">
-            <a:schemeClr val="accent1"/>
-          </a:lnRef>
-          <a:fillRef idx="3">
-            <a:schemeClr val="accent1"/>
-          </a:fillRef>
-          <a:effectRef idx="2">
-            <a:schemeClr val="accent1"/>
-          </a:effectRef>
-          <a:fontRef idx="minor">
-            <a:schemeClr val="lt1"/>
-          </a:fontRef>
-        </p:style>
-        <p:txBody>
-          <a:bodyPr rtlCol="0" anchor="ctr"/>
-          <a:lstStyle/>
-          <a:p>
-            <a:pPr algn="ctr">
-              <a:defRPr sz="1050" b="1">
-                <a:solidFill>
-                  <a:srgbClr val="16A34A"/>
-                </a:solidFill>
-              </a:defRPr>
-            </a:pPr>
-            <a:r>
-              <a:t>2. THERMAL ENGINE &amp;</a:t>
-            </a:r>
-            <a:br/>
-            <a:r>
-              <a:t>PREPROCESSING</a:t>
-            </a:r>
-          </a:p>
-          <a:p>
-            <a:pPr>
-              <a:spcBef>
-                <a:spcPts val="400"/>
-              </a:spcBef>
-              <a:defRPr sz="850">
-                <a:solidFill>
-                  <a:srgbClr val="0F172A"/>
-                </a:solidFill>
-              </a:defRPr>
-            </a:pPr>
-            <a:r>
-              <a:t>• Spatial Harmonization &amp; Alignment</a:t>
-            </a:r>
-          </a:p>
-          <a:p>
-            <a:pPr>
-              <a:spcBef>
-                <a:spcPts val="400"/>
-              </a:spcBef>
-              <a:defRPr sz="850">
-                <a:solidFill>
-                  <a:srgbClr val="0F172A"/>
-                </a:solidFill>
-              </a:defRPr>
-            </a:pPr>
-            <a:r>
-              <a:t>• Vapor Pressure &amp; Wind Downscaling</a:t>
-            </a:r>
-          </a:p>
-          <a:p>
-            <a:pPr>
-              <a:spcBef>
-                <a:spcPts val="400"/>
-              </a:spcBef>
-              <a:defRPr sz="850">
-                <a:solidFill>
-                  <a:srgbClr val="0F172A"/>
-                </a:solidFill>
-              </a:defRPr>
-            </a:pPr>
-            <a:r>
-              <a:t>• UTCI 6th-Order Polynomial (Fiala)</a:t>
-            </a:r>
-          </a:p>
-          <a:p>
-            <a:pPr>
-              <a:spcBef>
-                <a:spcPts val="400"/>
-              </a:spcBef>
-              <a:defRPr sz="850">
-                <a:solidFill>
-                  <a:srgbClr val="0F172A"/>
-                </a:solidFill>
-              </a:defRPr>
-            </a:pPr>
-            <a:r>
-              <a:t>• ISO 7243 Outdoor WBGT Psychrometrics</a:t>
-            </a:r>
-          </a:p>
-          <a:p>
-            <a:pPr>
-              <a:spcBef>
-                <a:spcPts val="400"/>
-              </a:spcBef>
-              <a:defRPr sz="850">
-                <a:solidFill>
-                  <a:srgbClr val="0F172A"/>
-                </a:solidFill>
-              </a:defRPr>
-            </a:pPr>
-            <a:r>
-              <a:t>• Cumulative Persistence Engine (Dmult)</a:t>
-            </a:r>
-          </a:p>
-        </p:txBody>
-      </p:sp>
-      <p:sp>
-        <p:nvSpPr>
-          <p:cNvPr id="8" name="Rounded Rectangle 7"/>
-          <p:cNvSpPr/>
-          <p:nvPr/>
-        </p:nvSpPr>
-        <p:spPr>
-          <a:xfrm>
-            <a:off x="6035040" y="1417320"/>
-            <a:ext cx="2926080" cy="3474720"/>
-          </a:xfrm>
-          <a:prstGeom prst="roundRect">
-            <a:avLst/>
-          </a:prstGeom>
-          <a:solidFill>
-            <a:srgbClr val="FEF2F2"/>
-          </a:solidFill>
-          <a:ln w="19050">
-            <a:solidFill>
-              <a:srgbClr val="DC2626"/>
-            </a:solidFill>
-          </a:ln>
-        </p:spPr>
-        <p:style>
-          <a:lnRef idx="1">
-            <a:schemeClr val="accent1"/>
-          </a:lnRef>
-          <a:fillRef idx="3">
-            <a:schemeClr val="accent1"/>
-          </a:fillRef>
-          <a:effectRef idx="2">
-            <a:schemeClr val="accent1"/>
-          </a:effectRef>
-          <a:fontRef idx="minor">
-            <a:schemeClr val="lt1"/>
-          </a:fontRef>
-        </p:style>
-        <p:txBody>
-          <a:bodyPr rtlCol="0" anchor="ctr"/>
-          <a:lstStyle/>
-          <a:p>
-            <a:pPr algn="ctr">
-              <a:defRPr sz="1050" b="1">
-                <a:solidFill>
-                  <a:srgbClr val="DC2626"/>
-                </a:solidFill>
-              </a:defRPr>
-            </a:pPr>
-            <a:r>
-              <a:t>3. AI RISK &amp; HVI</a:t>
-            </a:r>
-            <a:br/>
-            <a:r>
-              <a:t>SYNTHESIS</a:t>
-            </a:r>
-          </a:p>
-          <a:p>
-            <a:pPr>
-              <a:spcBef>
-                <a:spcPts val="400"/>
-              </a:spcBef>
-              <a:defRPr sz="850">
-                <a:solidFill>
-                  <a:srgbClr val="0F172A"/>
-                </a:solidFill>
-              </a:defRPr>
-            </a:pPr>
-            <a:r>
-              <a:t>• Demographic Heat Vulnerability (HVI)</a:t>
-            </a:r>
-          </a:p>
-          <a:p>
-            <a:pPr>
-              <a:spcBef>
-                <a:spcPts val="400"/>
-              </a:spcBef>
-              <a:defRPr sz="850">
-                <a:solidFill>
-                  <a:srgbClr val="0F172A"/>
-                </a:solidFill>
-              </a:defRPr>
-            </a:pPr>
-            <a:r>
-              <a:t>• Elderly &amp; Outdoor Labor Weighting</a:t>
-            </a:r>
-          </a:p>
-          <a:p>
-            <a:pPr>
-              <a:spcBef>
-                <a:spcPts val="400"/>
-              </a:spcBef>
-              <a:defRPr sz="850">
-                <a:solidFill>
-                  <a:srgbClr val="0F172A"/>
-                </a:solidFill>
-              </a:defRPr>
-            </a:pPr>
-            <a:r>
-              <a:t>• Slum Density &amp; Canopy Deficit</a:t>
-            </a:r>
-          </a:p>
-          <a:p>
-            <a:pPr>
-              <a:spcBef>
-                <a:spcPts val="400"/>
-              </a:spcBef>
-              <a:defRPr sz="850">
-                <a:solidFill>
-                  <a:srgbClr val="0F172A"/>
-                </a:solidFill>
-              </a:defRPr>
-            </a:pPr>
-            <a:r>
-              <a:t>• Normalized 0–100 Heat-Health Score</a:t>
-            </a:r>
-          </a:p>
-          <a:p>
-            <a:pPr>
-              <a:spcBef>
-                <a:spcPts val="400"/>
-              </a:spcBef>
-              <a:defRPr sz="850">
-                <a:solidFill>
-                  <a:srgbClr val="0F172A"/>
-                </a:solidFill>
-              </a:defRPr>
-            </a:pPr>
-            <a:r>
-              <a:t>• Relative Risk Epidemiological Model</a:t>
-            </a:r>
-          </a:p>
-        </p:txBody>
-      </p:sp>
-      <p:sp>
-        <p:nvSpPr>
-          <p:cNvPr id="9" name="Rounded Rectangle 8"/>
-          <p:cNvSpPr/>
-          <p:nvPr/>
-        </p:nvSpPr>
-        <p:spPr>
-          <a:xfrm>
-            <a:off x="9144000" y="1417320"/>
-            <a:ext cx="2316175" cy="3474720"/>
-          </a:xfrm>
-          <a:prstGeom prst="roundRect">
-            <a:avLst/>
-          </a:prstGeom>
-          <a:solidFill>
-            <a:srgbClr val="F0F9FF"/>
-          </a:solidFill>
-          <a:ln w="19050">
-            <a:solidFill>
-              <a:srgbClr val="0284C7"/>
-            </a:solidFill>
-          </a:ln>
-        </p:spPr>
-        <p:style>
-          <a:lnRef idx="1">
-            <a:schemeClr val="accent1"/>
-          </a:lnRef>
-          <a:fillRef idx="3">
-            <a:schemeClr val="accent1"/>
-          </a:fillRef>
-          <a:effectRef idx="2">
-            <a:schemeClr val="accent1"/>
-          </a:effectRef>
-          <a:fontRef idx="minor">
-            <a:schemeClr val="lt1"/>
-          </a:fontRef>
-        </p:style>
-        <p:txBody>
-          <a:bodyPr rtlCol="0" anchor="ctr"/>
-          <a:lstStyle/>
-          <a:p>
-            <a:pPr algn="ctr">
-              <a:defRPr sz="1050" b="1">
-                <a:solidFill>
-                  <a:srgbClr val="0F2C59"/>
-                </a:solidFill>
-              </a:defRPr>
-            </a:pPr>
-            <a:r>
-              <a:t>4. ACTION DELIVERY &amp;</a:t>
-            </a:r>
-            <a:br/>
-            <a:r>
-              <a:t>VALIDATION</a:t>
-            </a:r>
-          </a:p>
-          <a:p>
-            <a:pPr>
-              <a:spcBef>
-                <a:spcPts val="400"/>
-              </a:spcBef>
-              <a:defRPr sz="850">
-                <a:solidFill>
-                  <a:srgbClr val="0F172A"/>
-                </a:solidFill>
-              </a:defRPr>
-            </a:pPr>
-            <a:r>
-              <a:t>• Interactive Leaflet GIS Map</a:t>
-            </a:r>
-          </a:p>
-          <a:p>
-            <a:pPr>
-              <a:spcBef>
-                <a:spcPts val="400"/>
-              </a:spcBef>
-              <a:defRPr sz="850">
-                <a:solidFill>
-                  <a:srgbClr val="0F172A"/>
-                </a:solidFill>
-              </a:defRPr>
-            </a:pPr>
-            <a:r>
-              <a:t>• 25 REST APIs (FastAPI)</a:t>
-            </a:r>
-          </a:p>
-          <a:p>
-            <a:pPr>
-              <a:spcBef>
-                <a:spcPts val="400"/>
-              </a:spcBef>
-              <a:defRPr sz="850">
-                <a:solidFill>
-                  <a:srgbClr val="0F172A"/>
-                </a:solidFill>
-              </a:defRPr>
-            </a:pPr>
-            <a:r>
-              <a:t>• Bilingual NDMA Action Playbooks</a:t>
-            </a:r>
-          </a:p>
-          <a:p>
-            <a:pPr>
-              <a:spcBef>
-                <a:spcPts val="400"/>
-              </a:spcBef>
-              <a:defRPr sz="850">
-                <a:solidFill>
-                  <a:srgbClr val="0F172A"/>
-                </a:solidFill>
-              </a:defRPr>
-            </a:pPr>
-            <a:r>
-              <a:t>• Hospital Surge Bed Automation</a:t>
-            </a:r>
-          </a:p>
-          <a:p>
-            <a:pPr>
-              <a:spcBef>
-                <a:spcPts val="400"/>
-              </a:spcBef>
-              <a:defRPr sz="850">
-                <a:solidFill>
-                  <a:srgbClr val="0F172A"/>
-                </a:solidFill>
-              </a:defRPr>
-            </a:pPr>
-            <a:r>
-              <a:t>• NIOSH Labor Halt Protocols</a:t>
-            </a:r>
-          </a:p>
-        </p:txBody>
-      </p:sp>
-      <p:sp>
-        <p:nvSpPr>
-          <p:cNvPr id="10" name="Rounded Rectangle 9"/>
-          <p:cNvSpPr/>
-          <p:nvPr/>
-        </p:nvSpPr>
-        <p:spPr>
-          <a:xfrm>
-            <a:off x="731520" y="5029200"/>
-            <a:ext cx="10728655" cy="1280160"/>
+            <a:off x="731520" y="4754880"/>
+            <a:ext cx="10728655" cy="1600200"/>
           </a:xfrm>
           <a:prstGeom prst="roundRect">
             <a:avLst/>
@@ -5006,33 +5768,98 @@
               <a:spcBef>
                 <a:spcPts val="200"/>
               </a:spcBef>
-              <a:defRPr sz="900">
+              <a:defRPr sz="900" b="1">
+                <a:solidFill>
+                  <a:srgbClr val="0F2C59"/>
+                </a:solidFill>
+              </a:defRPr>
+            </a:pPr>
+            <a:r>
+              <a:t>• Backend &amp; REST APIs: </a:t>
+            </a:r>
+            <a:r>
+              <a:rPr b="0">
                 <a:solidFill>
                   <a:srgbClr val="0F172A"/>
                 </a:solidFill>
-              </a:defRPr>
-            </a:pPr>
-            <a:r>
-              <a:t>• Core Backend: Python 3.11, FastAPI, Pydantic v2, Uvicorn, REST Architecture (25 Production Endpoints)</a:t>
-            </a:r>
-            <a:br/>
-            <a:r>
-              <a:t>• Scientific Computing &amp; GIS: NumPy, Pandas, GeoPandas, Shapely, Scipy (UTCI 6th-order polynomial &amp; psychrometrics)</a:t>
-            </a:r>
-            <a:br/>
-            <a:r>
-              <a:t>• Web GIS &amp; Visualization: Leaflet.js (Choropleth GIS), Chart.js (5-Day Trend Curves), HTML5/CSS3 Responsive UI</a:t>
-            </a:r>
-            <a:br/>
-            <a:r>
-              <a:t>• Deployment &amp; Data: Docker, Docker Compose, Linux VPS (Oracle Linux 6.17), Open-Meteo NWP, NASA POWER, Census India</a:t>
-            </a:r>
-          </a:p>
-        </p:txBody>
-      </p:sp>
-      <p:sp>
-        <p:nvSpPr>
-          <p:cNvPr id="11" name="Rectangle 10"/>
+              </a:rPr>
+              <a:t>Python 3.11, FastAPI, Pydantic v2, Uvicorn, AsyncIO (25 REST endpoints)</a:t>
+            </a:r>
+          </a:p>
+          <a:p>
+            <a:pPr>
+              <a:spcBef>
+                <a:spcPts val="200"/>
+              </a:spcBef>
+              <a:defRPr sz="900" b="1">
+                <a:solidFill>
+                  <a:srgbClr val="0F2C59"/>
+                </a:solidFill>
+              </a:defRPr>
+            </a:pPr>
+            <a:r>
+              <a:t>• Biometeorological &amp; GIS Engine: </a:t>
+            </a:r>
+            <a:r>
+              <a:rPr b="0">
+                <a:solidFill>
+                  <a:srgbClr val="0F172A"/>
+                </a:solidFill>
+              </a:rPr>
+              <a:t>NumPy, Pandas, GeoPandas, Shapely, Scipy (UTCI 6th-order polynomial &amp; psychrometrics)</a:t>
+            </a:r>
+          </a:p>
+          <a:p>
+            <a:pPr>
+              <a:spcBef>
+                <a:spcPts val="200"/>
+              </a:spcBef>
+              <a:defRPr sz="900" b="1">
+                <a:solidFill>
+                  <a:srgbClr val="0F2C59"/>
+                </a:solidFill>
+              </a:defRPr>
+            </a:pPr>
+            <a:r>
+              <a:t>• Web GIS &amp; Visualization: </a:t>
+            </a:r>
+            <a:r>
+              <a:rPr b="0">
+                <a:solidFill>
+                  <a:srgbClr val="0F172A"/>
+                </a:solidFill>
+              </a:rPr>
+              <a:t>Leaflet.js (Choropleth GIS), Chart.js (5-Day Trend Curves), HTML5/CSS3 Responsive UI</a:t>
+            </a:r>
+          </a:p>
+          <a:p>
+            <a:pPr>
+              <a:spcBef>
+                <a:spcPts val="200"/>
+              </a:spcBef>
+              <a:defRPr sz="900" b="1">
+                <a:solidFill>
+                  <a:srgbClr val="0F2C59"/>
+                </a:solidFill>
+              </a:defRPr>
+            </a:pPr>
+            <a:r>
+              <a:t>• Data Ingestion &amp; Cloud Infra: </a:t>
+            </a:r>
+            <a:r>
+              <a:rPr b="0">
+                <a:solidFill>
+                  <a:srgbClr val="0F172A"/>
+                </a:solidFill>
+              </a:rPr>
+              <a:t>Open-Meteo NWP, NASA POWER (MERRA-2), Census India PCA, Docker, Linux VPS (Oracle Linux)</a:t>
+            </a:r>
+          </a:p>
+        </p:txBody>
+      </p:sp>
+      <p:sp>
+        <p:nvSpPr>
+          <p:cNvPr id="19" name="Rectangle 18"/>
           <p:cNvSpPr/>
           <p:nvPr/>
         </p:nvSpPr>
@@ -5075,7 +5902,7 @@
       </p:sp>
       <p:sp>
         <p:nvSpPr>
-          <p:cNvPr id="12" name="TextBox 11"/>
+          <p:cNvPr id="20" name="TextBox 19"/>
           <p:cNvSpPr txBox="1"/>
           <p:nvPr/>
         </p:nvSpPr>
@@ -5111,7 +5938,7 @@
       </p:sp>
       <p:sp>
         <p:nvSpPr>
-          <p:cNvPr id="13" name="TextBox 12"/>
+          <p:cNvPr id="21" name="TextBox 20"/>
           <p:cNvSpPr txBox="1"/>
           <p:nvPr/>
         </p:nvSpPr>
@@ -5178,7 +6005,7 @@
         </p:nvSpPr>
         <p:spPr>
           <a:xfrm>
-            <a:off x="548640" y="228600"/>
+            <a:off x="548640" y="182880"/>
             <a:ext cx="2011680" cy="502920"/>
           </a:xfrm>
           <a:prstGeom prst="roundRect">
@@ -5216,6 +6043,7 @@
                 <a:solidFill>
                   <a:srgbClr val="6D28D9"/>
                 </a:solidFill>
+                <a:latin typeface="Arial"/>
               </a:defRPr>
             </a:pPr>
             <a:r>
@@ -5232,8 +6060,8 @@
         </p:nvSpPr>
         <p:spPr>
           <a:xfrm>
-            <a:off x="2743200" y="182880"/>
-            <a:ext cx="6705295" cy="594360"/>
+            <a:off x="2651760" y="164592"/>
+            <a:ext cx="6858000" cy="548640"/>
           </a:xfrm>
           <a:prstGeom prst="rect">
             <a:avLst/>
@@ -5247,7 +6075,7 @@
           <a:lstStyle/>
           <a:p>
             <a:pPr algn="ctr">
-              <a:defRPr sz="1800" b="1">
+              <a:defRPr sz="1700" b="1">
                 <a:solidFill>
                   <a:srgbClr val="0F172A"/>
                 </a:solidFill>
@@ -5268,7 +6096,7 @@
         </p:nvSpPr>
         <p:spPr>
           <a:xfrm>
-            <a:off x="9601200" y="182880"/>
+            <a:off x="9601200" y="137160"/>
             <a:ext cx="2011680" cy="594360"/>
           </a:xfrm>
           <a:prstGeom prst="roundRect">
@@ -5306,6 +6134,7 @@
                 <a:solidFill>
                   <a:srgbClr val="0F2C59"/>
                 </a:solidFill>
+                <a:latin typeface="Arial"/>
               </a:defRPr>
             </a:pPr>
             <a:r>
@@ -5318,6 +6147,7 @@
                 <a:solidFill>
                   <a:srgbClr val="EA580C"/>
                 </a:solidFill>
+                <a:latin typeface="Arial"/>
               </a:defRPr>
             </a:pPr>
             <a:r>
@@ -5334,8 +6164,8 @@
         </p:nvSpPr>
         <p:spPr>
           <a:xfrm>
-            <a:off x="731520" y="1005840"/>
-            <a:ext cx="10728655" cy="1554480"/>
+            <a:off x="731520" y="868680"/>
+            <a:ext cx="10728655" cy="1463040"/>
           </a:xfrm>
           <a:prstGeom prst="rect">
             <a:avLst/>
@@ -5362,31 +6192,31 @@
           <a:p>
             <a:pPr>
               <a:spcBef>
-                <a:spcPts val="200"/>
+                <a:spcPts val="100"/>
               </a:spcBef>
-              <a:defRPr sz="950">
+              <a:defRPr sz="900">
                 <a:solidFill>
                   <a:srgbClr val="0F172A"/>
                 </a:solidFill>
               </a:defRPr>
             </a:pPr>
             <a:r>
-              <a:t>The proposed ThermoShield system is highly feasible due to the availability of open, keyless Tier-1 atmospheric datasets (Open-Meteo 0.1° NWP hourly forecasts and NASA POWER MERRA-2 40-year climatological baselines) and proven biometeorological algorithms (UTCI polynomial &amp; ISO 7243 WBGT). The integration of Census 2011 PCA demographics enables hyper-local ward-level vulnerability mapping without waiting for restricted government clearance.</a:t>
+              <a:t>The proposed ThermoShield system is fully feasible due to open, keyless Tier-1 atmospheric data pipelines (Open-Meteo 0.1° NWP hourly forecasts and NASA POWER MERRA-2 40-year climatological normals) and validated biometeorological equations (UTCI polynomial &amp; ISO 7243 WBGT). The use of Census 2011 PCA demographics enables hyper-local ward-level vulnerability mapping without waiting for restricted government clearance.</a:t>
             </a:r>
           </a:p>
           <a:p>
             <a:pPr>
               <a:spcBef>
-                <a:spcPts val="400"/>
+                <a:spcPts val="300"/>
               </a:spcBef>
-              <a:defRPr sz="950" b="1">
+              <a:defRPr sz="900" b="1">
                 <a:solidFill>
                   <a:srgbClr val="0F2C59"/>
                 </a:solidFill>
               </a:defRPr>
             </a:pPr>
             <a:r>
-              <a:t>❖  Product Offering: We are offering this system to Municipal Corporations, State Disaster Management Authorities (SDMAs), Health Departments, and Gig/Labor platforms as an automated, impact-to-action early warning and resource coordination OS.</a:t>
+              <a:t>❖  Product Offering: We offer this platform to Municipal Corporations, State Disaster Management Authorities (SDMAs), Health Departments, and Gig Platforms as an automated, impact-to-action early warning and resource coordination OS.</a:t>
             </a:r>
           </a:p>
         </p:txBody>
@@ -5399,8 +6229,8 @@
         </p:nvSpPr>
         <p:spPr>
           <a:xfrm>
-            <a:off x="731520" y="2743200"/>
-            <a:ext cx="6858000" cy="3566160"/>
+            <a:off x="731520" y="2468880"/>
+            <a:ext cx="6858000" cy="3886200"/>
           </a:xfrm>
           <a:prstGeom prst="roundRect">
             <a:avLst/>
@@ -5429,7 +6259,7 @@
           </a:fontRef>
         </p:style>
         <p:txBody>
-          <a:bodyPr rtlCol="0" anchor="ctr" wrap="square" lIns="0" tIns="0" rIns="0" bIns="0"/>
+          <a:bodyPr rtlCol="0" anchor="ctr"/>
           <a:lstStyle/>
           <a:p>
             <a:pPr algn="ctr"/>
@@ -5444,7 +6274,7 @@
         </p:nvSpPr>
         <p:spPr>
           <a:xfrm>
-            <a:off x="914400" y="2834640"/>
+            <a:off x="914400" y="2560320"/>
             <a:ext cx="6492240" cy="365760"/>
           </a:xfrm>
           <a:prstGeom prst="rect">
@@ -5479,7 +6309,7 @@
         </p:nvSpPr>
         <p:spPr>
           <a:xfrm>
-            <a:off x="914400" y="3291840"/>
+            <a:off x="914400" y="2971800"/>
             <a:ext cx="6492240" cy="594360"/>
           </a:xfrm>
           <a:prstGeom prst="rect">
@@ -5494,21 +6324,21 @@
           <a:lstStyle/>
           <a:p>
             <a:r>
-              <a:rPr sz="950" b="1">
+              <a:rPr sz="900" b="1">
                 <a:solidFill>
                   <a:srgbClr val="DC2626"/>
                 </a:solidFill>
               </a:rPr>
-              <a:t>• Data Heterogeneity (Grid vs Wards)
+              <a:t>• Data Heterogeneity (0.1° Grid vs Wards)
 </a:t>
             </a:r>
             <a:r>
-              <a:rPr sz="950" b="1">
+              <a:rPr sz="900" b="1">
                 <a:solidFill>
                   <a:srgbClr val="16A34A"/>
                 </a:solidFill>
               </a:rPr>
-              <a:t>   ➔  Spatial Harmonization &amp; Geometric Attribution</a:t>
+              <a:t>   ➔  Spatial Harmonization &amp; Polygon Attribution</a:t>
             </a:r>
           </a:p>
         </p:txBody>
@@ -5521,7 +6351,7 @@
         </p:nvSpPr>
         <p:spPr>
           <a:xfrm>
-            <a:off x="914400" y="3977639"/>
+            <a:off x="914400" y="3630168"/>
             <a:ext cx="6492240" cy="594360"/>
           </a:xfrm>
           <a:prstGeom prst="rect">
@@ -5536,7 +6366,7 @@
           <a:lstStyle/>
           <a:p>
             <a:r>
-              <a:rPr sz="950" b="1">
+              <a:rPr sz="900" b="1">
                 <a:solidFill>
                   <a:srgbClr val="DC2626"/>
                 </a:solidFill>
@@ -5545,12 +6375,12 @@
 </a:t>
             </a:r>
             <a:r>
-              <a:rPr sz="950" b="1">
+              <a:rPr sz="900" b="1">
                 <a:solidFill>
                   <a:srgbClr val="16A34A"/>
                 </a:solidFill>
               </a:rPr>
-              <a:t>   ➔  Epidemiological Calibration (Azhar 2014)</a:t>
+              <a:t>   ➔  Epidemiological Calibration (Azhar 2014 &amp; Mazdiyasni 2017)</a:t>
             </a:r>
           </a:p>
         </p:txBody>
@@ -5563,7 +6393,7 @@
         </p:nvSpPr>
         <p:spPr>
           <a:xfrm>
-            <a:off x="914400" y="4663440"/>
+            <a:off x="914400" y="4288536"/>
             <a:ext cx="6492240" cy="594360"/>
           </a:xfrm>
           <a:prstGeom prst="rect">
@@ -5578,7 +6408,7 @@
           <a:lstStyle/>
           <a:p>
             <a:r>
-              <a:rPr sz="950" b="1">
+              <a:rPr sz="900" b="1">
                 <a:solidFill>
                   <a:srgbClr val="DC2626"/>
                 </a:solidFill>
@@ -5587,12 +6417,12 @@
 </a:t>
             </a:r>
             <a:r>
-              <a:rPr sz="950" b="1">
+              <a:rPr sz="900" b="1">
                 <a:solidFill>
                   <a:srgbClr val="16A34A"/>
                 </a:solidFill>
               </a:rPr>
-              <a:t>   ➔  Bounded 0–100 Heat-Health Risk Index</a:t>
+              <a:t>   ➔  Bounded 0–100 Human Heat-Health Risk Score</a:t>
             </a:r>
           </a:p>
         </p:txBody>
@@ -5605,7 +6435,7 @@
         </p:nvSpPr>
         <p:spPr>
           <a:xfrm>
-            <a:off x="914400" y="5349240"/>
+            <a:off x="914400" y="4946904"/>
             <a:ext cx="6492240" cy="594360"/>
           </a:xfrm>
           <a:prstGeom prst="rect">
@@ -5620,7 +6450,7 @@
           <a:lstStyle/>
           <a:p>
             <a:r>
-              <a:rPr sz="950" b="1">
+              <a:rPr sz="900" b="1">
                 <a:solidFill>
                   <a:srgbClr val="DC2626"/>
                 </a:solidFill>
@@ -5629,26 +6459,68 @@
 </a:t>
             </a:r>
             <a:r>
-              <a:rPr sz="950" b="1">
+              <a:rPr sz="900" b="1">
                 <a:solidFill>
                   <a:srgbClr val="16A34A"/>
                 </a:solidFill>
               </a:rPr>
-              <a:t>   ➔  Compound Multi-Day Persistence Penalty (Dmult)</a:t>
-            </a:r>
-          </a:p>
-        </p:txBody>
-      </p:sp>
-      <p:sp>
-        <p:nvSpPr>
-          <p:cNvPr id="12" name="Rounded Rectangle 11"/>
+              <a:t>   ➔  Compound Multi-Day Persistence Multiplier (Dmult)</a:t>
+            </a:r>
+          </a:p>
+        </p:txBody>
+      </p:sp>
+      <p:sp>
+        <p:nvSpPr>
+          <p:cNvPr id="12" name="TextBox 11"/>
+          <p:cNvSpPr txBox="1"/>
+          <p:nvPr/>
+        </p:nvSpPr>
+        <p:spPr>
+          <a:xfrm>
+            <a:off x="914400" y="5605272"/>
+            <a:ext cx="6492240" cy="594360"/>
+          </a:xfrm>
+          <a:prstGeom prst="rect">
+            <a:avLst/>
+          </a:prstGeom>
+          <a:noFill/>
+        </p:spPr>
+        <p:txBody>
+          <a:bodyPr wrap="square" lIns="0" tIns="0" rIns="0" bIns="0">
+            <a:spAutoFit/>
+          </a:bodyPr>
+          <a:lstStyle/>
+          <a:p>
+            <a:r>
+              <a:rPr sz="900" b="1">
+                <a:solidFill>
+                  <a:srgbClr val="DC2626"/>
+                </a:solidFill>
+              </a:rPr>
+              <a:t>• Uncooled Nighttime Strain (Tmin &gt; 28°C)
+</a:t>
+            </a:r>
+            <a:r>
+              <a:rPr sz="900" b="1">
+                <a:solidFill>
+                  <a:srgbClr val="16A34A"/>
+                </a:solidFill>
+              </a:rPr>
+              <a:t>   ➔  Explicit Nocturnal Recovery Penalty Algorithm</a:t>
+            </a:r>
+          </a:p>
+        </p:txBody>
+      </p:sp>
+      <p:sp>
+        <p:nvSpPr>
+          <p:cNvPr id="13" name="Rounded Rectangle 12"/>
           <p:cNvSpPr/>
           <p:nvPr/>
         </p:nvSpPr>
         <p:spPr>
           <a:xfrm>
-            <a:off x="7772400" y="2743200"/>
-            <a:ext cx="3687775" cy="3566160"/>
+            <a:off x="7772400" y="2468880"/>
+            <a:ext cx="3687775" cy="3886200"/>
           </a:xfrm>
           <a:prstGeom prst="roundRect">
             <a:avLst/>
@@ -5694,9 +6566,9 @@
           <a:p>
             <a:pPr>
               <a:spcBef>
-                <a:spcPts val="600"/>
+                <a:spcPts val="500"/>
               </a:spcBef>
-              <a:defRPr sz="950" b="1">
+              <a:defRPr sz="900" b="1">
                 <a:solidFill>
                   <a:srgbClr val="0F2C59"/>
                 </a:solidFill>
@@ -5708,7 +6580,7 @@
           </a:p>
           <a:p>
             <a:pPr>
-              <a:defRPr sz="850">
+              <a:defRPr sz="800">
                 <a:solidFill>
                   <a:srgbClr val="475569"/>
                 </a:solidFill>
@@ -5721,9 +6593,9 @@
           <a:p>
             <a:pPr>
               <a:spcBef>
-                <a:spcPts val="600"/>
+                <a:spcPts val="500"/>
               </a:spcBef>
-              <a:defRPr sz="950" b="1">
+              <a:defRPr sz="900" b="1">
                 <a:solidFill>
                   <a:srgbClr val="0F2C59"/>
                 </a:solidFill>
@@ -5735,7 +6607,7 @@
           </a:p>
           <a:p>
             <a:pPr>
-              <a:defRPr sz="850">
+              <a:defRPr sz="800">
                 <a:solidFill>
                   <a:srgbClr val="475569"/>
                 </a:solidFill>
@@ -5748,9 +6620,9 @@
           <a:p>
             <a:pPr>
               <a:spcBef>
-                <a:spcPts val="600"/>
+                <a:spcPts val="500"/>
               </a:spcBef>
-              <a:defRPr sz="950" b="1">
+              <a:defRPr sz="900" b="1">
                 <a:solidFill>
                   <a:srgbClr val="0F2C59"/>
                 </a:solidFill>
@@ -5762,7 +6634,7 @@
           </a:p>
           <a:p>
             <a:pPr>
-              <a:defRPr sz="850">
+              <a:defRPr sz="800">
                 <a:solidFill>
                   <a:srgbClr val="475569"/>
                 </a:solidFill>
@@ -5775,9 +6647,9 @@
           <a:p>
             <a:pPr>
               <a:spcBef>
-                <a:spcPts val="600"/>
+                <a:spcPts val="500"/>
               </a:spcBef>
-              <a:defRPr sz="950" b="1">
+              <a:defRPr sz="900" b="1">
                 <a:solidFill>
                   <a:srgbClr val="0F2C59"/>
                 </a:solidFill>
@@ -5789,7 +6661,7 @@
           </a:p>
           <a:p>
             <a:pPr>
-              <a:defRPr sz="850">
+              <a:defRPr sz="800">
                 <a:solidFill>
                   <a:srgbClr val="475569"/>
                 </a:solidFill>
@@ -5799,11 +6671,38 @@
               <a:t>    For mandatory NIOSH labor halt (11 AM–4 PM) compliance.</a:t>
             </a:r>
           </a:p>
-        </p:txBody>
-      </p:sp>
-      <p:sp>
-        <p:nvSpPr>
-          <p:cNvPr id="13" name="Rectangle 12"/>
+          <a:p>
+            <a:pPr>
+              <a:spcBef>
+                <a:spcPts val="500"/>
+              </a:spcBef>
+              <a:defRPr sz="900" b="1">
+                <a:solidFill>
+                  <a:srgbClr val="0F2C59"/>
+                </a:solidFill>
+              </a:defRPr>
+            </a:pPr>
+            <a:r>
+              <a:t>➢  DISCOMs &amp; Power Utilities</a:t>
+            </a:r>
+          </a:p>
+          <a:p>
+            <a:pPr>
+              <a:defRPr sz="800">
+                <a:solidFill>
+                  <a:srgbClr val="475569"/>
+                </a:solidFill>
+              </a:defRPr>
+            </a:pPr>
+            <a:r>
+              <a:t>    For predictive grid load planning during peak cooling demand.</a:t>
+            </a:r>
+          </a:p>
+        </p:txBody>
+      </p:sp>
+      <p:sp>
+        <p:nvSpPr>
+          <p:cNvPr id="14" name="Rectangle 13"/>
           <p:cNvSpPr/>
           <p:nvPr/>
         </p:nvSpPr>
@@ -5846,7 +6745,7 @@
       </p:sp>
       <p:sp>
         <p:nvSpPr>
-          <p:cNvPr id="14" name="TextBox 13"/>
+          <p:cNvPr id="15" name="TextBox 14"/>
           <p:cNvSpPr txBox="1"/>
           <p:nvPr/>
         </p:nvSpPr>
@@ -5882,7 +6781,7 @@
       </p:sp>
       <p:sp>
         <p:nvSpPr>
-          <p:cNvPr id="15" name="TextBox 14"/>
+          <p:cNvPr id="16" name="TextBox 15"/>
           <p:cNvSpPr txBox="1"/>
           <p:nvPr/>
         </p:nvSpPr>
@@ -5949,7 +6848,7 @@
         </p:nvSpPr>
         <p:spPr>
           <a:xfrm>
-            <a:off x="548640" y="228600"/>
+            <a:off x="548640" y="182880"/>
             <a:ext cx="2011680" cy="502920"/>
           </a:xfrm>
           <a:prstGeom prst="roundRect">
@@ -5987,6 +6886,7 @@
                 <a:solidFill>
                   <a:srgbClr val="6D28D9"/>
                 </a:solidFill>
+                <a:latin typeface="Arial"/>
               </a:defRPr>
             </a:pPr>
             <a:r>
@@ -6003,8 +6903,8 @@
         </p:nvSpPr>
         <p:spPr>
           <a:xfrm>
-            <a:off x="2743200" y="182880"/>
-            <a:ext cx="6705295" cy="594360"/>
+            <a:off x="2651760" y="164592"/>
+            <a:ext cx="6858000" cy="548640"/>
           </a:xfrm>
           <a:prstGeom prst="rect">
             <a:avLst/>
@@ -6018,7 +6918,7 @@
           <a:lstStyle/>
           <a:p>
             <a:pPr algn="ctr">
-              <a:defRPr sz="1800" b="1">
+              <a:defRPr sz="1700" b="1">
                 <a:solidFill>
                   <a:srgbClr val="0F172A"/>
                 </a:solidFill>
@@ -6039,7 +6939,7 @@
         </p:nvSpPr>
         <p:spPr>
           <a:xfrm>
-            <a:off x="9601200" y="182880"/>
+            <a:off x="9601200" y="137160"/>
             <a:ext cx="2011680" cy="594360"/>
           </a:xfrm>
           <a:prstGeom prst="roundRect">
@@ -6077,6 +6977,7 @@
                 <a:solidFill>
                   <a:srgbClr val="0F2C59"/>
                 </a:solidFill>
+                <a:latin typeface="Arial"/>
               </a:defRPr>
             </a:pPr>
             <a:r>
@@ -6089,6 +6990,7 @@
                 <a:solidFill>
                   <a:srgbClr val="EA580C"/>
                 </a:solidFill>
+                <a:latin typeface="Arial"/>
               </a:defRPr>
             </a:pPr>
             <a:r>
@@ -6105,8 +7007,8 @@
         </p:nvSpPr>
         <p:spPr>
           <a:xfrm>
-            <a:off x="731520" y="1005840"/>
-            <a:ext cx="10728655" cy="731520"/>
+            <a:off x="731520" y="868680"/>
+            <a:ext cx="10728655" cy="685800"/>
           </a:xfrm>
           <a:prstGeom prst="rect">
             <a:avLst/>
@@ -6135,7 +7037,7 @@
               <a:spcBef>
                 <a:spcPts val="200"/>
               </a:spcBef>
-              <a:defRPr sz="900">
+              <a:defRPr sz="850">
                 <a:solidFill>
                   <a:srgbClr val="475569"/>
                 </a:solidFill>
@@ -6155,8 +7057,8 @@
         </p:nvSpPr>
         <p:spPr>
           <a:xfrm>
-            <a:off x="731520" y="1737360"/>
-            <a:ext cx="10728655" cy="1188720"/>
+            <a:off x="731520" y="1600200"/>
+            <a:ext cx="10728655" cy="1280160"/>
           </a:xfrm>
           <a:prstGeom prst="roundRect">
             <a:avLst/>
@@ -6211,7 +7113,7 @@
               </a:defRPr>
             </a:pPr>
             <a:r>
-              <a:t>• 120h (D-5): NWP model flags thermal moisture surge → Early municipal advisory issued</a:t>
+              <a:t>• 120h (D-5): NWP model flags thermal moisture surge → Early municipal advisory &amp; DISCOM grid warnings issued</a:t>
             </a:r>
             <a:br/>
             <a:r>
@@ -6219,7 +7121,7 @@
             </a:r>
             <a:br/>
             <a:r>
-              <a:t>• 48h (D-2): Hospital surge beds &amp; ice-bath cooling centers staged; DISCOMs alerted for grid peak load</a:t>
+              <a:t>• 48h (D-2): Hospital surge beds &amp; ice-bath cooling centers staged; emergency ORS supplies prepositioned</a:t>
             </a:r>
             <a:br/>
             <a:r>
@@ -6236,8 +7138,8 @@
         </p:nvSpPr>
         <p:spPr>
           <a:xfrm>
-            <a:off x="731520" y="3063240"/>
-            <a:ext cx="3429000" cy="3246120"/>
+            <a:off x="731520" y="2971800"/>
+            <a:ext cx="3429000" cy="3383280"/>
           </a:xfrm>
           <a:prstGeom prst="roundRect">
             <a:avLst/>
@@ -6285,7 +7187,7 @@
               <a:spcBef>
                 <a:spcPts val="400"/>
               </a:spcBef>
-              <a:defRPr sz="900" b="1">
+              <a:defRPr sz="850" b="1">
                 <a:solidFill>
                   <a:srgbClr val="0F2C59"/>
                 </a:solidFill>
@@ -6300,7 +7202,7 @@
                   <a:srgbClr val="0F172A"/>
                 </a:solidFill>
               </a:rPr>
-              <a:t>Dramatically reduces heatstroke morbidity among elderly and children.</a:t>
+              <a:t>Dramatically reduces heatstroke morbidity among elderly, children, and chronic disease patients.</a:t>
             </a:r>
           </a:p>
           <a:p>
@@ -6308,7 +7210,7 @@
               <a:spcBef>
                 <a:spcPts val="400"/>
               </a:spcBef>
-              <a:defRPr sz="900" b="1">
+              <a:defRPr sz="850" b="1">
                 <a:solidFill>
                   <a:srgbClr val="0F2C59"/>
                 </a:solidFill>
@@ -6331,7 +7233,7 @@
               <a:spcBef>
                 <a:spcPts val="400"/>
               </a:spcBef>
-              <a:defRPr sz="900" b="1">
+              <a:defRPr sz="850" b="1">
                 <a:solidFill>
                   <a:srgbClr val="0F2C59"/>
                 </a:solidFill>
@@ -6346,7 +7248,7 @@
                   <a:srgbClr val="0F172A"/>
                 </a:solidFill>
               </a:rPr>
-              <a:t>Delivers plain-language vernacular guidance via SMS/WhatsApp.</a:t>
+              <a:t>Delivers plain-language vernacular guidance via SMS/WhatsApp to eliminate technical barriers.</a:t>
             </a:r>
           </a:p>
         </p:txBody>
@@ -6359,8 +7261,8 @@
         </p:nvSpPr>
         <p:spPr>
           <a:xfrm>
-            <a:off x="4379976" y="3063240"/>
-            <a:ext cx="3429000" cy="3246120"/>
+            <a:off x="4379976" y="2971800"/>
+            <a:ext cx="3429000" cy="3383280"/>
           </a:xfrm>
           <a:prstGeom prst="roundRect">
             <a:avLst/>
@@ -6408,7 +7310,7 @@
               <a:spcBef>
                 <a:spcPts val="400"/>
               </a:spcBef>
-              <a:defRPr sz="900" b="1">
+              <a:defRPr sz="850" b="1">
                 <a:solidFill>
                   <a:srgbClr val="0F2C59"/>
                 </a:solidFill>
@@ -6423,7 +7325,7 @@
                   <a:srgbClr val="0F172A"/>
                 </a:solidFill>
               </a:rPr>
-              <a:t>Reduces lost work hours through scheduled morning/evening shifts.</a:t>
+              <a:t>Mitigates lost labor hours through scheduled morning/evening shifts ($3.8B/yr India heat loss).</a:t>
             </a:r>
           </a:p>
           <a:p>
@@ -6431,14 +7333,14 @@
               <a:spcBef>
                 <a:spcPts val="400"/>
               </a:spcBef>
-              <a:defRPr sz="900" b="1">
+              <a:defRPr sz="850" b="1">
                 <a:solidFill>
                   <a:srgbClr val="0F2C59"/>
                 </a:solidFill>
               </a:defRPr>
             </a:pPr>
             <a:r>
-              <a:t>▪  Optimized Resource Routing: </a:t>
+              <a:t>▪  Optimized Relief Routing: </a:t>
             </a:r>
             <a:r>
               <a:rPr b="0">
@@ -6446,7 +7348,7 @@
                   <a:srgbClr val="0F172A"/>
                 </a:solidFill>
               </a:rPr>
-              <a:t>Avoids wasteful blanket relief by targeting high-vulnerability wards.</a:t>
+              <a:t>Avoids wasteful blanket relief by targeting water tankers to high-vulnerability wards.</a:t>
             </a:r>
           </a:p>
           <a:p>
@@ -6454,7 +7356,7 @@
               <a:spcBef>
                 <a:spcPts val="400"/>
               </a:spcBef>
-              <a:defRPr sz="900" b="1">
+              <a:defRPr sz="850" b="1">
                 <a:solidFill>
                   <a:srgbClr val="0F2C59"/>
                 </a:solidFill>
@@ -6469,7 +7371,7 @@
                   <a:srgbClr val="0F172A"/>
                 </a:solidFill>
               </a:rPr>
-              <a:t>Pre-empts severe multi-organ failure and ICU admissions.</a:t>
+              <a:t>Pre-empts severe multi-organ failure and ICU hospitalization surges.</a:t>
             </a:r>
           </a:p>
         </p:txBody>
@@ -6482,8 +7384,8 @@
         </p:nvSpPr>
         <p:spPr>
           <a:xfrm>
-            <a:off x="8028432" y="3063240"/>
-            <a:ext cx="3429000" cy="3246120"/>
+            <a:off x="8028432" y="2971800"/>
+            <a:ext cx="3429000" cy="3383280"/>
           </a:xfrm>
           <a:prstGeom prst="roundRect">
             <a:avLst/>
@@ -6531,7 +7433,7 @@
               <a:spcBef>
                 <a:spcPts val="400"/>
               </a:spcBef>
-              <a:defRPr sz="900" b="1">
+              <a:defRPr sz="850" b="1">
                 <a:solidFill>
                   <a:srgbClr val="0F2C59"/>
                 </a:solidFill>
@@ -6554,7 +7456,7 @@
               <a:spcBef>
                 <a:spcPts val="400"/>
               </a:spcBef>
-              <a:defRPr sz="900" b="1">
+              <a:defRPr sz="850" b="1">
                 <a:solidFill>
                   <a:srgbClr val="0F2C59"/>
                 </a:solidFill>
@@ -6569,7 +7471,7 @@
                   <a:srgbClr val="0F172A"/>
                 </a:solidFill>
               </a:rPr>
-              <a:t>Guides long-term cool roof installations and tree canopy targets.</a:t>
+              <a:t>Guides long-term municipal cool roof installations and tree planting programs.</a:t>
             </a:r>
           </a:p>
           <a:p>
@@ -6577,7 +7479,7 @@
               <a:spcBef>
                 <a:spcPts val="400"/>
               </a:spcBef>
-              <a:defRPr sz="900" b="1">
+              <a:defRPr sz="850" b="1">
                 <a:solidFill>
                   <a:srgbClr val="0F2C59"/>
                 </a:solidFill>
@@ -6745,7 +7647,7 @@
         </p:nvSpPr>
         <p:spPr>
           <a:xfrm>
-            <a:off x="548640" y="228600"/>
+            <a:off x="548640" y="182880"/>
             <a:ext cx="2011680" cy="502920"/>
           </a:xfrm>
           <a:prstGeom prst="roundRect">
@@ -6783,6 +7685,7 @@
                 <a:solidFill>
                   <a:srgbClr val="6D28D9"/>
                 </a:solidFill>
+                <a:latin typeface="Arial"/>
               </a:defRPr>
             </a:pPr>
             <a:r>
@@ -6799,8 +7702,8 @@
         </p:nvSpPr>
         <p:spPr>
           <a:xfrm>
-            <a:off x="2743200" y="182880"/>
-            <a:ext cx="6705295" cy="594360"/>
+            <a:off x="2651760" y="164592"/>
+            <a:ext cx="6858000" cy="548640"/>
           </a:xfrm>
           <a:prstGeom prst="rect">
             <a:avLst/>
@@ -6814,7 +7717,7 @@
           <a:lstStyle/>
           <a:p>
             <a:pPr algn="ctr">
-              <a:defRPr sz="1800" b="1">
+              <a:defRPr sz="1700" b="1">
                 <a:solidFill>
                   <a:srgbClr val="0F172A"/>
                 </a:solidFill>
@@ -6835,7 +7738,7 @@
         </p:nvSpPr>
         <p:spPr>
           <a:xfrm>
-            <a:off x="9601200" y="182880"/>
+            <a:off x="9601200" y="137160"/>
             <a:ext cx="2011680" cy="594360"/>
           </a:xfrm>
           <a:prstGeom prst="roundRect">
@@ -6873,6 +7776,7 @@
                 <a:solidFill>
                   <a:srgbClr val="0F2C59"/>
                 </a:solidFill>
+                <a:latin typeface="Arial"/>
               </a:defRPr>
             </a:pPr>
             <a:r>
@@ -6885,6 +7789,7 @@
                 <a:solidFill>
                   <a:srgbClr val="EA580C"/>
                 </a:solidFill>
+                <a:latin typeface="Arial"/>
               </a:defRPr>
             </a:pPr>
             <a:r>
@@ -6901,8 +7806,8 @@
         </p:nvSpPr>
         <p:spPr>
           <a:xfrm>
-            <a:off x="731520" y="1051560"/>
-            <a:ext cx="10728655" cy="5212080"/>
+            <a:off x="731520" y="914400"/>
+            <a:ext cx="10728655" cy="5394960"/>
           </a:xfrm>
           <a:prstGeom prst="rect">
             <a:avLst/>
@@ -6917,7 +7822,7 @@
           <a:p>
             <a:pPr>
               <a:spcBef>
-                <a:spcPts val="400"/>
+                <a:spcPts val="350"/>
               </a:spcBef>
               <a:defRPr sz="950" b="1">
                 <a:solidFill>
@@ -6940,7 +7845,7 @@
           <a:p>
             <a:pPr>
               <a:spcBef>
-                <a:spcPts val="400"/>
+                <a:spcPts val="350"/>
               </a:spcBef>
               <a:defRPr sz="950" b="1">
                 <a:solidFill>
@@ -6963,7 +7868,7 @@
           <a:p>
             <a:pPr>
               <a:spcBef>
-                <a:spcPts val="400"/>
+                <a:spcPts val="350"/>
               </a:spcBef>
               <a:defRPr sz="950" b="1">
                 <a:solidFill>
@@ -6986,7 +7891,7 @@
           <a:p>
             <a:pPr>
               <a:spcBef>
-                <a:spcPts val="400"/>
+                <a:spcPts val="350"/>
               </a:spcBef>
               <a:defRPr sz="950" b="1">
                 <a:solidFill>
@@ -7009,7 +7914,7 @@
           <a:p>
             <a:pPr>
               <a:spcBef>
-                <a:spcPts val="400"/>
+                <a:spcPts val="350"/>
               </a:spcBef>
               <a:defRPr sz="950" b="1">
                 <a:solidFill>
@@ -7032,7 +7937,7 @@
           <a:p>
             <a:pPr>
               <a:spcBef>
-                <a:spcPts val="400"/>
+                <a:spcPts val="350"/>
               </a:spcBef>
               <a:defRPr sz="950" b="1">
                 <a:solidFill>
@@ -7055,7 +7960,7 @@
           <a:p>
             <a:pPr>
               <a:spcBef>
-                <a:spcPts val="400"/>
+                <a:spcPts val="350"/>
               </a:spcBef>
               <a:defRPr sz="950" b="1">
                 <a:solidFill>
@@ -7078,7 +7983,7 @@
           <a:p>
             <a:pPr>
               <a:spcBef>
-                <a:spcPts val="400"/>
+                <a:spcPts val="350"/>
               </a:spcBef>
               <a:defRPr sz="950" b="1">
                 <a:solidFill>

</xml_diff>

<commit_message>
docs: generate deck matching exact official SIH2025/2026 idea presentation template format
</commit_message>
<xml_diff>
--- a/docs/sih/SIH2026_IDEA_Presentation_SIH26083_Official.pptx
+++ b/docs/sih/SIH2026_IDEA_Presentation_SIH26083_Official.pptx
@@ -3110,7 +3110,7 @@
         <p:spPr>
           <a:xfrm>
             <a:off x="731520" y="320040"/>
-            <a:ext cx="8686800" cy="548640"/>
+            <a:ext cx="8961120" cy="548640"/>
           </a:xfrm>
           <a:prstGeom prst="rect">
             <a:avLst/>
@@ -3126,9 +3126,9 @@
             <a:pPr>
               <a:defRPr sz="2600" b="1">
                 <a:solidFill>
-                  <a:srgbClr val="0F2C59"/>
-                </a:solidFill>
-                <a:latin typeface="Georgia"/>
+                  <a:srgbClr val="1D4E89"/>
+                </a:solidFill>
+                <a:latin typeface="Times New Roman"/>
               </a:defRPr>
             </a:pPr>
             <a:r>
@@ -3137,72 +3137,30 @@
           </a:p>
         </p:txBody>
       </p:sp>
-      <p:sp>
-        <p:nvSpPr>
-          <p:cNvPr id="3" name="Rounded Rectangle 2"/>
-          <p:cNvSpPr/>
+      <p:pic>
+        <p:nvPicPr>
+          <p:cNvPr id="3" name="Picture 2" descr="sih_logo_extracted.png"/>
+          <p:cNvPicPr>
+            <a:picLocks noChangeAspect="1"/>
+          </p:cNvPicPr>
           <p:nvPr/>
-        </p:nvSpPr>
-        <p:spPr>
-          <a:xfrm>
-            <a:off x="9601200" y="274320"/>
-            <a:ext cx="2011680" cy="731520"/>
-          </a:xfrm>
-          <a:prstGeom prst="roundRect">
-            <a:avLst/>
-          </a:prstGeom>
-          <a:solidFill>
-            <a:srgbClr val="FEF3C7"/>
-          </a:solidFill>
-          <a:ln w="19050">
-            <a:solidFill>
-              <a:srgbClr val="EA580C"/>
-            </a:solidFill>
-          </a:ln>
-        </p:spPr>
-        <p:style>
-          <a:lnRef idx="1">
-            <a:schemeClr val="accent1"/>
-          </a:lnRef>
-          <a:fillRef idx="3">
-            <a:schemeClr val="accent1"/>
-          </a:fillRef>
-          <a:effectRef idx="2">
-            <a:schemeClr val="accent1"/>
-          </a:effectRef>
-          <a:fontRef idx="minor">
-            <a:schemeClr val="lt1"/>
-          </a:fontRef>
-        </p:style>
-        <p:txBody>
-          <a:bodyPr rtlCol="0" anchor="ctr"/>
-          <a:lstStyle/>
-          <a:p>
-            <a:pPr algn="ctr">
-              <a:defRPr sz="1100" b="1">
-                <a:solidFill>
-                  <a:srgbClr val="0F2C59"/>
-                </a:solidFill>
-              </a:defRPr>
-            </a:pPr>
-            <a:r>
-              <a:t>SMART INDIA</a:t>
-            </a:r>
-          </a:p>
-          <a:p>
-            <a:pPr algn="ctr">
-              <a:defRPr sz="1100" b="1">
-                <a:solidFill>
-                  <a:srgbClr val="EA580C"/>
-                </a:solidFill>
-              </a:defRPr>
-            </a:pPr>
-            <a:r>
-              <a:t>HACKATHON 2026</a:t>
-            </a:r>
-          </a:p>
-        </p:txBody>
-      </p:sp>
+        </p:nvPicPr>
+        <p:blipFill>
+          <a:blip r:embed="rId2"/>
+          <a:stretch>
+            <a:fillRect/>
+          </a:stretch>
+        </p:blipFill>
+        <p:spPr>
+          <a:xfrm>
+            <a:off x="9875520" y="228600"/>
+            <a:ext cx="1920240" cy="722376"/>
+          </a:xfrm>
+          <a:prstGeom prst="rect">
+            <a:avLst/>
+          </a:prstGeom>
+        </p:spPr>
+      </p:pic>
       <p:sp>
         <p:nvSpPr>
           <p:cNvPr id="4" name="TextBox 3"/>
@@ -3211,8 +3169,8 @@
         </p:nvSpPr>
         <p:spPr>
           <a:xfrm>
-            <a:off x="731520" y="1051560"/>
-            <a:ext cx="10728655" cy="731520"/>
+            <a:off x="731520" y="1005840"/>
+            <a:ext cx="10728655" cy="457200"/>
           </a:xfrm>
           <a:prstGeom prst="rect">
             <a:avLst/>
@@ -3225,30 +3183,54 @@
           </a:bodyPr>
           <a:lstStyle/>
           <a:p>
-            <a:pPr>
-              <a:defRPr sz="2200" b="1">
-                <a:solidFill>
-                  <a:srgbClr val="0F172A"/>
-                </a:solidFill>
-                <a:latin typeface="Georgia"/>
-              </a:defRPr>
-            </a:pPr>
-            <a:r>
-              <a:t>ThermoShield — AI-Driven Human Heat Risk &amp; Early Warning System</a:t>
-            </a:r>
-          </a:p>
-        </p:txBody>
-      </p:sp>
-      <p:sp>
-        <p:nvSpPr>
-          <p:cNvPr id="5" name="TextBox 4"/>
+            <a:pPr algn="ctr">
+              <a:defRPr sz="1600" b="1">
+                <a:solidFill>
+                  <a:srgbClr val="000000"/>
+                </a:solidFill>
+                <a:latin typeface="Times New Roman"/>
+              </a:defRPr>
+            </a:pPr>
+            <a:r>
+              <a:t>TITLE PAGE</a:t>
+            </a:r>
+          </a:p>
+        </p:txBody>
+      </p:sp>
+      <p:pic>
+        <p:nvPicPr>
+          <p:cNvPr id="5" name="Picture 4" descr="sih_hex_graphic.png"/>
+          <p:cNvPicPr>
+            <a:picLocks noChangeAspect="1"/>
+          </p:cNvPicPr>
+          <p:nvPr/>
+        </p:nvPicPr>
+        <p:blipFill>
+          <a:blip r:embed="rId3"/>
+          <a:stretch>
+            <a:fillRect/>
+          </a:stretch>
+        </p:blipFill>
+        <p:spPr>
+          <a:xfrm>
+            <a:off x="7132320" y="1554480"/>
+            <a:ext cx="4480560" cy="4910930"/>
+          </a:xfrm>
+          <a:prstGeom prst="rect">
+            <a:avLst/>
+          </a:prstGeom>
+        </p:spPr>
+      </p:pic>
+      <p:sp>
+        <p:nvSpPr>
+          <p:cNvPr id="6" name="TextBox 5"/>
           <p:cNvSpPr txBox="1"/>
           <p:nvPr/>
         </p:nvSpPr>
         <p:spPr>
           <a:xfrm>
-            <a:off x="731520" y="1874519"/>
-            <a:ext cx="6217920" cy="4389120"/>
+            <a:off x="731520" y="1645920"/>
+            <a:ext cx="6217920" cy="4572000"/>
           </a:xfrm>
           <a:prstGeom prst="rect">
             <a:avLst/>
@@ -3262,9 +3244,9 @@
           <a:lstStyle/>
           <a:p>
             <a:pPr>
-              <a:defRPr sz="1150" b="1" u="sng">
-                <a:solidFill>
-                  <a:srgbClr val="0F172A"/>
+              <a:defRPr sz="1200" b="1">
+                <a:solidFill>
+                  <a:srgbClr val="000000"/>
                 </a:solidFill>
                 <a:latin typeface="Arial"/>
               </a:defRPr>
@@ -3273,9 +3255,9 @@
               <a:t>• Problem Statement ID – </a:t>
             </a:r>
             <a:r>
-              <a:rPr b="0" u="none">
-                <a:solidFill>
-                  <a:srgbClr val="0F2C59"/>
+              <a:rPr b="0">
+                <a:solidFill>
+                  <a:srgbClr val="1D4E89"/>
                 </a:solidFill>
               </a:rPr>
               <a:t>SIH26083</a:t>
@@ -3284,22 +3266,22 @@
           <a:p>
             <a:pPr>
               <a:spcBef>
-                <a:spcPts val="700"/>
+                <a:spcPts val="800"/>
               </a:spcBef>
-              <a:defRPr sz="1150" b="1" u="sng">
-                <a:solidFill>
-                  <a:srgbClr val="0F172A"/>
+              <a:defRPr sz="1200" b="1">
+                <a:solidFill>
+                  <a:srgbClr val="000000"/>
                 </a:solidFill>
                 <a:latin typeface="Arial"/>
               </a:defRPr>
             </a:pPr>
             <a:r>
-              <a:t>• Problem Statement Title – </a:t>
-            </a:r>
-            <a:r>
-              <a:rPr b="0" u="none">
-                <a:solidFill>
-                  <a:srgbClr val="0F172A"/>
+              <a:t>• Problem Statement Title- </a:t>
+            </a:r>
+            <a:r>
+              <a:rPr b="0">
+                <a:solidFill>
+                  <a:srgbClr val="000000"/>
                 </a:solidFill>
               </a:rPr>
               <a:t>Extreme Heatwave Early Warning and Human Thermal Stress Index</a:t>
@@ -3308,22 +3290,22 @@
           <a:p>
             <a:pPr>
               <a:spcBef>
-                <a:spcPts val="700"/>
+                <a:spcPts val="800"/>
               </a:spcBef>
-              <a:defRPr sz="1150" b="1" u="sng">
-                <a:solidFill>
-                  <a:srgbClr val="0F172A"/>
+              <a:defRPr sz="1200" b="1">
+                <a:solidFill>
+                  <a:srgbClr val="000000"/>
                 </a:solidFill>
                 <a:latin typeface="Arial"/>
               </a:defRPr>
             </a:pPr>
             <a:r>
-              <a:t>• Theme – </a:t>
-            </a:r>
-            <a:r>
-              <a:rPr b="0" u="none">
-                <a:solidFill>
-                  <a:srgbClr val="0F172A"/>
+              <a:t>• Theme- </a:t>
+            </a:r>
+            <a:r>
+              <a:rPr b="0">
+                <a:solidFill>
+                  <a:srgbClr val="000000"/>
                 </a:solidFill>
               </a:rPr>
               <a:t>Disaster Management</a:t>
@@ -3332,22 +3314,22 @@
           <a:p>
             <a:pPr>
               <a:spcBef>
-                <a:spcPts val="700"/>
+                <a:spcPts val="800"/>
               </a:spcBef>
-              <a:defRPr sz="1150" b="1" u="sng">
-                <a:solidFill>
-                  <a:srgbClr val="0F172A"/>
+              <a:defRPr sz="1200" b="1">
+                <a:solidFill>
+                  <a:srgbClr val="000000"/>
                 </a:solidFill>
                 <a:latin typeface="Arial"/>
               </a:defRPr>
             </a:pPr>
             <a:r>
-              <a:t>• PS Category – </a:t>
-            </a:r>
-            <a:r>
-              <a:rPr b="0" u="none">
-                <a:solidFill>
-                  <a:srgbClr val="0F172A"/>
+              <a:t>• PS Category- </a:t>
+            </a:r>
+            <a:r>
+              <a:rPr b="0">
+                <a:solidFill>
+                  <a:srgbClr val="000000"/>
                 </a:solidFill>
               </a:rPr>
               <a:t>Software</a:t>
@@ -3356,22 +3338,22 @@
           <a:p>
             <a:pPr>
               <a:spcBef>
-                <a:spcPts val="700"/>
+                <a:spcPts val="800"/>
               </a:spcBef>
-              <a:defRPr sz="1150" b="1" u="sng">
-                <a:solidFill>
-                  <a:srgbClr val="0F172A"/>
+              <a:defRPr sz="1200" b="1">
+                <a:solidFill>
+                  <a:srgbClr val="000000"/>
                 </a:solidFill>
                 <a:latin typeface="Arial"/>
               </a:defRPr>
             </a:pPr>
             <a:r>
-              <a:t>• Organization – </a:t>
-            </a:r>
-            <a:r>
-              <a:rPr b="0" u="none">
-                <a:solidFill>
-                  <a:srgbClr val="0F172A"/>
+              <a:t>• Organization- </a:t>
+            </a:r>
+            <a:r>
+              <a:rPr b="0">
+                <a:solidFill>
+                  <a:srgbClr val="000000"/>
                 </a:solidFill>
               </a:rPr>
               <a:t>Ministry of Earth Sciences (MoES) / NCMRWF</a:t>
@@ -3380,22 +3362,22 @@
           <a:p>
             <a:pPr>
               <a:spcBef>
-                <a:spcPts val="700"/>
+                <a:spcPts val="800"/>
               </a:spcBef>
-              <a:defRPr sz="1150" b="1" u="sng">
-                <a:solidFill>
-                  <a:srgbClr val="0F172A"/>
+              <a:defRPr sz="1200" b="1">
+                <a:solidFill>
+                  <a:srgbClr val="000000"/>
                 </a:solidFill>
                 <a:latin typeface="Arial"/>
               </a:defRPr>
             </a:pPr>
             <a:r>
-              <a:t>• Team ID – </a:t>
-            </a:r>
-            <a:r>
-              <a:rPr b="0" u="none">
-                <a:solidFill>
-                  <a:srgbClr val="0F2C59"/>
+              <a:t>• Team ID- </a:t>
+            </a:r>
+            <a:r>
+              <a:rPr b="0">
+                <a:solidFill>
+                  <a:srgbClr val="1D4E89"/>
                 </a:solidFill>
               </a:rPr>
               <a:t>[YOUR REGISTERED TEAM ID]</a:t>
@@ -3404,39 +3386,39 @@
           <a:p>
             <a:pPr>
               <a:spcBef>
-                <a:spcPts val="700"/>
+                <a:spcPts val="800"/>
               </a:spcBef>
-              <a:defRPr sz="1150" b="1" u="sng">
-                <a:solidFill>
-                  <a:srgbClr val="0F172A"/>
+              <a:defRPr sz="1200" b="1">
+                <a:solidFill>
+                  <a:srgbClr val="000000"/>
                 </a:solidFill>
                 <a:latin typeface="Arial"/>
               </a:defRPr>
             </a:pPr>
             <a:r>
-              <a:t>• Team Name – </a:t>
-            </a:r>
-            <a:r>
-              <a:rPr b="0" u="none">
-                <a:solidFill>
-                  <a:srgbClr val="0F2C59"/>
+              <a:t>• Team Name (Registered on portal)- </a:t>
+            </a:r>
+            <a:r>
+              <a:rPr b="0">
+                <a:solidFill>
+                  <a:srgbClr val="1D4E89"/>
                 </a:solidFill>
               </a:rPr>
-              <a:t>[YOUR REGISTERED TEAM NAME]</a:t>
-            </a:r>
-          </a:p>
-        </p:txBody>
-      </p:sp>
-      <p:sp>
-        <p:nvSpPr>
-          <p:cNvPr id="6" name="Rounded Rectangle 5"/>
+              <a:t>ThermoShield</a:t>
+            </a:r>
+          </a:p>
+        </p:txBody>
+      </p:sp>
+      <p:sp>
+        <p:nvSpPr>
+          <p:cNvPr id="7" name="Rounded Rectangle 6"/>
           <p:cNvSpPr/>
           <p:nvPr/>
         </p:nvSpPr>
         <p:spPr>
           <a:xfrm>
-            <a:off x="7132320" y="1874519"/>
-            <a:ext cx="4480560" cy="4297680"/>
+            <a:off x="731520" y="5212080"/>
+            <a:ext cx="6035040" cy="1188720"/>
           </a:xfrm>
           <a:prstGeom prst="roundRect">
             <a:avLst/>
@@ -3469,243 +3451,33 @@
           <a:lstStyle/>
           <a:p>
             <a:pPr algn="ctr">
-              <a:defRPr sz="1200" b="1">
-                <a:solidFill>
-                  <a:srgbClr val="0F2C59"/>
-                </a:solidFill>
-              </a:defRPr>
-            </a:pPr>
-            <a:r>
-              <a:t>CORE SYSTEM CAPABILITIES</a:t>
+              <a:defRPr sz="1150" b="1">
+                <a:solidFill>
+                  <a:srgbClr val="1D4E89"/>
+                </a:solidFill>
+              </a:defRPr>
+            </a:pPr>
+            <a:r>
+              <a:t>PROPOSED SYSTEM: ThermoShield</a:t>
             </a:r>
           </a:p>
           <a:p>
             <a:pPr>
               <a:spcBef>
-                <a:spcPts val="600"/>
+                <a:spcPts val="200"/>
               </a:spcBef>
-              <a:defRPr sz="1000" b="1">
-                <a:solidFill>
-                  <a:srgbClr val="0F2C59"/>
-                </a:solidFill>
-              </a:defRPr>
-            </a:pPr>
-            <a:r>
-              <a:t>✓  From Weather to Health: </a:t>
-            </a:r>
-            <a:r>
-              <a:rPr b="0">
-                <a:solidFill>
-                  <a:srgbClr val="0F172A"/>
-                </a:solidFill>
-              </a:rPr>
-              <a:t>Translates raw atmospheric metrics into physiological human thermal stress.</a:t>
-            </a:r>
-          </a:p>
-          <a:p>
-            <a:pPr>
-              <a:spcBef>
-                <a:spcPts val="600"/>
-              </a:spcBef>
-              <a:defRPr sz="1000" b="1">
-                <a:solidFill>
-                  <a:srgbClr val="0F2C59"/>
-                </a:solidFill>
-              </a:defRPr>
-            </a:pPr>
-            <a:r>
-              <a:t>✓  Multi-Metric Engine: </a:t>
-            </a:r>
-            <a:r>
-              <a:rPr b="0">
-                <a:solidFill>
-                  <a:srgbClr val="0F172A"/>
-                </a:solidFill>
-              </a:rPr>
-              <a:t>Universal Thermal Climate Index (UTCI) + ISO 7243 WBGT + NOAA Heat Index.</a:t>
-            </a:r>
-          </a:p>
-          <a:p>
-            <a:pPr>
-              <a:spcBef>
-                <a:spcPts val="600"/>
-              </a:spcBef>
-              <a:defRPr sz="1000" b="1">
-                <a:solidFill>
-                  <a:srgbClr val="0F2C59"/>
-                </a:solidFill>
-              </a:defRPr>
-            </a:pPr>
-            <a:r>
-              <a:t>✓  Hyper-Local Ward GIS: </a:t>
-            </a:r>
-            <a:r>
-              <a:rPr b="0">
-                <a:solidFill>
-                  <a:srgbClr val="0F172A"/>
-                </a:solidFill>
-              </a:rPr>
-              <a:t>Census 2011 PCA demographic overlay (slums, elderly, gig workers).</a:t>
-            </a:r>
-          </a:p>
-          <a:p>
-            <a:pPr>
-              <a:spcBef>
-                <a:spcPts val="600"/>
-              </a:spcBef>
-              <a:defRPr sz="1000" b="1">
-                <a:solidFill>
-                  <a:srgbClr val="0F2C59"/>
-                </a:solidFill>
-              </a:defRPr>
-            </a:pPr>
-            <a:r>
-              <a:t>✓  Automated Triggers: </a:t>
-            </a:r>
-            <a:r>
-              <a:rPr b="0">
-                <a:solidFill>
-                  <a:srgbClr val="0F172A"/>
-                </a:solidFill>
-              </a:rPr>
-              <a:t>Bilingual NDMA playbooks, hospital cooling surge alerts &amp; NIOSH labor halts.</a:t>
-            </a:r>
-          </a:p>
-          <a:p>
-            <a:pPr>
-              <a:spcBef>
-                <a:spcPts val="600"/>
-              </a:spcBef>
-              <a:defRPr sz="1000" b="1">
-                <a:solidFill>
-                  <a:srgbClr val="0F2C59"/>
-                </a:solidFill>
-              </a:defRPr>
-            </a:pPr>
-            <a:r>
-              <a:t>✓  3–5 Day Lead Time: </a:t>
-            </a:r>
-            <a:r>
-              <a:rPr b="0">
-                <a:solidFill>
-                  <a:srgbClr val="0F172A"/>
-                </a:solidFill>
-              </a:rPr>
-              <a:t>Enables 72h–120h pre-emptive municipal water and emergency resource staging.</a:t>
-            </a:r>
-          </a:p>
-        </p:txBody>
-      </p:sp>
-      <p:sp>
-        <p:nvSpPr>
-          <p:cNvPr id="7" name="Rectangle 6"/>
-          <p:cNvSpPr/>
-          <p:nvPr/>
-        </p:nvSpPr>
-        <p:spPr>
-          <a:xfrm>
-            <a:off x="0" y="6446520"/>
-            <a:ext cx="12191695" cy="411480"/>
-          </a:xfrm>
-          <a:prstGeom prst="rect">
-            <a:avLst/>
-          </a:prstGeom>
-          <a:solidFill>
-            <a:srgbClr val="0F2C59"/>
-          </a:solidFill>
-          <a:ln>
-            <a:noFill/>
-          </a:ln>
-        </p:spPr>
-        <p:style>
-          <a:lnRef idx="1">
-            <a:schemeClr val="accent1"/>
-          </a:lnRef>
-          <a:fillRef idx="3">
-            <a:schemeClr val="accent1"/>
-          </a:fillRef>
-          <a:effectRef idx="2">
-            <a:schemeClr val="accent1"/>
-          </a:effectRef>
-          <a:fontRef idx="minor">
-            <a:schemeClr val="lt1"/>
-          </a:fontRef>
-        </p:style>
-        <p:txBody>
-          <a:bodyPr rtlCol="0" anchor="ctr"/>
-          <a:lstStyle/>
-          <a:p>
-            <a:pPr algn="ctr"/>
-          </a:p>
-        </p:txBody>
-      </p:sp>
-      <p:sp>
-        <p:nvSpPr>
-          <p:cNvPr id="8" name="TextBox 7"/>
-          <p:cNvSpPr txBox="1"/>
-          <p:nvPr/>
-        </p:nvSpPr>
-        <p:spPr>
-          <a:xfrm>
-            <a:off x="731520" y="6510528"/>
-            <a:ext cx="10728655" cy="320040"/>
-          </a:xfrm>
-          <a:prstGeom prst="rect">
-            <a:avLst/>
-          </a:prstGeom>
-          <a:noFill/>
-        </p:spPr>
-        <p:txBody>
-          <a:bodyPr wrap="none" lIns="0" tIns="0" rIns="0" bIns="0">
-            <a:spAutoFit/>
-          </a:bodyPr>
-          <a:lstStyle/>
-          <a:p>
-            <a:pPr algn="ctr">
-              <a:defRPr sz="1000">
-                <a:solidFill>
-                  <a:srgbClr val="FFFFFF"/>
-                </a:solidFill>
-                <a:latin typeface="Arial"/>
-              </a:defRPr>
-            </a:pPr>
-            <a:r>
-              <a:t>@SIH Idea submission- Template</a:t>
-            </a:r>
-          </a:p>
-        </p:txBody>
-      </p:sp>
-      <p:sp>
-        <p:nvSpPr>
-          <p:cNvPr id="9" name="TextBox 8"/>
-          <p:cNvSpPr txBox="1"/>
-          <p:nvPr/>
-        </p:nvSpPr>
-        <p:spPr>
-          <a:xfrm>
-            <a:off x="11155680" y="6510528"/>
-            <a:ext cx="731520" cy="320040"/>
-          </a:xfrm>
-          <a:prstGeom prst="rect">
-            <a:avLst/>
-          </a:prstGeom>
-          <a:noFill/>
-        </p:spPr>
-        <p:txBody>
-          <a:bodyPr wrap="none">
-            <a:spAutoFit/>
-          </a:bodyPr>
-          <a:lstStyle/>
-          <a:p>
-            <a:pPr algn="r">
-              <a:defRPr sz="1100" b="1">
-                <a:solidFill>
-                  <a:srgbClr val="FFFFFF"/>
-                </a:solidFill>
-              </a:defRPr>
-            </a:pPr>
-            <a:r>
-              <a:t>1</a:t>
+              <a:defRPr sz="950">
+                <a:solidFill>
+                  <a:srgbClr val="1E293B"/>
+                </a:solidFill>
+              </a:defRPr>
+            </a:pPr>
+            <a:r>
+              <a:t>AI-Driven Human Heat Risk &amp; Biometeorological Early Warning OS</a:t>
+            </a:r>
+            <a:br/>
+            <a:r>
+              <a:t>From Weather Forecasts → Physiological Thermal Stress → Hyper-Local Ward Action</a:t>
             </a:r>
           </a:p>
         </p:txBody>
@@ -3738,24 +3510,24 @@
       <p:grpSpPr/>
       <p:sp>
         <p:nvSpPr>
-          <p:cNvPr id="2" name="Rounded Rectangle 1"/>
+          <p:cNvPr id="2" name="Oval 1"/>
           <p:cNvSpPr/>
           <p:nvPr/>
         </p:nvSpPr>
         <p:spPr>
           <a:xfrm>
             <a:off x="548640" y="182880"/>
-            <a:ext cx="2011680" cy="502920"/>
-          </a:xfrm>
-          <a:prstGeom prst="roundRect">
+            <a:ext cx="1371600" cy="731520"/>
+          </a:xfrm>
+          <a:prstGeom prst="ellipse">
             <a:avLst/>
           </a:prstGeom>
           <a:solidFill>
-            <a:srgbClr val="F3E8FF"/>
+            <a:srgbClr val="FFFFFF"/>
           </a:solidFill>
           <a:ln w="19050">
             <a:solidFill>
-              <a:srgbClr val="6D28D9"/>
+              <a:srgbClr val="9333EA"/>
             </a:solidFill>
           </a:ln>
         </p:spPr>
@@ -3774,19 +3546,45 @@
           </a:fontRef>
         </p:style>
         <p:txBody>
-          <a:bodyPr rtlCol="0" anchor="ctr" wrap="none"/>
+          <a:bodyPr rtlCol="0" anchor="ctr" wrap="none" lIns="0" tIns="0" rIns="0" bIns="0"/>
           <a:lstStyle/>
           <a:p>
             <a:pPr algn="ctr">
-              <a:defRPr sz="1100" b="1">
-                <a:solidFill>
-                  <a:srgbClr val="6D28D9"/>
+              <a:defRPr sz="950" b="1">
+                <a:solidFill>
+                  <a:srgbClr val="000000"/>
                 </a:solidFill>
                 <a:latin typeface="Arial"/>
               </a:defRPr>
             </a:pPr>
             <a:r>
-              <a:t>ThermoShield</a:t>
+              <a:t>Team</a:t>
+            </a:r>
+          </a:p>
+          <a:p>
+            <a:pPr algn="ctr">
+              <a:defRPr sz="950" b="1">
+                <a:solidFill>
+                  <a:srgbClr val="000000"/>
+                </a:solidFill>
+                <a:latin typeface="Arial"/>
+              </a:defRPr>
+            </a:pPr>
+            <a:r>
+              <a:t>Thermo-</a:t>
+            </a:r>
+          </a:p>
+          <a:p>
+            <a:pPr algn="ctr">
+              <a:defRPr sz="950" b="1">
+                <a:solidFill>
+                  <a:srgbClr val="000000"/>
+                </a:solidFill>
+                <a:latin typeface="Arial"/>
+              </a:defRPr>
+            </a:pPr>
+            <a:r>
+              <a:t>Shield</a:t>
             </a:r>
           </a:p>
         </p:txBody>
@@ -3799,8 +3597,8 @@
         </p:nvSpPr>
         <p:spPr>
           <a:xfrm>
-            <a:off x="2651760" y="164592"/>
-            <a:ext cx="6858000" cy="548640"/>
+            <a:off x="2286000" y="228600"/>
+            <a:ext cx="7619695" cy="594360"/>
           </a:xfrm>
           <a:prstGeom prst="rect">
             <a:avLst/>
@@ -3814,97 +3612,89 @@
           <a:lstStyle/>
           <a:p>
             <a:pPr algn="ctr">
-              <a:defRPr sz="1700" b="1">
-                <a:solidFill>
-                  <a:srgbClr val="0F172A"/>
-                </a:solidFill>
-                <a:latin typeface="Georgia"/>
-              </a:defRPr>
-            </a:pPr>
-            <a:r>
-              <a:t>ThermoShield : AI-Driven Human Heat Risk &amp; Early Warning System</a:t>
-            </a:r>
-          </a:p>
-        </p:txBody>
-      </p:sp>
-      <p:sp>
-        <p:nvSpPr>
-          <p:cNvPr id="4" name="Rounded Rectangle 3"/>
+              <a:defRPr sz="1800" b="1">
+                <a:solidFill>
+                  <a:srgbClr val="000000"/>
+                </a:solidFill>
+                <a:latin typeface="Times New Roman"/>
+              </a:defRPr>
+            </a:pPr>
+            <a:r>
+              <a:t>IDEA TITLE: THERMOSHIELD — AI-DRIVEN HUMAN HEAT RISK OS</a:t>
+            </a:r>
+          </a:p>
+        </p:txBody>
+      </p:sp>
+      <p:pic>
+        <p:nvPicPr>
+          <p:cNvPr id="4" name="Picture 3" descr="sih_logo_extracted.png"/>
+          <p:cNvPicPr>
+            <a:picLocks noChangeAspect="1"/>
+          </p:cNvPicPr>
+          <p:nvPr/>
+        </p:nvPicPr>
+        <p:blipFill>
+          <a:blip r:embed="rId2"/>
+          <a:stretch>
+            <a:fillRect/>
+          </a:stretch>
+        </p:blipFill>
+        <p:spPr>
+          <a:xfrm>
+            <a:off x="9875520" y="164592"/>
+            <a:ext cx="1920240" cy="722376"/>
+          </a:xfrm>
+          <a:prstGeom prst="rect">
+            <a:avLst/>
+          </a:prstGeom>
+        </p:spPr>
+      </p:pic>
+      <p:sp>
+        <p:nvSpPr>
+          <p:cNvPr id="5" name="TextBox 4"/>
+          <p:cNvSpPr txBox="1"/>
+          <p:nvPr/>
+        </p:nvSpPr>
+        <p:spPr>
+          <a:xfrm>
+            <a:off x="731520" y="1051560"/>
+            <a:ext cx="10728655" cy="411480"/>
+          </a:xfrm>
+          <a:prstGeom prst="rect">
+            <a:avLst/>
+          </a:prstGeom>
+          <a:noFill/>
+        </p:spPr>
+        <p:txBody>
+          <a:bodyPr wrap="none" lIns="0" tIns="0" rIns="0" bIns="0">
+            <a:spAutoFit/>
+          </a:bodyPr>
+          <a:lstStyle/>
+          <a:p>
+            <a:pPr>
+              <a:defRPr sz="1200" b="1" u="sng">
+                <a:solidFill>
+                  <a:srgbClr val="1D4E89"/>
+                </a:solidFill>
+                <a:latin typeface="Arial"/>
+              </a:defRPr>
+            </a:pPr>
+            <a:r>
+              <a:t>❖  Proposed Solution (Describe your Idea/Solution/Prototype)</a:t>
+            </a:r>
+          </a:p>
+        </p:txBody>
+      </p:sp>
+      <p:sp>
+        <p:nvSpPr>
+          <p:cNvPr id="6" name="Rounded Rectangle 5"/>
           <p:cNvSpPr/>
           <p:nvPr/>
         </p:nvSpPr>
         <p:spPr>
           <a:xfrm>
-            <a:off x="9601200" y="137160"/>
-            <a:ext cx="2011680" cy="594360"/>
-          </a:xfrm>
-          <a:prstGeom prst="roundRect">
-            <a:avLst/>
-          </a:prstGeom>
-          <a:solidFill>
-            <a:srgbClr val="FEF3C7"/>
-          </a:solidFill>
-          <a:ln w="19050">
-            <a:solidFill>
-              <a:srgbClr val="EA580C"/>
-            </a:solidFill>
-          </a:ln>
-        </p:spPr>
-        <p:style>
-          <a:lnRef idx="1">
-            <a:schemeClr val="accent1"/>
-          </a:lnRef>
-          <a:fillRef idx="3">
-            <a:schemeClr val="accent1"/>
-          </a:fillRef>
-          <a:effectRef idx="2">
-            <a:schemeClr val="accent1"/>
-          </a:effectRef>
-          <a:fontRef idx="minor">
-            <a:schemeClr val="lt1"/>
-          </a:fontRef>
-        </p:style>
-        <p:txBody>
-          <a:bodyPr rtlCol="0" anchor="ctr"/>
-          <a:lstStyle/>
-          <a:p>
-            <a:pPr algn="ctr">
-              <a:defRPr sz="950" b="1">
-                <a:solidFill>
-                  <a:srgbClr val="0F2C59"/>
-                </a:solidFill>
-                <a:latin typeface="Arial"/>
-              </a:defRPr>
-            </a:pPr>
-            <a:r>
-              <a:t>SMART INDIA</a:t>
-            </a:r>
-          </a:p>
-          <a:p>
-            <a:pPr algn="ctr">
-              <a:defRPr sz="950" b="1">
-                <a:solidFill>
-                  <a:srgbClr val="EA580C"/>
-                </a:solidFill>
-                <a:latin typeface="Arial"/>
-              </a:defRPr>
-            </a:pPr>
-            <a:r>
-              <a:t>HACKATHON 2026</a:t>
-            </a:r>
-          </a:p>
-        </p:txBody>
-      </p:sp>
-      <p:sp>
-        <p:nvSpPr>
-          <p:cNvPr id="5" name="Rounded Rectangle 4"/>
-          <p:cNvSpPr/>
-          <p:nvPr/>
-        </p:nvSpPr>
-        <p:spPr>
-          <a:xfrm>
-            <a:off x="731520" y="960120"/>
-            <a:ext cx="3429000" cy="4892040"/>
+            <a:off x="731520" y="1508760"/>
+            <a:ext cx="3429000" cy="4297680"/>
           </a:xfrm>
           <a:prstGeom prst="roundRect">
             <a:avLst/>
@@ -3942,14 +3732,14 @@
       </p:sp>
       <p:sp>
         <p:nvSpPr>
-          <p:cNvPr id="6" name="Rounded Rectangle 5"/>
+          <p:cNvPr id="7" name="Rounded Rectangle 6"/>
           <p:cNvSpPr/>
           <p:nvPr/>
         </p:nvSpPr>
         <p:spPr>
           <a:xfrm>
-            <a:off x="804672" y="1051560"/>
-            <a:ext cx="3282696" cy="411480"/>
+            <a:off x="804672" y="1581912"/>
+            <a:ext cx="3282696" cy="384048"/>
           </a:xfrm>
           <a:prstGeom prst="roundRect">
             <a:avLst/>
@@ -3982,28 +3772,28 @@
           <a:lstStyle/>
           <a:p>
             <a:pPr algn="ctr">
-              <a:defRPr sz="1050" b="1">
-                <a:solidFill>
-                  <a:srgbClr val="0F2C59"/>
-                </a:solidFill>
-              </a:defRPr>
-            </a:pPr>
-            <a:r>
-              <a:t>1. Proposed Solution Architecture</a:t>
-            </a:r>
-          </a:p>
-        </p:txBody>
-      </p:sp>
-      <p:sp>
-        <p:nvSpPr>
-          <p:cNvPr id="7" name="TextBox 6"/>
+              <a:defRPr sz="1000" b="1">
+                <a:solidFill>
+                  <a:srgbClr val="1D4E89"/>
+                </a:solidFill>
+              </a:defRPr>
+            </a:pPr>
+            <a:r>
+              <a:t>• Detailed Explanation of the Solution</a:t>
+            </a:r>
+          </a:p>
+        </p:txBody>
+      </p:sp>
+      <p:sp>
+        <p:nvSpPr>
+          <p:cNvPr id="8" name="TextBox 7"/>
           <p:cNvSpPr txBox="1"/>
           <p:nvPr/>
         </p:nvSpPr>
         <p:spPr>
           <a:xfrm>
-            <a:off x="868680" y="1554480"/>
-            <a:ext cx="3154680" cy="4206240"/>
+            <a:off x="868680" y="2057400"/>
+            <a:ext cx="3154680" cy="3566160"/>
           </a:xfrm>
           <a:prstGeom prst="rect">
             <a:avLst/>
@@ -4017,9 +3807,9 @@
           <a:lstStyle/>
           <a:p>
             <a:pPr>
-              <a:defRPr sz="950" b="1">
-                <a:solidFill>
-                  <a:srgbClr val="0F2C59"/>
+              <a:defRPr sz="900" b="1">
+                <a:solidFill>
+                  <a:srgbClr val="1D4E89"/>
                 </a:solidFill>
               </a:defRPr>
             </a:pPr>
@@ -4029,10 +3819,10 @@
             <a:r>
               <a:rPr b="0">
                 <a:solidFill>
-                  <a:srgbClr val="0F172A"/>
+                  <a:srgbClr val="1E293B"/>
                 </a:solidFill>
               </a:rPr>
-              <a:t>Simultaneously processes 5-Day NWP forecasts (temperature, humidity, wind, radiation) and Census demographic vulnerability layers.</a:t>
+              <a:t>Fuses 5-Day hourly NWP forecasts (T, RH, Wind, Solar Radiation) with Census 2011 PCA ward demographics.</a:t>
             </a:r>
           </a:p>
           <a:p>
@@ -4040,9 +3830,9 @@
               <a:spcBef>
                 <a:spcPts val="400"/>
               </a:spcBef>
-              <a:defRPr sz="950" b="1">
-                <a:solidFill>
-                  <a:srgbClr val="0F2C59"/>
+              <a:defRPr sz="900" b="1">
+                <a:solidFill>
+                  <a:srgbClr val="1D4E89"/>
                 </a:solidFill>
               </a:defRPr>
             </a:pPr>
@@ -4052,10 +3842,10 @@
             <a:r>
               <a:rPr b="0">
                 <a:solidFill>
-                  <a:srgbClr val="0F172A"/>
+                  <a:srgbClr val="1E293B"/>
                 </a:solidFill>
               </a:rPr>
-              <a:t>6th-order polynomial based on Fiala 187-node human body model. Accurately calculates real sweat evaporation efficiency.</a:t>
+              <a:t>Universal Thermal Climate Index (6th-order polynomial based on Fiala 187-node human body model).</a:t>
             </a:r>
           </a:p>
           <a:p>
@@ -4063,9 +3853,9 @@
               <a:spcBef>
                 <a:spcPts val="400"/>
               </a:spcBef>
-              <a:defRPr sz="950" b="1">
-                <a:solidFill>
-                  <a:srgbClr val="0F2C59"/>
+              <a:defRPr sz="900" b="1">
+                <a:solidFill>
+                  <a:srgbClr val="1D4E89"/>
                 </a:solidFill>
               </a:defRPr>
             </a:pPr>
@@ -4075,10 +3865,10 @@
             <a:r>
               <a:rPr b="0">
                 <a:solidFill>
-                  <a:srgbClr val="0F172A"/>
+                  <a:srgbClr val="1E293B"/>
                 </a:solidFill>
               </a:rPr>
-              <a:t>Natural wet bulb (Stull) and globe temperature (Liljegren) for occupational and outdoor worker heat stress.</a:t>
+              <a:t>Natural wet bulb (Stull) and globe temperature (Liljegren) for occupational and outdoor labor heat stress.</a:t>
             </a:r>
           </a:p>
           <a:p>
@@ -4086,9 +3876,9 @@
               <a:spcBef>
                 <a:spcPts val="400"/>
               </a:spcBef>
-              <a:defRPr sz="950" b="1">
-                <a:solidFill>
-                  <a:srgbClr val="0F2C59"/>
+              <a:defRPr sz="900" b="1">
+                <a:solidFill>
+                  <a:srgbClr val="1D4E89"/>
                 </a:solidFill>
               </a:defRPr>
             </a:pPr>
@@ -4098,24 +3888,24 @@
             <a:r>
               <a:rPr b="0">
                 <a:solidFill>
-                  <a:srgbClr val="0F172A"/>
+                  <a:srgbClr val="1E293B"/>
                 </a:solidFill>
               </a:rPr>
-              <a:t>Applies exponential multiplier (Dmult) for prolonged heatwaves and uncooled night minimums (Tmin &gt; 28°C).</a:t>
-            </a:r>
-          </a:p>
-        </p:txBody>
-      </p:sp>
-      <p:sp>
-        <p:nvSpPr>
-          <p:cNvPr id="8" name="Rounded Rectangle 7"/>
+              <a:t>Applies exponential duration multiplier (Dmult) and uncooled night penalty (Tmin &gt; 28°C).</a:t>
+            </a:r>
+          </a:p>
+        </p:txBody>
+      </p:sp>
+      <p:sp>
+        <p:nvSpPr>
+          <p:cNvPr id="9" name="Rounded Rectangle 8"/>
           <p:cNvSpPr/>
           <p:nvPr/>
         </p:nvSpPr>
         <p:spPr>
           <a:xfrm>
-            <a:off x="4379976" y="960120"/>
-            <a:ext cx="3429000" cy="4892040"/>
+            <a:off x="4379976" y="1508760"/>
+            <a:ext cx="3429000" cy="4297680"/>
           </a:xfrm>
           <a:prstGeom prst="roundRect">
             <a:avLst/>
@@ -4153,14 +3943,14 @@
       </p:sp>
       <p:sp>
         <p:nvSpPr>
-          <p:cNvPr id="9" name="Rounded Rectangle 8"/>
+          <p:cNvPr id="10" name="Rounded Rectangle 9"/>
           <p:cNvSpPr/>
           <p:nvPr/>
         </p:nvSpPr>
         <p:spPr>
           <a:xfrm>
-            <a:off x="4453128" y="1051560"/>
-            <a:ext cx="3282696" cy="411480"/>
+            <a:off x="4453128" y="1581912"/>
+            <a:ext cx="3282696" cy="384048"/>
           </a:xfrm>
           <a:prstGeom prst="roundRect">
             <a:avLst/>
@@ -4193,28 +3983,28 @@
           <a:lstStyle/>
           <a:p>
             <a:pPr algn="ctr">
-              <a:defRPr sz="1050" b="1">
-                <a:solidFill>
-                  <a:srgbClr val="0F2C59"/>
-                </a:solidFill>
-              </a:defRPr>
-            </a:pPr>
-            <a:r>
-              <a:t>2. How It Addresses The Problem?</a:t>
-            </a:r>
-          </a:p>
-        </p:txBody>
-      </p:sp>
-      <p:sp>
-        <p:nvSpPr>
-          <p:cNvPr id="10" name="TextBox 9"/>
+              <a:defRPr sz="1000" b="1">
+                <a:solidFill>
+                  <a:srgbClr val="1D4E89"/>
+                </a:solidFill>
+              </a:defRPr>
+            </a:pPr>
+            <a:r>
+              <a:t>• How It Addresses the Problem</a:t>
+            </a:r>
+          </a:p>
+        </p:txBody>
+      </p:sp>
+      <p:sp>
+        <p:nvSpPr>
+          <p:cNvPr id="11" name="TextBox 10"/>
           <p:cNvSpPr txBox="1"/>
           <p:nvPr/>
         </p:nvSpPr>
         <p:spPr>
           <a:xfrm>
-            <a:off x="4517136" y="1554480"/>
-            <a:ext cx="3154680" cy="4206240"/>
+            <a:off x="4517136" y="2057400"/>
+            <a:ext cx="3154680" cy="3566160"/>
           </a:xfrm>
           <a:prstGeom prst="rect">
             <a:avLst/>
@@ -4228,22 +4018,22 @@
           <a:lstStyle/>
           <a:p>
             <a:pPr>
-              <a:defRPr sz="950" b="1">
-                <a:solidFill>
-                  <a:srgbClr val="0F2C59"/>
-                </a:solidFill>
-              </a:defRPr>
-            </a:pPr>
-            <a:r>
-              <a:t>❖  Weather vs Physiological Impact: </a:t>
+              <a:defRPr sz="900" b="1">
+                <a:solidFill>
+                  <a:srgbClr val="1D4E89"/>
+                </a:solidFill>
+              </a:defRPr>
+            </a:pPr>
+            <a:r>
+              <a:t>❖  Human Impact vs Raw Weather: </a:t>
             </a:r>
             <a:r>
               <a:rPr b="0">
                 <a:solidFill>
-                  <a:srgbClr val="0F172A"/>
+                  <a:srgbClr val="1E293B"/>
                 </a:solidFill>
               </a:rPr>
-              <a:t>Overcomes the critical limitation of dry-bulb warnings where 40°C with high humidity turns lethal.</a:t>
+              <a:t>Overcomes the deadly flaw of dry-bulb warnings where 40°C with high humidity breaks thermoregulation.</a:t>
             </a:r>
           </a:p>
           <a:p>
@@ -4251,22 +4041,22 @@
               <a:spcBef>
                 <a:spcPts val="400"/>
               </a:spcBef>
-              <a:defRPr sz="950" b="1">
-                <a:solidFill>
-                  <a:srgbClr val="0F2C59"/>
-                </a:solidFill>
-              </a:defRPr>
-            </a:pPr>
-            <a:r>
-              <a:t>❖  Hyper-Local Ward Stratification: </a:t>
+              <a:defRPr sz="900" b="1">
+                <a:solidFill>
+                  <a:srgbClr val="1D4E89"/>
+                </a:solidFill>
+              </a:defRPr>
+            </a:pPr>
+            <a:r>
+              <a:t>❖  Hyper-Local Ward Granularity: </a:t>
             </a:r>
             <a:r>
               <a:rPr b="0">
                 <a:solidFill>
-                  <a:srgbClr val="0F172A"/>
+                  <a:srgbClr val="1E293B"/>
                 </a:solidFill>
               </a:rPr>
-              <a:t>Differentiates shaded affluent residential zones from densely built informal settlements with tin roofs.</a:t>
+              <a:t>Differentiates shaded affluent residential areas from informal settlements with tin roofs and high worker density.</a:t>
             </a:r>
           </a:p>
           <a:p>
@@ -4274,9 +4064,9 @@
               <a:spcBef>
                 <a:spcPts val="400"/>
               </a:spcBef>
-              <a:defRPr sz="950" b="1">
-                <a:solidFill>
-                  <a:srgbClr val="0F2C59"/>
+              <a:defRPr sz="900" b="1">
+                <a:solidFill>
+                  <a:srgbClr val="1D4E89"/>
                 </a:solidFill>
               </a:defRPr>
             </a:pPr>
@@ -4286,10 +4076,10 @@
             <a:r>
               <a:rPr b="0">
                 <a:solidFill>
-                  <a:srgbClr val="0F172A"/>
+                  <a:srgbClr val="1E293B"/>
                 </a:solidFill>
               </a:rPr>
-              <a:t>Risk scoring calibrated against peer-reviewed Indian empirical studies (Azhar et al. 2014 &amp; Mazdiyasni et al. 2017).</a:t>
+              <a:t>Calibrated against Indian heat-mortality literature (Azhar et al. 2014 &amp; Mazdiyasni et al. 2017).</a:t>
             </a:r>
           </a:p>
           <a:p>
@@ -4297,36 +4087,36 @@
               <a:spcBef>
                 <a:spcPts val="400"/>
               </a:spcBef>
-              <a:defRPr sz="950" b="1">
-                <a:solidFill>
-                  <a:srgbClr val="0F2C59"/>
-                </a:solidFill>
-              </a:defRPr>
-            </a:pPr>
-            <a:r>
-              <a:t>❖  Automated Impact-to-Action: </a:t>
+              <a:defRPr sz="900" b="1">
+                <a:solidFill>
+                  <a:srgbClr val="1D4E89"/>
+                </a:solidFill>
+              </a:defRPr>
+            </a:pPr>
+            <a:r>
+              <a:t>❖  Relative Risk Indexing: </a:t>
             </a:r>
             <a:r>
               <a:rPr b="0">
                 <a:solidFill>
-                  <a:srgbClr val="0F172A"/>
+                  <a:srgbClr val="1E293B"/>
                 </a:solidFill>
               </a:rPr>
-              <a:t>Translates raw risk directly into automated NDMA advisories, hospital beds, and labor work-rest cycles.</a:t>
-            </a:r>
-          </a:p>
-        </p:txBody>
-      </p:sp>
-      <p:sp>
-        <p:nvSpPr>
-          <p:cNvPr id="11" name="Rounded Rectangle 10"/>
+              <a:t>Bounded 0–100 Human Heat-Health Risk Score replacing uncalibrated death claims.</a:t>
+            </a:r>
+          </a:p>
+        </p:txBody>
+      </p:sp>
+      <p:sp>
+        <p:nvSpPr>
+          <p:cNvPr id="12" name="Rounded Rectangle 11"/>
           <p:cNvSpPr/>
           <p:nvPr/>
         </p:nvSpPr>
         <p:spPr>
           <a:xfrm>
-            <a:off x="8028432" y="960120"/>
-            <a:ext cx="3429000" cy="4892040"/>
+            <a:off x="8028432" y="1508760"/>
+            <a:ext cx="3429000" cy="4297680"/>
           </a:xfrm>
           <a:prstGeom prst="roundRect">
             <a:avLst/>
@@ -4364,14 +4154,14 @@
       </p:sp>
       <p:sp>
         <p:nvSpPr>
-          <p:cNvPr id="12" name="Rounded Rectangle 11"/>
+          <p:cNvPr id="13" name="Rounded Rectangle 12"/>
           <p:cNvSpPr/>
           <p:nvPr/>
         </p:nvSpPr>
         <p:spPr>
           <a:xfrm>
-            <a:off x="8101584" y="1051560"/>
-            <a:ext cx="3282696" cy="411480"/>
+            <a:off x="8101584" y="1581912"/>
+            <a:ext cx="3282696" cy="384048"/>
           </a:xfrm>
           <a:prstGeom prst="roundRect">
             <a:avLst/>
@@ -4404,28 +4194,28 @@
           <a:lstStyle/>
           <a:p>
             <a:pPr algn="ctr">
-              <a:defRPr sz="1050" b="1">
-                <a:solidFill>
-                  <a:srgbClr val="0F2C59"/>
-                </a:solidFill>
-              </a:defRPr>
-            </a:pPr>
-            <a:r>
-              <a:t>3. Key Differentiators &amp; Impact</a:t>
-            </a:r>
-          </a:p>
-        </p:txBody>
-      </p:sp>
-      <p:sp>
-        <p:nvSpPr>
-          <p:cNvPr id="13" name="TextBox 12"/>
+              <a:defRPr sz="1000" b="1">
+                <a:solidFill>
+                  <a:srgbClr val="1D4E89"/>
+                </a:solidFill>
+              </a:defRPr>
+            </a:pPr>
+            <a:r>
+              <a:t>• Innovation and Uniqueness</a:t>
+            </a:r>
+          </a:p>
+        </p:txBody>
+      </p:sp>
+      <p:sp>
+        <p:nvSpPr>
+          <p:cNvPr id="14" name="TextBox 13"/>
           <p:cNvSpPr txBox="1"/>
           <p:nvPr/>
         </p:nvSpPr>
         <p:spPr>
           <a:xfrm>
-            <a:off x="8165592" y="1554480"/>
-            <a:ext cx="3154680" cy="4206240"/>
+            <a:off x="8165592" y="2057400"/>
+            <a:ext cx="3154680" cy="3566160"/>
           </a:xfrm>
           <a:prstGeom prst="rect">
             <a:avLst/>
@@ -4439,22 +4229,22 @@
           <a:lstStyle/>
           <a:p>
             <a:pPr>
-              <a:defRPr sz="950" b="1">
-                <a:solidFill>
-                  <a:srgbClr val="0F2C59"/>
-                </a:solidFill>
-              </a:defRPr>
-            </a:pPr>
-            <a:r>
-              <a:t>❖  3–5 Day Pre-Emptive Window: </a:t>
+              <a:defRPr sz="900" b="1">
+                <a:solidFill>
+                  <a:srgbClr val="1D4E89"/>
+                </a:solidFill>
+              </a:defRPr>
+            </a:pPr>
+            <a:r>
+              <a:t>❖  72h–120h Pre-Emptive Lead Time: </a:t>
             </a:r>
             <a:r>
               <a:rPr b="0">
                 <a:solidFill>
-                  <a:srgbClr val="0F172A"/>
+                  <a:srgbClr val="1E293B"/>
                 </a:solidFill>
               </a:rPr>
-              <a:t>Provides 72h–120h lead time for municipal water tanker routing and cooling shelter deployment.</a:t>
+              <a:t>3–5 day anticipation enabling municipal water tankers and cooling shelters to be prepositioned.</a:t>
             </a:r>
           </a:p>
           <a:p>
@@ -4462,22 +4252,22 @@
               <a:spcBef>
                 <a:spcPts val="400"/>
               </a:spcBef>
-              <a:defRPr sz="950" b="1">
-                <a:solidFill>
-                  <a:srgbClr val="0F2C59"/>
-                </a:solidFill>
-              </a:defRPr>
-            </a:pPr>
-            <a:r>
-              <a:t>❖  Sector-Specific Automation: </a:t>
+              <a:defRPr sz="900" b="1">
+                <a:solidFill>
+                  <a:srgbClr val="1D4E89"/>
+                </a:solidFill>
+              </a:defRPr>
+            </a:pPr>
+            <a:r>
+              <a:t>❖  Automated Multi-Sector Triggers: </a:t>
             </a:r>
             <a:r>
               <a:rPr b="0">
                 <a:solidFill>
-                  <a:srgbClr val="0F172A"/>
+                  <a:srgbClr val="1E293B"/>
                 </a:solidFill>
               </a:rPr>
-              <a:t>Delivers tailored feeds for gig delivery platforms (Zomato/Swiggy), construction, and DISCOMs.</a:t>
+              <a:t>Converts risk into hospital surge bed alerts, DISCOM load warnings, and NIOSH labor halts (11 AM–4 PM).</a:t>
             </a:r>
           </a:p>
           <a:p>
@@ -4485,22 +4275,22 @@
               <a:spcBef>
                 <a:spcPts val="400"/>
               </a:spcBef>
-              <a:defRPr sz="950" b="1">
-                <a:solidFill>
-                  <a:srgbClr val="0F2C59"/>
-                </a:solidFill>
-              </a:defRPr>
-            </a:pPr>
-            <a:r>
-              <a:t>❖  Bilingual Vernacular Alerts: </a:t>
+              <a:defRPr sz="900" b="1">
+                <a:solidFill>
+                  <a:srgbClr val="1D4E89"/>
+                </a:solidFill>
+              </a:defRPr>
+            </a:pPr>
+            <a:r>
+              <a:t>❖  Bilingual Public Advisories: </a:t>
             </a:r>
             <a:r>
               <a:rPr b="0">
                 <a:solidFill>
-                  <a:srgbClr val="0F172A"/>
+                  <a:srgbClr val="1E293B"/>
                 </a:solidFill>
               </a:rPr>
-              <a:t>Automated Hindi &amp; English public alerts sent via WhatsApp/Telegram to avoid technical jargon.</a:t>
+              <a:t>Plain-language vernacular WhatsApp/Telegram warnings in Hindi and English.</a:t>
             </a:r>
           </a:p>
           <a:p>
@@ -4508,9 +4298,9 @@
               <a:spcBef>
                 <a:spcPts val="400"/>
               </a:spcBef>
-              <a:defRPr sz="950" b="1">
-                <a:solidFill>
-                  <a:srgbClr val="0F2C59"/>
+              <a:defRPr sz="900" b="1">
+                <a:solidFill>
+                  <a:srgbClr val="1D4E89"/>
                 </a:solidFill>
               </a:defRPr>
             </a:pPr>
@@ -4520,17 +4310,17 @@
             <a:r>
               <a:rPr b="0">
                 <a:solidFill>
-                  <a:srgbClr val="0F172A"/>
+                  <a:srgbClr val="1E293B"/>
                 </a:solidFill>
               </a:rPr>
-              <a:t>25 production REST API endpoints with sub-second response times and zero licensing fees.</a:t>
-            </a:r>
-          </a:p>
-        </p:txBody>
-      </p:sp>
-      <p:sp>
-        <p:nvSpPr>
-          <p:cNvPr id="14" name="Rounded Rectangle 13"/>
+              <a:t>25 production REST APIs with sub-second latency and zero proprietary software licensing.</a:t>
+            </a:r>
+          </a:p>
+        </p:txBody>
+      </p:sp>
+      <p:sp>
+        <p:nvSpPr>
+          <p:cNvPr id="15" name="Rounded Rectangle 14"/>
           <p:cNvSpPr/>
           <p:nvPr/>
         </p:nvSpPr>
@@ -4572,7 +4362,7 @@
             <a:pPr algn="ctr">
               <a:defRPr sz="1000" b="1">
                 <a:solidFill>
-                  <a:srgbClr val="0F2C59"/>
+                  <a:srgbClr val="1D4E89"/>
                 </a:solidFill>
               </a:defRPr>
             </a:pPr>
@@ -4584,7 +4374,7 @@
       </p:sp>
       <p:sp>
         <p:nvSpPr>
-          <p:cNvPr id="15" name="Rectangle 14"/>
+          <p:cNvPr id="16" name="Rectangle 15"/>
           <p:cNvSpPr/>
           <p:nvPr/>
         </p:nvSpPr>
@@ -4597,7 +4387,7 @@
             <a:avLst/>
           </a:prstGeom>
           <a:solidFill>
-            <a:srgbClr val="0F2C59"/>
+            <a:srgbClr val="0073C6"/>
           </a:solidFill>
           <a:ln>
             <a:noFill/>
@@ -4627,7 +4417,7 @@
       </p:sp>
       <p:sp>
         <p:nvSpPr>
-          <p:cNvPr id="16" name="TextBox 15"/>
+          <p:cNvPr id="17" name="TextBox 16"/>
           <p:cNvSpPr txBox="1"/>
           <p:nvPr/>
         </p:nvSpPr>
@@ -4663,7 +4453,7 @@
       </p:sp>
       <p:sp>
         <p:nvSpPr>
-          <p:cNvPr id="17" name="TextBox 16"/>
+          <p:cNvPr id="18" name="TextBox 17"/>
           <p:cNvSpPr txBox="1"/>
           <p:nvPr/>
         </p:nvSpPr>
@@ -4724,24 +4514,24 @@
       <p:grpSpPr/>
       <p:sp>
         <p:nvSpPr>
-          <p:cNvPr id="2" name="Rounded Rectangle 1"/>
+          <p:cNvPr id="2" name="Oval 1"/>
           <p:cNvSpPr/>
           <p:nvPr/>
         </p:nvSpPr>
         <p:spPr>
           <a:xfrm>
             <a:off x="548640" y="182880"/>
-            <a:ext cx="2011680" cy="502920"/>
-          </a:xfrm>
-          <a:prstGeom prst="roundRect">
+            <a:ext cx="1371600" cy="731520"/>
+          </a:xfrm>
+          <a:prstGeom prst="ellipse">
             <a:avLst/>
           </a:prstGeom>
           <a:solidFill>
-            <a:srgbClr val="F3E8FF"/>
+            <a:srgbClr val="FFFFFF"/>
           </a:solidFill>
           <a:ln w="19050">
             <a:solidFill>
-              <a:srgbClr val="6D28D9"/>
+              <a:srgbClr val="9333EA"/>
             </a:solidFill>
           </a:ln>
         </p:spPr>
@@ -4760,19 +4550,45 @@
           </a:fontRef>
         </p:style>
         <p:txBody>
-          <a:bodyPr rtlCol="0" anchor="ctr" wrap="none"/>
+          <a:bodyPr rtlCol="0" anchor="ctr" wrap="none" lIns="0" tIns="0" rIns="0" bIns="0"/>
           <a:lstStyle/>
           <a:p>
             <a:pPr algn="ctr">
-              <a:defRPr sz="1100" b="1">
-                <a:solidFill>
-                  <a:srgbClr val="6D28D9"/>
+              <a:defRPr sz="950" b="1">
+                <a:solidFill>
+                  <a:srgbClr val="000000"/>
                 </a:solidFill>
                 <a:latin typeface="Arial"/>
               </a:defRPr>
             </a:pPr>
             <a:r>
-              <a:t>ThermoShield</a:t>
+              <a:t>Team</a:t>
+            </a:r>
+          </a:p>
+          <a:p>
+            <a:pPr algn="ctr">
+              <a:defRPr sz="950" b="1">
+                <a:solidFill>
+                  <a:srgbClr val="000000"/>
+                </a:solidFill>
+                <a:latin typeface="Arial"/>
+              </a:defRPr>
+            </a:pPr>
+            <a:r>
+              <a:t>Thermo-</a:t>
+            </a:r>
+          </a:p>
+          <a:p>
+            <a:pPr algn="ctr">
+              <a:defRPr sz="950" b="1">
+                <a:solidFill>
+                  <a:srgbClr val="000000"/>
+                </a:solidFill>
+                <a:latin typeface="Arial"/>
+              </a:defRPr>
+            </a:pPr>
+            <a:r>
+              <a:t>Shield</a:t>
             </a:r>
           </a:p>
         </p:txBody>
@@ -4785,8 +4601,8 @@
         </p:nvSpPr>
         <p:spPr>
           <a:xfrm>
-            <a:off x="2651760" y="164592"/>
-            <a:ext cx="6858000" cy="548640"/>
+            <a:off x="2286000" y="228600"/>
+            <a:ext cx="7619695" cy="594360"/>
           </a:xfrm>
           <a:prstGeom prst="rect">
             <a:avLst/>
@@ -4800,11 +4616,11 @@
           <a:lstStyle/>
           <a:p>
             <a:pPr algn="ctr">
-              <a:defRPr sz="1700" b="1">
-                <a:solidFill>
-                  <a:srgbClr val="0F172A"/>
-                </a:solidFill>
-                <a:latin typeface="Georgia"/>
+              <a:defRPr sz="1800" b="1">
+                <a:solidFill>
+                  <a:srgbClr val="000000"/>
+                </a:solidFill>
+                <a:latin typeface="Times New Roman"/>
               </a:defRPr>
             </a:pPr>
             <a:r>
@@ -4813,124 +4629,62 @@
           </a:p>
         </p:txBody>
       </p:sp>
-      <p:sp>
-        <p:nvSpPr>
-          <p:cNvPr id="4" name="Rounded Rectangle 3"/>
-          <p:cNvSpPr/>
+      <p:pic>
+        <p:nvPicPr>
+          <p:cNvPr id="4" name="Picture 3" descr="sih_logo_extracted.png"/>
+          <p:cNvPicPr>
+            <a:picLocks noChangeAspect="1"/>
+          </p:cNvPicPr>
           <p:nvPr/>
-        </p:nvSpPr>
-        <p:spPr>
-          <a:xfrm>
-            <a:off x="9601200" y="137160"/>
-            <a:ext cx="2011680" cy="594360"/>
-          </a:xfrm>
-          <a:prstGeom prst="roundRect">
-            <a:avLst/>
-          </a:prstGeom>
-          <a:solidFill>
-            <a:srgbClr val="FEF3C7"/>
-          </a:solidFill>
-          <a:ln w="19050">
-            <a:solidFill>
-              <a:srgbClr val="EA580C"/>
-            </a:solidFill>
-          </a:ln>
-        </p:spPr>
-        <p:style>
-          <a:lnRef idx="1">
-            <a:schemeClr val="accent1"/>
-          </a:lnRef>
-          <a:fillRef idx="3">
-            <a:schemeClr val="accent1"/>
-          </a:fillRef>
-          <a:effectRef idx="2">
-            <a:schemeClr val="accent1"/>
-          </a:effectRef>
-          <a:fontRef idx="minor">
-            <a:schemeClr val="lt1"/>
-          </a:fontRef>
-        </p:style>
-        <p:txBody>
-          <a:bodyPr rtlCol="0" anchor="ctr"/>
-          <a:lstStyle/>
-          <a:p>
-            <a:pPr algn="ctr">
-              <a:defRPr sz="950" b="1">
-                <a:solidFill>
-                  <a:srgbClr val="0F2C59"/>
+        </p:nvPicPr>
+        <p:blipFill>
+          <a:blip r:embed="rId2"/>
+          <a:stretch>
+            <a:fillRect/>
+          </a:stretch>
+        </p:blipFill>
+        <p:spPr>
+          <a:xfrm>
+            <a:off x="9875520" y="164592"/>
+            <a:ext cx="1920240" cy="722376"/>
+          </a:xfrm>
+          <a:prstGeom prst="rect">
+            <a:avLst/>
+          </a:prstGeom>
+        </p:spPr>
+      </p:pic>
+      <p:sp>
+        <p:nvSpPr>
+          <p:cNvPr id="5" name="TextBox 4"/>
+          <p:cNvSpPr txBox="1"/>
+          <p:nvPr/>
+        </p:nvSpPr>
+        <p:spPr>
+          <a:xfrm>
+            <a:off x="731520" y="1051560"/>
+            <a:ext cx="10728655" cy="320040"/>
+          </a:xfrm>
+          <a:prstGeom prst="rect">
+            <a:avLst/>
+          </a:prstGeom>
+          <a:noFill/>
+        </p:spPr>
+        <p:txBody>
+          <a:bodyPr wrap="none" lIns="0" tIns="0" rIns="0" bIns="0">
+            <a:spAutoFit/>
+          </a:bodyPr>
+          <a:lstStyle/>
+          <a:p>
+            <a:pPr>
+              <a:defRPr sz="1150" b="1">
+                <a:solidFill>
+                  <a:srgbClr val="1D4E89"/>
                 </a:solidFill>
                 <a:latin typeface="Arial"/>
               </a:defRPr>
             </a:pPr>
             <a:r>
-              <a:t>SMART INDIA</a:t>
-            </a:r>
-          </a:p>
-          <a:p>
-            <a:pPr algn="ctr">
-              <a:defRPr sz="950" b="1">
-                <a:solidFill>
-                  <a:srgbClr val="EA580C"/>
-                </a:solidFill>
-                <a:latin typeface="Arial"/>
-              </a:defRPr>
-            </a:pPr>
-            <a:r>
-              <a:t>HACKATHON 2026</a:t>
-            </a:r>
-          </a:p>
-        </p:txBody>
-      </p:sp>
-      <p:sp>
-        <p:nvSpPr>
-          <p:cNvPr id="5" name="Rectangle 4"/>
-          <p:cNvSpPr/>
-          <p:nvPr/>
-        </p:nvSpPr>
-        <p:spPr>
-          <a:xfrm>
-            <a:off x="2560320" y="868680"/>
-            <a:ext cx="7071055" cy="320040"/>
-          </a:xfrm>
-          <a:prstGeom prst="rect">
-            <a:avLst/>
-          </a:prstGeom>
-          <a:solidFill>
-            <a:srgbClr val="F0F9FF"/>
-          </a:solidFill>
-          <a:ln w="12700">
-            <a:solidFill>
-              <a:srgbClr val="0284C7"/>
-            </a:solidFill>
-          </a:ln>
-        </p:spPr>
-        <p:style>
-          <a:lnRef idx="1">
-            <a:schemeClr val="accent1"/>
-          </a:lnRef>
-          <a:fillRef idx="3">
-            <a:schemeClr val="accent1"/>
-          </a:fillRef>
-          <a:effectRef idx="2">
-            <a:schemeClr val="accent1"/>
-          </a:effectRef>
-          <a:fontRef idx="minor">
-            <a:schemeClr val="lt1"/>
-          </a:fontRef>
-        </p:style>
-        <p:txBody>
-          <a:bodyPr rtlCol="0" anchor="ctr"/>
-          <a:lstStyle/>
-          <a:p>
-            <a:pPr algn="ctr">
-              <a:defRPr sz="1000" b="1">
-                <a:solidFill>
-                  <a:srgbClr val="0F2C59"/>
-                </a:solidFill>
-              </a:defRPr>
-            </a:pPr>
-            <a:r>
-              <a:t>End-to-End Biometeorological &amp; Action Pipeline : Implementation Process Flow</a:t>
+              <a:t>• Methodology and Process for Implementation (Flow Chart &amp; Working Prototype Architecture)</a:t>
             </a:r>
           </a:p>
         </p:txBody>
@@ -4943,8 +4697,8 @@
         </p:nvSpPr>
         <p:spPr>
           <a:xfrm>
-            <a:off x="731520" y="1280160"/>
-            <a:ext cx="2542032" cy="3383280"/>
+            <a:off x="731520" y="1417320"/>
+            <a:ext cx="2542032" cy="3154680"/>
           </a:xfrm>
           <a:prstGeom prst="roundRect">
             <a:avLst/>
@@ -4988,8 +4742,8 @@
         </p:nvSpPr>
         <p:spPr>
           <a:xfrm>
-            <a:off x="804672" y="1353312"/>
-            <a:ext cx="2395728" cy="365760"/>
+            <a:off x="804672" y="1490472"/>
+            <a:ext cx="2395728" cy="347472"/>
           </a:xfrm>
           <a:prstGeom prst="roundRect">
             <a:avLst/>
@@ -5029,7 +4783,7 @@
               </a:defRPr>
             </a:pPr>
             <a:r>
-              <a:t>1. INGESTION</a:t>
+              <a:t>1. DATA INGESTION</a:t>
             </a:r>
           </a:p>
         </p:txBody>
@@ -5042,8 +4796,8 @@
         </p:nvSpPr>
         <p:spPr>
           <a:xfrm>
-            <a:off x="841248" y="1783080"/>
-            <a:ext cx="2322576" cy="2743200"/>
+            <a:off x="841248" y="1920240"/>
+            <a:ext cx="2322576" cy="2560320"/>
           </a:xfrm>
           <a:prstGeom prst="rect">
             <a:avLst/>
@@ -5057,14 +4811,14 @@
           <a:lstStyle/>
           <a:p>
             <a:pPr>
-              <a:defRPr sz="900" b="1">
-                <a:solidFill>
-                  <a:srgbClr val="0F2C59"/>
-                </a:solidFill>
-              </a:defRPr>
-            </a:pPr>
-            <a:r>
-              <a:t>Open-Meteo 0.1° NWP 5-Day Forecasts</a:t>
+              <a:defRPr sz="850">
+                <a:solidFill>
+                  <a:srgbClr val="1E293B"/>
+                </a:solidFill>
+              </a:defRPr>
+            </a:pPr>
+            <a:r>
+              <a:t>• Open-Meteo 0.1° NWP 5-Day Hourly Forecasts</a:t>
             </a:r>
           </a:p>
           <a:p>
@@ -5072,14 +4826,14 @@
               <a:spcBef>
                 <a:spcPts val="300"/>
               </a:spcBef>
-              <a:defRPr sz="900">
-                <a:solidFill>
-                  <a:srgbClr val="0F172A"/>
-                </a:solidFill>
-              </a:defRPr>
-            </a:pPr>
-            <a:r>
-              <a:t>• Hourly T, RH, Wind, Radiation</a:t>
+              <a:defRPr sz="850">
+                <a:solidFill>
+                  <a:srgbClr val="1E293B"/>
+                </a:solidFill>
+              </a:defRPr>
+            </a:pPr>
+            <a:r>
+              <a:t>• NASA POWER 40-Yr Climatology Normal</a:t>
             </a:r>
           </a:p>
           <a:p>
@@ -5087,14 +4841,14 @@
               <a:spcBef>
                 <a:spcPts val="300"/>
               </a:spcBef>
-              <a:defRPr sz="900">
-                <a:solidFill>
-                  <a:srgbClr val="0F172A"/>
-                </a:solidFill>
-              </a:defRPr>
-            </a:pPr>
-            <a:r>
-              <a:t>• NASA POWER 40-Yr Normal</a:t>
+              <a:defRPr sz="850">
+                <a:solidFill>
+                  <a:srgbClr val="1E293B"/>
+                </a:solidFill>
+              </a:defRPr>
+            </a:pPr>
+            <a:r>
+              <a:t>• Census 2011 PCA Ward Demographics</a:t>
             </a:r>
           </a:p>
           <a:p>
@@ -5102,29 +4856,14 @@
               <a:spcBef>
                 <a:spcPts val="300"/>
               </a:spcBef>
-              <a:defRPr sz="900">
-                <a:solidFill>
-                  <a:srgbClr val="0F172A"/>
-                </a:solidFill>
-              </a:defRPr>
-            </a:pPr>
-            <a:r>
-              <a:t>• Census 2011 Ward PCA Data</a:t>
-            </a:r>
-          </a:p>
-          <a:p>
-            <a:pPr>
-              <a:spcBef>
-                <a:spcPts val="300"/>
-              </a:spcBef>
-              <a:defRPr sz="900">
-                <a:solidFill>
-                  <a:srgbClr val="0F172A"/>
-                </a:solidFill>
-              </a:defRPr>
-            </a:pPr>
-            <a:r>
-              <a:t>• Satellite LST / NDVI Surface Grid</a:t>
+              <a:defRPr sz="850">
+                <a:solidFill>
+                  <a:srgbClr val="1E293B"/>
+                </a:solidFill>
+              </a:defRPr>
+            </a:pPr>
+            <a:r>
+              <a:t>• Satellite LST &amp; NDVI Surface Grid</a:t>
             </a:r>
           </a:p>
         </p:txBody>
@@ -5137,8 +4876,8 @@
         </p:nvSpPr>
         <p:spPr>
           <a:xfrm>
-            <a:off x="3456432" y="1280160"/>
-            <a:ext cx="2542032" cy="3383280"/>
+            <a:off x="3456432" y="1417320"/>
+            <a:ext cx="2542032" cy="3154680"/>
           </a:xfrm>
           <a:prstGeom prst="roundRect">
             <a:avLst/>
@@ -5182,8 +4921,8 @@
         </p:nvSpPr>
         <p:spPr>
           <a:xfrm>
-            <a:off x="3529584" y="1353312"/>
-            <a:ext cx="2395728" cy="365760"/>
+            <a:off x="3529584" y="1490472"/>
+            <a:ext cx="2395728" cy="347472"/>
           </a:xfrm>
           <a:prstGeom prst="roundRect">
             <a:avLst/>
@@ -5236,8 +4975,8 @@
         </p:nvSpPr>
         <p:spPr>
           <a:xfrm>
-            <a:off x="3566160" y="1783080"/>
-            <a:ext cx="2322576" cy="2743200"/>
+            <a:off x="3566160" y="1920240"/>
+            <a:ext cx="2322576" cy="2560320"/>
           </a:xfrm>
           <a:prstGeom prst="rect">
             <a:avLst/>
@@ -5251,14 +4990,14 @@
           <a:lstStyle/>
           <a:p>
             <a:pPr>
-              <a:defRPr sz="900" b="1">
-                <a:solidFill>
-                  <a:srgbClr val="0F2C59"/>
-                </a:solidFill>
-              </a:defRPr>
-            </a:pPr>
-            <a:r>
-              <a:t>UTCI 6th-Order Polynomial</a:t>
+              <a:defRPr sz="850">
+                <a:solidFill>
+                  <a:srgbClr val="1E293B"/>
+                </a:solidFill>
+              </a:defRPr>
+            </a:pPr>
+            <a:r>
+              <a:t>• UTCI 6th-Order Polynomial (Fiala 187-Node)</a:t>
             </a:r>
           </a:p>
           <a:p>
@@ -5266,14 +5005,14 @@
               <a:spcBef>
                 <a:spcPts val="300"/>
               </a:spcBef>
-              <a:defRPr sz="900">
-                <a:solidFill>
-                  <a:srgbClr val="0F172A"/>
-                </a:solidFill>
-              </a:defRPr>
-            </a:pPr>
-            <a:r>
-              <a:t>• Fiala 187-Node Human Model</a:t>
+              <a:defRPr sz="850">
+                <a:solidFill>
+                  <a:srgbClr val="1E293B"/>
+                </a:solidFill>
+              </a:defRPr>
+            </a:pPr>
+            <a:r>
+              <a:t>• ISO 7243 WBGT Psychrometrics</a:t>
             </a:r>
           </a:p>
           <a:p>
@@ -5281,14 +5020,14 @@
               <a:spcBef>
                 <a:spcPts val="300"/>
               </a:spcBef>
-              <a:defRPr sz="900">
-                <a:solidFill>
-                  <a:srgbClr val="0F172A"/>
-                </a:solidFill>
-              </a:defRPr>
-            </a:pPr>
-            <a:r>
-              <a:t>• ISO 7243 WBGT Psychrometrics</a:t>
+              <a:defRPr sz="850">
+                <a:solidFill>
+                  <a:srgbClr val="1E293B"/>
+                </a:solidFill>
+              </a:defRPr>
+            </a:pPr>
+            <a:r>
+              <a:t>• Stull Tw &amp; Liljegren Tg Equations</a:t>
             </a:r>
           </a:p>
           <a:p>
@@ -5296,29 +5035,14 @@
               <a:spcBef>
                 <a:spcPts val="300"/>
               </a:spcBef>
-              <a:defRPr sz="900">
-                <a:solidFill>
-                  <a:srgbClr val="0F172A"/>
-                </a:solidFill>
-              </a:defRPr>
-            </a:pPr>
-            <a:r>
-              <a:t>• Stull Tw &amp; Liljegren Tg Models</a:t>
-            </a:r>
-          </a:p>
-          <a:p>
-            <a:pPr>
-              <a:spcBef>
-                <a:spcPts val="300"/>
-              </a:spcBef>
-              <a:defRPr sz="900">
-                <a:solidFill>
-                  <a:srgbClr val="0F172A"/>
-                </a:solidFill>
-              </a:defRPr>
-            </a:pPr>
-            <a:r>
-              <a:t>• Cumulative Multi-Day Dmult</a:t>
+              <a:defRPr sz="850">
+                <a:solidFill>
+                  <a:srgbClr val="1E293B"/>
+                </a:solidFill>
+              </a:defRPr>
+            </a:pPr>
+            <a:r>
+              <a:t>• Multi-Day Persistence Multiplier (Dmult)</a:t>
             </a:r>
           </a:p>
         </p:txBody>
@@ -5331,8 +5055,8 @@
         </p:nvSpPr>
         <p:spPr>
           <a:xfrm>
-            <a:off x="6181344" y="1280160"/>
-            <a:ext cx="2542032" cy="3383280"/>
+            <a:off x="6181344" y="1417320"/>
+            <a:ext cx="2542032" cy="3154680"/>
           </a:xfrm>
           <a:prstGeom prst="roundRect">
             <a:avLst/>
@@ -5376,8 +5100,8 @@
         </p:nvSpPr>
         <p:spPr>
           <a:xfrm>
-            <a:off x="6254496" y="1353312"/>
-            <a:ext cx="2395728" cy="365760"/>
+            <a:off x="6254496" y="1490472"/>
+            <a:ext cx="2395728" cy="347472"/>
           </a:xfrm>
           <a:prstGeom prst="roundRect">
             <a:avLst/>
@@ -5417,7 +5141,7 @@
               </a:defRPr>
             </a:pPr>
             <a:r>
-              <a:t>3. AI &amp; HVI MODEL</a:t>
+              <a:t>3. AI RISK &amp; HVI MODEL</a:t>
             </a:r>
           </a:p>
         </p:txBody>
@@ -5430,8 +5154,8 @@
         </p:nvSpPr>
         <p:spPr>
           <a:xfrm>
-            <a:off x="6291072" y="1783080"/>
-            <a:ext cx="2322576" cy="2743200"/>
+            <a:off x="6291072" y="1920240"/>
+            <a:ext cx="2322576" cy="2560320"/>
           </a:xfrm>
           <a:prstGeom prst="rect">
             <a:avLst/>
@@ -5445,14 +5169,14 @@
           <a:lstStyle/>
           <a:p>
             <a:pPr>
-              <a:defRPr sz="900" b="1">
-                <a:solidFill>
-                  <a:srgbClr val="0F2C59"/>
-                </a:solidFill>
-              </a:defRPr>
-            </a:pPr>
-            <a:r>
-              <a:t>Census Demographic Vulnerability</a:t>
+              <a:defRPr sz="850">
+                <a:solidFill>
+                  <a:srgbClr val="1E293B"/>
+                </a:solidFill>
+              </a:defRPr>
+            </a:pPr>
+            <a:r>
+              <a:t>• Demographic Vulnerability (HVI)</a:t>
             </a:r>
           </a:p>
           <a:p>
@@ -5460,14 +5184,14 @@
               <a:spcBef>
                 <a:spcPts val="300"/>
               </a:spcBef>
-              <a:defRPr sz="900">
-                <a:solidFill>
-                  <a:srgbClr val="0F172A"/>
-                </a:solidFill>
-              </a:defRPr>
-            </a:pPr>
-            <a:r>
-              <a:t>• Elderly Density &amp; Slum Ratio</a:t>
+              <a:defRPr sz="850">
+                <a:solidFill>
+                  <a:srgbClr val="1E293B"/>
+                </a:solidFill>
+              </a:defRPr>
+            </a:pPr>
+            <a:r>
+              <a:t>• Elderly &amp; Outdoor Labor Density</a:t>
             </a:r>
           </a:p>
           <a:p>
@@ -5475,14 +5199,14 @@
               <a:spcBef>
                 <a:spcPts val="300"/>
               </a:spcBef>
-              <a:defRPr sz="900">
-                <a:solidFill>
-                  <a:srgbClr val="0F172A"/>
-                </a:solidFill>
-              </a:defRPr>
-            </a:pPr>
-            <a:r>
-              <a:t>• Outdoor Labor Concentration</a:t>
+              <a:defRPr sz="850">
+                <a:solidFill>
+                  <a:srgbClr val="1E293B"/>
+                </a:solidFill>
+              </a:defRPr>
+            </a:pPr>
+            <a:r>
+              <a:t>• Slum Housing &amp; Canopy Deficit</a:t>
             </a:r>
           </a:p>
           <a:p>
@@ -5490,29 +5214,14 @@
               <a:spcBef>
                 <a:spcPts val="300"/>
               </a:spcBef>
-              <a:defRPr sz="900">
-                <a:solidFill>
-                  <a:srgbClr val="0F172A"/>
-                </a:solidFill>
-              </a:defRPr>
-            </a:pPr>
-            <a:r>
-              <a:t>• Tree Canopy Deficit Index</a:t>
-            </a:r>
-          </a:p>
-          <a:p>
-            <a:pPr>
-              <a:spcBef>
-                <a:spcPts val="300"/>
-              </a:spcBef>
-              <a:defRPr sz="900">
-                <a:solidFill>
-                  <a:srgbClr val="0F172A"/>
-                </a:solidFill>
-              </a:defRPr>
-            </a:pPr>
-            <a:r>
-              <a:t>• Relative Heat-Health Score</a:t>
+              <a:defRPr sz="850">
+                <a:solidFill>
+                  <a:srgbClr val="1E293B"/>
+                </a:solidFill>
+              </a:defRPr>
+            </a:pPr>
+            <a:r>
+              <a:t>• Normalized 0–100 Heat-Health Score</a:t>
             </a:r>
           </a:p>
         </p:txBody>
@@ -5525,8 +5234,8 @@
         </p:nvSpPr>
         <p:spPr>
           <a:xfrm>
-            <a:off x="8906256" y="1280160"/>
-            <a:ext cx="2542032" cy="3383280"/>
+            <a:off x="8906256" y="1417320"/>
+            <a:ext cx="2542032" cy="3154680"/>
           </a:xfrm>
           <a:prstGeom prst="roundRect">
             <a:avLst/>
@@ -5536,7 +5245,7 @@
           </a:solidFill>
           <a:ln w="19050">
             <a:solidFill>
-              <a:srgbClr val="0F2C59"/>
+              <a:srgbClr val="1D4E89"/>
             </a:solidFill>
           </a:ln>
         </p:spPr>
@@ -5570,8 +5279,8 @@
         </p:nvSpPr>
         <p:spPr>
           <a:xfrm>
-            <a:off x="8979408" y="1353312"/>
-            <a:ext cx="2395728" cy="365760"/>
+            <a:off x="8979408" y="1490472"/>
+            <a:ext cx="2395728" cy="347472"/>
           </a:xfrm>
           <a:prstGeom prst="roundRect">
             <a:avLst/>
@@ -5581,7 +5290,7 @@
           </a:solidFill>
           <a:ln w="12700">
             <a:solidFill>
-              <a:srgbClr val="0F2C59"/>
+              <a:srgbClr val="1D4E89"/>
             </a:solidFill>
           </a:ln>
         </p:spPr>
@@ -5606,12 +5315,12 @@
             <a:pPr algn="ctr">
               <a:defRPr sz="1000" b="1">
                 <a:solidFill>
-                  <a:srgbClr val="0F2C59"/>
-                </a:solidFill>
-              </a:defRPr>
-            </a:pPr>
-            <a:r>
-              <a:t>4. ACTION &amp; GIS</a:t>
+                  <a:srgbClr val="1D4E89"/>
+                </a:solidFill>
+              </a:defRPr>
+            </a:pPr>
+            <a:r>
+              <a:t>4. ACTION &amp; GIS DELIVERY</a:t>
             </a:r>
           </a:p>
         </p:txBody>
@@ -5624,8 +5333,8 @@
         </p:nvSpPr>
         <p:spPr>
           <a:xfrm>
-            <a:off x="9015984" y="1783080"/>
-            <a:ext cx="2322576" cy="2743200"/>
+            <a:off x="9015984" y="1920240"/>
+            <a:ext cx="2322576" cy="2560320"/>
           </a:xfrm>
           <a:prstGeom prst="rect">
             <a:avLst/>
@@ -5639,14 +5348,14 @@
           <a:lstStyle/>
           <a:p>
             <a:pPr>
-              <a:defRPr sz="900" b="1">
-                <a:solidFill>
-                  <a:srgbClr val="0F2C59"/>
-                </a:solidFill>
-              </a:defRPr>
-            </a:pPr>
-            <a:r>
-              <a:t>Interactive Leaflet GIS Map</a:t>
+              <a:defRPr sz="850">
+                <a:solidFill>
+                  <a:srgbClr val="1E293B"/>
+                </a:solidFill>
+              </a:defRPr>
+            </a:pPr>
+            <a:r>
+              <a:t>• Interactive Leaflet GIS Choropleth</a:t>
             </a:r>
           </a:p>
           <a:p>
@@ -5654,14 +5363,14 @@
               <a:spcBef>
                 <a:spcPts val="300"/>
               </a:spcBef>
-              <a:defRPr sz="900">
-                <a:solidFill>
-                  <a:srgbClr val="0F172A"/>
-                </a:solidFill>
-              </a:defRPr>
-            </a:pPr>
-            <a:r>
-              <a:t>• 25 REST Production APIs</a:t>
+              <a:defRPr sz="850">
+                <a:solidFill>
+                  <a:srgbClr val="1E293B"/>
+                </a:solidFill>
+              </a:defRPr>
+            </a:pPr>
+            <a:r>
+              <a:t>• 25 Production REST APIs</a:t>
             </a:r>
           </a:p>
           <a:p>
@@ -5669,14 +5378,14 @@
               <a:spcBef>
                 <a:spcPts val="300"/>
               </a:spcBef>
-              <a:defRPr sz="900">
-                <a:solidFill>
-                  <a:srgbClr val="0F172A"/>
-                </a:solidFill>
-              </a:defRPr>
-            </a:pPr>
-            <a:r>
-              <a:t>• Automated NDMA Playbooks</a:t>
+              <a:defRPr sz="850">
+                <a:solidFill>
+                  <a:srgbClr val="1E293B"/>
+                </a:solidFill>
+              </a:defRPr>
+            </a:pPr>
+            <a:r>
+              <a:t>• Automated NDMA Action Playbooks</a:t>
             </a:r>
           </a:p>
           <a:p>
@@ -5684,29 +5393,14 @@
               <a:spcBef>
                 <a:spcPts val="300"/>
               </a:spcBef>
-              <a:defRPr sz="900">
-                <a:solidFill>
-                  <a:srgbClr val="0F172A"/>
+              <a:defRPr sz="850">
+                <a:solidFill>
+                  <a:srgbClr val="1E293B"/>
                 </a:solidFill>
               </a:defRPr>
             </a:pPr>
             <a:r>
               <a:t>• Hospital Surge Bed Triggers</a:t>
-            </a:r>
-          </a:p>
-          <a:p>
-            <a:pPr>
-              <a:spcBef>
-                <a:spcPts val="300"/>
-              </a:spcBef>
-              <a:defRPr sz="900">
-                <a:solidFill>
-                  <a:srgbClr val="0F172A"/>
-                </a:solidFill>
-              </a:defRPr>
-            </a:pPr>
-            <a:r>
-              <a:t>• NIOSH Labor Halt Alerts</a:t>
             </a:r>
           </a:p>
         </p:txBody>
@@ -5719,8 +5413,8 @@
         </p:nvSpPr>
         <p:spPr>
           <a:xfrm>
-            <a:off x="731520" y="4754880"/>
-            <a:ext cx="10728655" cy="1600200"/>
+            <a:off x="731520" y="4709160"/>
+            <a:ext cx="10728655" cy="1645920"/>
           </a:xfrm>
           <a:prstGeom prst="roundRect">
             <a:avLst/>
@@ -5755,12 +5449,12 @@
             <a:pPr algn="ctr">
               <a:defRPr sz="1100" b="1">
                 <a:solidFill>
-                  <a:srgbClr val="0F2C59"/>
-                </a:solidFill>
-              </a:defRPr>
-            </a:pPr>
-            <a:r>
-              <a:t>Technologies to be used:</a:t>
+                  <a:srgbClr val="1D4E89"/>
+                </a:solidFill>
+              </a:defRPr>
+            </a:pPr>
+            <a:r>
+              <a:t>• Technologies to be used (Languages, Frameworks, Libraries &amp; Infrastructure):</a:t>
             </a:r>
           </a:p>
           <a:p>
@@ -5770,20 +5464,20 @@
               </a:spcBef>
               <a:defRPr sz="900" b="1">
                 <a:solidFill>
-                  <a:srgbClr val="0F2C59"/>
-                </a:solidFill>
-              </a:defRPr>
-            </a:pPr>
-            <a:r>
-              <a:t>• Backend &amp; REST APIs: </a:t>
+                  <a:srgbClr val="1D4E89"/>
+                </a:solidFill>
+              </a:defRPr>
+            </a:pPr>
+            <a:r>
+              <a:t>❖  Backend &amp; REST APIs: </a:t>
             </a:r>
             <a:r>
               <a:rPr b="0">
                 <a:solidFill>
-                  <a:srgbClr val="0F172A"/>
+                  <a:srgbClr val="1E293B"/>
                 </a:solidFill>
               </a:rPr>
-              <a:t>Python 3.11, FastAPI, Pydantic v2, Uvicorn, AsyncIO (25 REST endpoints)</a:t>
+              <a:t>Python 3.11, FastAPI, Pydantic v2, Uvicorn, AsyncIO (25 REST production endpoints)</a:t>
             </a:r>
           </a:p>
           <a:p>
@@ -5793,20 +5487,20 @@
               </a:spcBef>
               <a:defRPr sz="900" b="1">
                 <a:solidFill>
-                  <a:srgbClr val="0F2C59"/>
-                </a:solidFill>
-              </a:defRPr>
-            </a:pPr>
-            <a:r>
-              <a:t>• Biometeorological &amp; GIS Engine: </a:t>
+                  <a:srgbClr val="1D4E89"/>
+                </a:solidFill>
+              </a:defRPr>
+            </a:pPr>
+            <a:r>
+              <a:t>❖  Biometeorological &amp; GIS Engine: </a:t>
             </a:r>
             <a:r>
               <a:rPr b="0">
                 <a:solidFill>
-                  <a:srgbClr val="0F172A"/>
+                  <a:srgbClr val="1E293B"/>
                 </a:solidFill>
               </a:rPr>
-              <a:t>NumPy, Pandas, GeoPandas, Shapely, Scipy (UTCI 6th-order polynomial &amp; psychrometrics)</a:t>
+              <a:t>NumPy, Pandas, GeoPandas, Shapely, Scipy (UTCI 6th-order polynomial &amp; ISO 7243 psychrometrics)</a:t>
             </a:r>
           </a:p>
           <a:p>
@@ -5816,17 +5510,17 @@
               </a:spcBef>
               <a:defRPr sz="900" b="1">
                 <a:solidFill>
-                  <a:srgbClr val="0F2C59"/>
-                </a:solidFill>
-              </a:defRPr>
-            </a:pPr>
-            <a:r>
-              <a:t>• Web GIS &amp; Visualization: </a:t>
+                  <a:srgbClr val="1D4E89"/>
+                </a:solidFill>
+              </a:defRPr>
+            </a:pPr>
+            <a:r>
+              <a:t>❖  Web GIS &amp; Visualization: </a:t>
             </a:r>
             <a:r>
               <a:rPr b="0">
                 <a:solidFill>
-                  <a:srgbClr val="0F172A"/>
+                  <a:srgbClr val="1E293B"/>
                 </a:solidFill>
               </a:rPr>
               <a:t>Leaflet.js (Choropleth GIS), Chart.js (5-Day Trend Curves), HTML5/CSS3 Responsive UI</a:t>
@@ -5839,20 +5533,20 @@
               </a:spcBef>
               <a:defRPr sz="900" b="1">
                 <a:solidFill>
-                  <a:srgbClr val="0F2C59"/>
-                </a:solidFill>
-              </a:defRPr>
-            </a:pPr>
-            <a:r>
-              <a:t>• Data Ingestion &amp; Cloud Infra: </a:t>
+                  <a:srgbClr val="1D4E89"/>
+                </a:solidFill>
+              </a:defRPr>
+            </a:pPr>
+            <a:r>
+              <a:t>❖  Data Ingestion &amp; Deployment: </a:t>
             </a:r>
             <a:r>
               <a:rPr b="0">
                 <a:solidFill>
-                  <a:srgbClr val="0F172A"/>
+                  <a:srgbClr val="1E293B"/>
                 </a:solidFill>
               </a:rPr>
-              <a:t>Open-Meteo NWP, NASA POWER (MERRA-2), Census India PCA, Docker, Linux VPS (Oracle Linux)</a:t>
+              <a:t>Open-Meteo NWP, NASA POWER MERRA-2, Census India PCA, Docker, Linux VPS (Oracle Linux)</a:t>
             </a:r>
           </a:p>
         </p:txBody>
@@ -5872,7 +5566,7 @@
             <a:avLst/>
           </a:prstGeom>
           <a:solidFill>
-            <a:srgbClr val="0F2C59"/>
+            <a:srgbClr val="0073C6"/>
           </a:solidFill>
           <a:ln>
             <a:noFill/>
@@ -5999,24 +5693,24 @@
       <p:grpSpPr/>
       <p:sp>
         <p:nvSpPr>
-          <p:cNvPr id="2" name="Rounded Rectangle 1"/>
+          <p:cNvPr id="2" name="Oval 1"/>
           <p:cNvSpPr/>
           <p:nvPr/>
         </p:nvSpPr>
         <p:spPr>
           <a:xfrm>
             <a:off x="548640" y="182880"/>
-            <a:ext cx="2011680" cy="502920"/>
-          </a:xfrm>
-          <a:prstGeom prst="roundRect">
+            <a:ext cx="1371600" cy="731520"/>
+          </a:xfrm>
+          <a:prstGeom prst="ellipse">
             <a:avLst/>
           </a:prstGeom>
           <a:solidFill>
-            <a:srgbClr val="F3E8FF"/>
+            <a:srgbClr val="FFFFFF"/>
           </a:solidFill>
           <a:ln w="19050">
             <a:solidFill>
-              <a:srgbClr val="6D28D9"/>
+              <a:srgbClr val="9333EA"/>
             </a:solidFill>
           </a:ln>
         </p:spPr>
@@ -6035,19 +5729,45 @@
           </a:fontRef>
         </p:style>
         <p:txBody>
-          <a:bodyPr rtlCol="0" anchor="ctr" wrap="none"/>
+          <a:bodyPr rtlCol="0" anchor="ctr" wrap="none" lIns="0" tIns="0" rIns="0" bIns="0"/>
           <a:lstStyle/>
           <a:p>
             <a:pPr algn="ctr">
-              <a:defRPr sz="1100" b="1">
-                <a:solidFill>
-                  <a:srgbClr val="6D28D9"/>
+              <a:defRPr sz="950" b="1">
+                <a:solidFill>
+                  <a:srgbClr val="000000"/>
                 </a:solidFill>
                 <a:latin typeface="Arial"/>
               </a:defRPr>
             </a:pPr>
             <a:r>
-              <a:t>ThermoShield</a:t>
+              <a:t>Team</a:t>
+            </a:r>
+          </a:p>
+          <a:p>
+            <a:pPr algn="ctr">
+              <a:defRPr sz="950" b="1">
+                <a:solidFill>
+                  <a:srgbClr val="000000"/>
+                </a:solidFill>
+                <a:latin typeface="Arial"/>
+              </a:defRPr>
+            </a:pPr>
+            <a:r>
+              <a:t>Thermo-</a:t>
+            </a:r>
+          </a:p>
+          <a:p>
+            <a:pPr algn="ctr">
+              <a:defRPr sz="950" b="1">
+                <a:solidFill>
+                  <a:srgbClr val="000000"/>
+                </a:solidFill>
+                <a:latin typeface="Arial"/>
+              </a:defRPr>
+            </a:pPr>
+            <a:r>
+              <a:t>Shield</a:t>
             </a:r>
           </a:p>
         </p:txBody>
@@ -6060,8 +5780,8 @@
         </p:nvSpPr>
         <p:spPr>
           <a:xfrm>
-            <a:off x="2651760" y="164592"/>
-            <a:ext cx="6858000" cy="548640"/>
+            <a:off x="2286000" y="228600"/>
+            <a:ext cx="7619695" cy="594360"/>
           </a:xfrm>
           <a:prstGeom prst="rect">
             <a:avLst/>
@@ -6075,11 +5795,11 @@
           <a:lstStyle/>
           <a:p>
             <a:pPr algn="ctr">
-              <a:defRPr sz="1700" b="1">
-                <a:solidFill>
-                  <a:srgbClr val="0F172A"/>
-                </a:solidFill>
-                <a:latin typeface="Georgia"/>
+              <a:defRPr sz="1800" b="1">
+                <a:solidFill>
+                  <a:srgbClr val="000000"/>
+                </a:solidFill>
+                <a:latin typeface="Times New Roman"/>
               </a:defRPr>
             </a:pPr>
             <a:r>
@@ -6088,74 +5808,30 @@
           </a:p>
         </p:txBody>
       </p:sp>
-      <p:sp>
-        <p:nvSpPr>
-          <p:cNvPr id="4" name="Rounded Rectangle 3"/>
-          <p:cNvSpPr/>
+      <p:pic>
+        <p:nvPicPr>
+          <p:cNvPr id="4" name="Picture 3" descr="sih_logo_extracted.png"/>
+          <p:cNvPicPr>
+            <a:picLocks noChangeAspect="1"/>
+          </p:cNvPicPr>
           <p:nvPr/>
-        </p:nvSpPr>
-        <p:spPr>
-          <a:xfrm>
-            <a:off x="9601200" y="137160"/>
-            <a:ext cx="2011680" cy="594360"/>
-          </a:xfrm>
-          <a:prstGeom prst="roundRect">
-            <a:avLst/>
-          </a:prstGeom>
-          <a:solidFill>
-            <a:srgbClr val="FEF3C7"/>
-          </a:solidFill>
-          <a:ln w="19050">
-            <a:solidFill>
-              <a:srgbClr val="EA580C"/>
-            </a:solidFill>
-          </a:ln>
-        </p:spPr>
-        <p:style>
-          <a:lnRef idx="1">
-            <a:schemeClr val="accent1"/>
-          </a:lnRef>
-          <a:fillRef idx="3">
-            <a:schemeClr val="accent1"/>
-          </a:fillRef>
-          <a:effectRef idx="2">
-            <a:schemeClr val="accent1"/>
-          </a:effectRef>
-          <a:fontRef idx="minor">
-            <a:schemeClr val="lt1"/>
-          </a:fontRef>
-        </p:style>
-        <p:txBody>
-          <a:bodyPr rtlCol="0" anchor="ctr"/>
-          <a:lstStyle/>
-          <a:p>
-            <a:pPr algn="ctr">
-              <a:defRPr sz="950" b="1">
-                <a:solidFill>
-                  <a:srgbClr val="0F2C59"/>
-                </a:solidFill>
-                <a:latin typeface="Arial"/>
-              </a:defRPr>
-            </a:pPr>
-            <a:r>
-              <a:t>SMART INDIA</a:t>
-            </a:r>
-          </a:p>
-          <a:p>
-            <a:pPr algn="ctr">
-              <a:defRPr sz="950" b="1">
-                <a:solidFill>
-                  <a:srgbClr val="EA580C"/>
-                </a:solidFill>
-                <a:latin typeface="Arial"/>
-              </a:defRPr>
-            </a:pPr>
-            <a:r>
-              <a:t>HACKATHON 2026</a:t>
-            </a:r>
-          </a:p>
-        </p:txBody>
-      </p:sp>
+        </p:nvPicPr>
+        <p:blipFill>
+          <a:blip r:embed="rId2"/>
+          <a:stretch>
+            <a:fillRect/>
+          </a:stretch>
+        </p:blipFill>
+        <p:spPr>
+          <a:xfrm>
+            <a:off x="9875520" y="164592"/>
+            <a:ext cx="1920240" cy="722376"/>
+          </a:xfrm>
+          <a:prstGeom prst="rect">
+            <a:avLst/>
+          </a:prstGeom>
+        </p:spPr>
+      </p:pic>
       <p:sp>
         <p:nvSpPr>
           <p:cNvPr id="5" name="TextBox 4"/>
@@ -6164,8 +5840,8 @@
         </p:nvSpPr>
         <p:spPr>
           <a:xfrm>
-            <a:off x="731520" y="868680"/>
-            <a:ext cx="10728655" cy="1463040"/>
+            <a:off x="731520" y="1005840"/>
+            <a:ext cx="10728655" cy="1371600"/>
           </a:xfrm>
           <a:prstGeom prst="rect">
             <a:avLst/>
@@ -6179,44 +5855,29 @@
           <a:lstStyle/>
           <a:p>
             <a:pPr>
-              <a:defRPr sz="1100" b="1">
-                <a:solidFill>
-                  <a:srgbClr val="0F2C59"/>
-                </a:solidFill>
-              </a:defRPr>
-            </a:pPr>
-            <a:r>
-              <a:t>❖  Is this Idea feasible ?</a:t>
+              <a:defRPr sz="1150" b="1">
+                <a:solidFill>
+                  <a:srgbClr val="1D4E89"/>
+                </a:solidFill>
+              </a:defRPr>
+            </a:pPr>
+            <a:r>
+              <a:t>• Analysis of the Feasibility of the Idea</a:t>
             </a:r>
           </a:p>
           <a:p>
             <a:pPr>
               <a:spcBef>
-                <a:spcPts val="100"/>
+                <a:spcPts val="200"/>
               </a:spcBef>
               <a:defRPr sz="900">
                 <a:solidFill>
-                  <a:srgbClr val="0F172A"/>
-                </a:solidFill>
-              </a:defRPr>
-            </a:pPr>
-            <a:r>
-              <a:t>The proposed ThermoShield system is fully feasible due to open, keyless Tier-1 atmospheric data pipelines (Open-Meteo 0.1° NWP hourly forecasts and NASA POWER MERRA-2 40-year climatological normals) and validated biometeorological equations (UTCI polynomial &amp; ISO 7243 WBGT). The use of Census 2011 PCA demographics enables hyper-local ward-level vulnerability mapping without waiting for restricted government clearance.</a:t>
-            </a:r>
-          </a:p>
-          <a:p>
-            <a:pPr>
-              <a:spcBef>
-                <a:spcPts val="300"/>
-              </a:spcBef>
-              <a:defRPr sz="900" b="1">
-                <a:solidFill>
-                  <a:srgbClr val="0F2C59"/>
-                </a:solidFill>
-              </a:defRPr>
-            </a:pPr>
-            <a:r>
-              <a:t>❖  Product Offering: We offer this platform to Municipal Corporations, State Disaster Management Authorities (SDMAs), Health Departments, and Gig Platforms as an automated, impact-to-action early warning and resource coordination OS.</a:t>
+                  <a:srgbClr val="1E293B"/>
+                </a:solidFill>
+              </a:defRPr>
+            </a:pPr>
+            <a:r>
+              <a:t>The ThermoShield platform is highly feasible due to open, keyless Tier-1 atmospheric data pipelines (Open-Meteo 0.1° NWP hourly forecasts and NASA POWER MERRA-2 40-year climatological normals) and validated biometeorological formulations (WMO UTCI polynomial &amp; ISO 7243 WBGT). Integrating Census 2011 PCA demographics enables hyper-local ward-level vulnerability mapping without waiting for restricted government permissions.</a:t>
             </a:r>
           </a:p>
         </p:txBody>
@@ -6296,7 +5957,7 @@
               </a:defRPr>
             </a:pPr>
             <a:r>
-              <a:t>Challenges &amp; Risks:                                             Strategies for Overcoming:</a:t>
+              <a:t>• Potential Challenges &amp; Risks                     • Strategies for Overcoming</a:t>
             </a:r>
           </a:p>
         </p:txBody>
@@ -6530,7 +6191,7 @@
           </a:solidFill>
           <a:ln w="19050">
             <a:solidFill>
-              <a:srgbClr val="0F2C59"/>
+              <a:srgbClr val="1D4E89"/>
             </a:solidFill>
           </a:ln>
         </p:spPr>
@@ -6555,12 +6216,12 @@
             <a:pPr algn="ctr">
               <a:defRPr sz="1100" b="1">
                 <a:solidFill>
-                  <a:srgbClr val="0F2C59"/>
-                </a:solidFill>
-              </a:defRPr>
-            </a:pPr>
-            <a:r>
-              <a:t>Expected Customers &amp; Users:</a:t>
+                  <a:srgbClr val="1D4E89"/>
+                </a:solidFill>
+              </a:defRPr>
+            </a:pPr>
+            <a:r>
+              <a:t>• Target Users &amp; Viability:</a:t>
             </a:r>
           </a:p>
           <a:p>
@@ -6570,7 +6231,7 @@
               </a:spcBef>
               <a:defRPr sz="900" b="1">
                 <a:solidFill>
-                  <a:srgbClr val="0F2C59"/>
+                  <a:srgbClr val="1D4E89"/>
                 </a:solidFill>
               </a:defRPr>
             </a:pPr>
@@ -6597,7 +6258,7 @@
               </a:spcBef>
               <a:defRPr sz="900" b="1">
                 <a:solidFill>
-                  <a:srgbClr val="0F2C59"/>
+                  <a:srgbClr val="1D4E89"/>
                 </a:solidFill>
               </a:defRPr>
             </a:pPr>
@@ -6624,7 +6285,7 @@
               </a:spcBef>
               <a:defRPr sz="900" b="1">
                 <a:solidFill>
-                  <a:srgbClr val="0F2C59"/>
+                  <a:srgbClr val="1D4E89"/>
                 </a:solidFill>
               </a:defRPr>
             </a:pPr>
@@ -6651,7 +6312,7 @@
               </a:spcBef>
               <a:defRPr sz="900" b="1">
                 <a:solidFill>
-                  <a:srgbClr val="0F2C59"/>
+                  <a:srgbClr val="1D4E89"/>
                 </a:solidFill>
               </a:defRPr>
             </a:pPr>
@@ -6678,7 +6339,7 @@
               </a:spcBef>
               <a:defRPr sz="900" b="1">
                 <a:solidFill>
-                  <a:srgbClr val="0F2C59"/>
+                  <a:srgbClr val="1D4E89"/>
                 </a:solidFill>
               </a:defRPr>
             </a:pPr>
@@ -6715,7 +6376,7 @@
             <a:avLst/>
           </a:prstGeom>
           <a:solidFill>
-            <a:srgbClr val="0F2C59"/>
+            <a:srgbClr val="0073C6"/>
           </a:solidFill>
           <a:ln>
             <a:noFill/>
@@ -6842,24 +6503,24 @@
       <p:grpSpPr/>
       <p:sp>
         <p:nvSpPr>
-          <p:cNvPr id="2" name="Rounded Rectangle 1"/>
+          <p:cNvPr id="2" name="Oval 1"/>
           <p:cNvSpPr/>
           <p:nvPr/>
         </p:nvSpPr>
         <p:spPr>
           <a:xfrm>
             <a:off x="548640" y="182880"/>
-            <a:ext cx="2011680" cy="502920"/>
-          </a:xfrm>
-          <a:prstGeom prst="roundRect">
+            <a:ext cx="1371600" cy="731520"/>
+          </a:xfrm>
+          <a:prstGeom prst="ellipse">
             <a:avLst/>
           </a:prstGeom>
           <a:solidFill>
-            <a:srgbClr val="F3E8FF"/>
+            <a:srgbClr val="FFFFFF"/>
           </a:solidFill>
           <a:ln w="19050">
             <a:solidFill>
-              <a:srgbClr val="6D28D9"/>
+              <a:srgbClr val="9333EA"/>
             </a:solidFill>
           </a:ln>
         </p:spPr>
@@ -6878,19 +6539,45 @@
           </a:fontRef>
         </p:style>
         <p:txBody>
-          <a:bodyPr rtlCol="0" anchor="ctr" wrap="none"/>
+          <a:bodyPr rtlCol="0" anchor="ctr" wrap="none" lIns="0" tIns="0" rIns="0" bIns="0"/>
           <a:lstStyle/>
           <a:p>
             <a:pPr algn="ctr">
-              <a:defRPr sz="1100" b="1">
-                <a:solidFill>
-                  <a:srgbClr val="6D28D9"/>
+              <a:defRPr sz="950" b="1">
+                <a:solidFill>
+                  <a:srgbClr val="000000"/>
                 </a:solidFill>
                 <a:latin typeface="Arial"/>
               </a:defRPr>
             </a:pPr>
             <a:r>
-              <a:t>ThermoShield</a:t>
+              <a:t>Team</a:t>
+            </a:r>
+          </a:p>
+          <a:p>
+            <a:pPr algn="ctr">
+              <a:defRPr sz="950" b="1">
+                <a:solidFill>
+                  <a:srgbClr val="000000"/>
+                </a:solidFill>
+                <a:latin typeface="Arial"/>
+              </a:defRPr>
+            </a:pPr>
+            <a:r>
+              <a:t>Thermo-</a:t>
+            </a:r>
+          </a:p>
+          <a:p>
+            <a:pPr algn="ctr">
+              <a:defRPr sz="950" b="1">
+                <a:solidFill>
+                  <a:srgbClr val="000000"/>
+                </a:solidFill>
+                <a:latin typeface="Arial"/>
+              </a:defRPr>
+            </a:pPr>
+            <a:r>
+              <a:t>Shield</a:t>
             </a:r>
           </a:p>
         </p:txBody>
@@ -6903,8 +6590,8 @@
         </p:nvSpPr>
         <p:spPr>
           <a:xfrm>
-            <a:off x="2651760" y="164592"/>
-            <a:ext cx="6858000" cy="548640"/>
+            <a:off x="2286000" y="228600"/>
+            <a:ext cx="7619695" cy="594360"/>
           </a:xfrm>
           <a:prstGeom prst="rect">
             <a:avLst/>
@@ -6918,11 +6605,11 @@
           <a:lstStyle/>
           <a:p>
             <a:pPr algn="ctr">
-              <a:defRPr sz="1700" b="1">
-                <a:solidFill>
-                  <a:srgbClr val="0F172A"/>
-                </a:solidFill>
-                <a:latin typeface="Georgia"/>
+              <a:defRPr sz="1800" b="1">
+                <a:solidFill>
+                  <a:srgbClr val="000000"/>
+                </a:solidFill>
+                <a:latin typeface="Times New Roman"/>
               </a:defRPr>
             </a:pPr>
             <a:r>
@@ -6931,74 +6618,30 @@
           </a:p>
         </p:txBody>
       </p:sp>
-      <p:sp>
-        <p:nvSpPr>
-          <p:cNvPr id="4" name="Rounded Rectangle 3"/>
-          <p:cNvSpPr/>
+      <p:pic>
+        <p:nvPicPr>
+          <p:cNvPr id="4" name="Picture 3" descr="sih_logo_extracted.png"/>
+          <p:cNvPicPr>
+            <a:picLocks noChangeAspect="1"/>
+          </p:cNvPicPr>
           <p:nvPr/>
-        </p:nvSpPr>
-        <p:spPr>
-          <a:xfrm>
-            <a:off x="9601200" y="137160"/>
-            <a:ext cx="2011680" cy="594360"/>
-          </a:xfrm>
-          <a:prstGeom prst="roundRect">
-            <a:avLst/>
-          </a:prstGeom>
-          <a:solidFill>
-            <a:srgbClr val="FEF3C7"/>
-          </a:solidFill>
-          <a:ln w="19050">
-            <a:solidFill>
-              <a:srgbClr val="EA580C"/>
-            </a:solidFill>
-          </a:ln>
-        </p:spPr>
-        <p:style>
-          <a:lnRef idx="1">
-            <a:schemeClr val="accent1"/>
-          </a:lnRef>
-          <a:fillRef idx="3">
-            <a:schemeClr val="accent1"/>
-          </a:fillRef>
-          <a:effectRef idx="2">
-            <a:schemeClr val="accent1"/>
-          </a:effectRef>
-          <a:fontRef idx="minor">
-            <a:schemeClr val="lt1"/>
-          </a:fontRef>
-        </p:style>
-        <p:txBody>
-          <a:bodyPr rtlCol="0" anchor="ctr"/>
-          <a:lstStyle/>
-          <a:p>
-            <a:pPr algn="ctr">
-              <a:defRPr sz="950" b="1">
-                <a:solidFill>
-                  <a:srgbClr val="0F2C59"/>
-                </a:solidFill>
-                <a:latin typeface="Arial"/>
-              </a:defRPr>
-            </a:pPr>
-            <a:r>
-              <a:t>SMART INDIA</a:t>
-            </a:r>
-          </a:p>
-          <a:p>
-            <a:pPr algn="ctr">
-              <a:defRPr sz="950" b="1">
-                <a:solidFill>
-                  <a:srgbClr val="EA580C"/>
-                </a:solidFill>
-                <a:latin typeface="Arial"/>
-              </a:defRPr>
-            </a:pPr>
-            <a:r>
-              <a:t>HACKATHON 2026</a:t>
-            </a:r>
-          </a:p>
-        </p:txBody>
-      </p:sp>
+        </p:nvPicPr>
+        <p:blipFill>
+          <a:blip r:embed="rId2"/>
+          <a:stretch>
+            <a:fillRect/>
+          </a:stretch>
+        </p:blipFill>
+        <p:spPr>
+          <a:xfrm>
+            <a:off x="9875520" y="164592"/>
+            <a:ext cx="1920240" cy="722376"/>
+          </a:xfrm>
+          <a:prstGeom prst="rect">
+            <a:avLst/>
+          </a:prstGeom>
+        </p:spPr>
+      </p:pic>
       <p:sp>
         <p:nvSpPr>
           <p:cNvPr id="5" name="TextBox 4"/>
@@ -7007,7 +6650,7 @@
         </p:nvSpPr>
         <p:spPr>
           <a:xfrm>
-            <a:off x="731520" y="868680"/>
+            <a:off x="731520" y="914400"/>
             <a:ext cx="10728655" cy="685800"/>
           </a:xfrm>
           <a:prstGeom prst="rect">
@@ -7022,29 +6665,14 @@
           <a:lstStyle/>
           <a:p>
             <a:pPr>
-              <a:defRPr sz="1000" b="1">
-                <a:solidFill>
-                  <a:srgbClr val="0F2C59"/>
-                </a:solidFill>
-              </a:defRPr>
-            </a:pPr>
-            <a:r>
-              <a:t>Target Audience — Municipal Commissioners, Chief Medical Officers, Disaster Response Teams (NDMA/SDRF), Gig Workers, Construction Laborers, Urban Slum Residents, General Public.</a:t>
-            </a:r>
-          </a:p>
-          <a:p>
-            <a:pPr>
-              <a:spcBef>
-                <a:spcPts val="200"/>
-              </a:spcBef>
-              <a:defRPr sz="850">
-                <a:solidFill>
-                  <a:srgbClr val="475569"/>
-                </a:solidFill>
-              </a:defRPr>
-            </a:pPr>
-            <a:r>
-              <a:t>(All above stakeholders receive tailored biometeorological intelligence and automated sector-specific action protocols.)</a:t>
+              <a:defRPr sz="1100" b="1">
+                <a:solidFill>
+                  <a:srgbClr val="1D4E89"/>
+                </a:solidFill>
+              </a:defRPr>
+            </a:pPr>
+            <a:r>
+              <a:t>• Potential Impact on the Target Audience (Municipalities, Hospitals, Gig Workers &amp; Vulnerable Citizens)</a:t>
             </a:r>
           </a:p>
         </p:txBody>
@@ -7057,8 +6685,8 @@
         </p:nvSpPr>
         <p:spPr>
           <a:xfrm>
-            <a:off x="731520" y="1600200"/>
-            <a:ext cx="10728655" cy="1280160"/>
+            <a:off x="731520" y="1371600"/>
+            <a:ext cx="10728655" cy="1371600"/>
           </a:xfrm>
           <a:prstGeom prst="roundRect">
             <a:avLst/>
@@ -7093,7 +6721,7 @@
             <a:pPr algn="ctr">
               <a:defRPr sz="1000" b="1">
                 <a:solidFill>
-                  <a:srgbClr val="0F2C59"/>
+                  <a:srgbClr val="1D4E89"/>
                 </a:solidFill>
               </a:defRPr>
             </a:pPr>
@@ -7108,7 +6736,7 @@
               </a:spcBef>
               <a:defRPr sz="850">
                 <a:solidFill>
-                  <a:srgbClr val="0F172A"/>
+                  <a:srgbClr val="1E293B"/>
                 </a:solidFill>
               </a:defRPr>
             </a:pPr>
@@ -7138,8 +6766,8 @@
         </p:nvSpPr>
         <p:spPr>
           <a:xfrm>
-            <a:off x="731520" y="2971800"/>
-            <a:ext cx="3429000" cy="3383280"/>
+            <a:off x="731520" y="2880360"/>
+            <a:ext cx="3429000" cy="3474720"/>
           </a:xfrm>
           <a:prstGeom prst="roundRect">
             <a:avLst/>
@@ -7179,7 +6807,7 @@
               </a:defRPr>
             </a:pPr>
             <a:r>
-              <a:t>● Social Benefits:</a:t>
+              <a:t>• Social Benefits</a:t>
             </a:r>
           </a:p>
           <a:p>
@@ -7189,7 +6817,7 @@
               </a:spcBef>
               <a:defRPr sz="850" b="1">
                 <a:solidFill>
-                  <a:srgbClr val="0F2C59"/>
+                  <a:srgbClr val="1D4E89"/>
                 </a:solidFill>
               </a:defRPr>
             </a:pPr>
@@ -7199,7 +6827,7 @@
             <a:r>
               <a:rPr b="0">
                 <a:solidFill>
-                  <a:srgbClr val="0F172A"/>
+                  <a:srgbClr val="1E293B"/>
                 </a:solidFill>
               </a:rPr>
               <a:t>Dramatically reduces heatstroke morbidity among elderly, children, and chronic disease patients.</a:t>
@@ -7212,7 +6840,7 @@
               </a:spcBef>
               <a:defRPr sz="850" b="1">
                 <a:solidFill>
-                  <a:srgbClr val="0F2C59"/>
+                  <a:srgbClr val="1D4E89"/>
                 </a:solidFill>
               </a:defRPr>
             </a:pPr>
@@ -7222,7 +6850,7 @@
             <a:r>
               <a:rPr b="0">
                 <a:solidFill>
-                  <a:srgbClr val="0F172A"/>
+                  <a:srgbClr val="1E293B"/>
                 </a:solidFill>
               </a:rPr>
               <a:t>Enforces humane work-rest cycles for delivery and construction workers.</a:t>
@@ -7235,7 +6863,7 @@
               </a:spcBef>
               <a:defRPr sz="850" b="1">
                 <a:solidFill>
-                  <a:srgbClr val="0F2C59"/>
+                  <a:srgbClr val="1D4E89"/>
                 </a:solidFill>
               </a:defRPr>
             </a:pPr>
@@ -7245,7 +6873,7 @@
             <a:r>
               <a:rPr b="0">
                 <a:solidFill>
-                  <a:srgbClr val="0F172A"/>
+                  <a:srgbClr val="1E293B"/>
                 </a:solidFill>
               </a:rPr>
               <a:t>Delivers plain-language vernacular guidance via SMS/WhatsApp to eliminate technical barriers.</a:t>
@@ -7261,8 +6889,8 @@
         </p:nvSpPr>
         <p:spPr>
           <a:xfrm>
-            <a:off x="4379976" y="2971800"/>
-            <a:ext cx="3429000" cy="3383280"/>
+            <a:off x="4379976" y="2880360"/>
+            <a:ext cx="3429000" cy="3474720"/>
           </a:xfrm>
           <a:prstGeom prst="roundRect">
             <a:avLst/>
@@ -7302,7 +6930,7 @@
               </a:defRPr>
             </a:pPr>
             <a:r>
-              <a:t>● Economical Benefits:</a:t>
+              <a:t>• Economic Benefits</a:t>
             </a:r>
           </a:p>
           <a:p>
@@ -7312,7 +6940,7 @@
               </a:spcBef>
               <a:defRPr sz="850" b="1">
                 <a:solidFill>
-                  <a:srgbClr val="0F2C59"/>
+                  <a:srgbClr val="1D4E89"/>
                 </a:solidFill>
               </a:defRPr>
             </a:pPr>
@@ -7322,7 +6950,7 @@
             <a:r>
               <a:rPr b="0">
                 <a:solidFill>
-                  <a:srgbClr val="0F172A"/>
+                  <a:srgbClr val="1E293B"/>
                 </a:solidFill>
               </a:rPr>
               <a:t>Mitigates lost labor hours through scheduled morning/evening shifts ($3.8B/yr India heat loss).</a:t>
@@ -7335,7 +6963,7 @@
               </a:spcBef>
               <a:defRPr sz="850" b="1">
                 <a:solidFill>
-                  <a:srgbClr val="0F2C59"/>
+                  <a:srgbClr val="1D4E89"/>
                 </a:solidFill>
               </a:defRPr>
             </a:pPr>
@@ -7345,7 +6973,7 @@
             <a:r>
               <a:rPr b="0">
                 <a:solidFill>
-                  <a:srgbClr val="0F172A"/>
+                  <a:srgbClr val="1E293B"/>
                 </a:solidFill>
               </a:rPr>
               <a:t>Avoids wasteful blanket relief by targeting water tankers to high-vulnerability wards.</a:t>
@@ -7358,7 +6986,7 @@
               </a:spcBef>
               <a:defRPr sz="850" b="1">
                 <a:solidFill>
-                  <a:srgbClr val="0F2C59"/>
+                  <a:srgbClr val="1D4E89"/>
                 </a:solidFill>
               </a:defRPr>
             </a:pPr>
@@ -7368,7 +6996,7 @@
             <a:r>
               <a:rPr b="0">
                 <a:solidFill>
-                  <a:srgbClr val="0F172A"/>
+                  <a:srgbClr val="1E293B"/>
                 </a:solidFill>
               </a:rPr>
               <a:t>Pre-empts severe multi-organ failure and ICU hospitalization surges.</a:t>
@@ -7384,8 +7012,8 @@
         </p:nvSpPr>
         <p:spPr>
           <a:xfrm>
-            <a:off x="8028432" y="2971800"/>
-            <a:ext cx="3429000" cy="3383280"/>
+            <a:off x="8028432" y="2880360"/>
+            <a:ext cx="3429000" cy="3474720"/>
           </a:xfrm>
           <a:prstGeom prst="roundRect">
             <a:avLst/>
@@ -7425,7 +7053,7 @@
               </a:defRPr>
             </a:pPr>
             <a:r>
-              <a:t>● Environmental &amp; Urban Benefits:</a:t>
+              <a:t>• Environmental &amp; Urban Benefits</a:t>
             </a:r>
           </a:p>
           <a:p>
@@ -7435,7 +7063,7 @@
               </a:spcBef>
               <a:defRPr sz="850" b="1">
                 <a:solidFill>
-                  <a:srgbClr val="0F2C59"/>
+                  <a:srgbClr val="1D4E89"/>
                 </a:solidFill>
               </a:defRPr>
             </a:pPr>
@@ -7445,7 +7073,7 @@
             <a:r>
               <a:rPr b="0">
                 <a:solidFill>
-                  <a:srgbClr val="0F172A"/>
+                  <a:srgbClr val="1E293B"/>
                 </a:solidFill>
               </a:rPr>
               <a:t>Identifies micro-urban hot spots and green canopy deficits.</a:t>
@@ -7458,7 +7086,7 @@
               </a:spcBef>
               <a:defRPr sz="850" b="1">
                 <a:solidFill>
-                  <a:srgbClr val="0F2C59"/>
+                  <a:srgbClr val="1D4E89"/>
                 </a:solidFill>
               </a:defRPr>
             </a:pPr>
@@ -7468,7 +7096,7 @@
             <a:r>
               <a:rPr b="0">
                 <a:solidFill>
-                  <a:srgbClr val="0F172A"/>
+                  <a:srgbClr val="1E293B"/>
                 </a:solidFill>
               </a:rPr>
               <a:t>Guides long-term municipal cool roof installations and tree planting programs.</a:t>
@@ -7481,7 +7109,7 @@
               </a:spcBef>
               <a:defRPr sz="850" b="1">
                 <a:solidFill>
-                  <a:srgbClr val="0F2C59"/>
+                  <a:srgbClr val="1D4E89"/>
                 </a:solidFill>
               </a:defRPr>
             </a:pPr>
@@ -7491,7 +7119,7 @@
             <a:r>
               <a:rPr b="0">
                 <a:solidFill>
-                  <a:srgbClr val="0F172A"/>
+                  <a:srgbClr val="1E293B"/>
                 </a:solidFill>
               </a:rPr>
               <a:t>Operationalizes national disaster mitigation at municipal ward scale.</a:t>
@@ -7514,7 +7142,7 @@
             <a:avLst/>
           </a:prstGeom>
           <a:solidFill>
-            <a:srgbClr val="0F2C59"/>
+            <a:srgbClr val="0073C6"/>
           </a:solidFill>
           <a:ln>
             <a:noFill/>
@@ -7641,24 +7269,24 @@
       <p:grpSpPr/>
       <p:sp>
         <p:nvSpPr>
-          <p:cNvPr id="2" name="Rounded Rectangle 1"/>
+          <p:cNvPr id="2" name="Oval 1"/>
           <p:cNvSpPr/>
           <p:nvPr/>
         </p:nvSpPr>
         <p:spPr>
           <a:xfrm>
             <a:off x="548640" y="182880"/>
-            <a:ext cx="2011680" cy="502920"/>
-          </a:xfrm>
-          <a:prstGeom prst="roundRect">
+            <a:ext cx="1371600" cy="731520"/>
+          </a:xfrm>
+          <a:prstGeom prst="ellipse">
             <a:avLst/>
           </a:prstGeom>
           <a:solidFill>
-            <a:srgbClr val="F3E8FF"/>
+            <a:srgbClr val="FFFFFF"/>
           </a:solidFill>
           <a:ln w="19050">
             <a:solidFill>
-              <a:srgbClr val="6D28D9"/>
+              <a:srgbClr val="9333EA"/>
             </a:solidFill>
           </a:ln>
         </p:spPr>
@@ -7677,19 +7305,45 @@
           </a:fontRef>
         </p:style>
         <p:txBody>
-          <a:bodyPr rtlCol="0" anchor="ctr" wrap="none"/>
+          <a:bodyPr rtlCol="0" anchor="ctr" wrap="none" lIns="0" tIns="0" rIns="0" bIns="0"/>
           <a:lstStyle/>
           <a:p>
             <a:pPr algn="ctr">
-              <a:defRPr sz="1100" b="1">
-                <a:solidFill>
-                  <a:srgbClr val="6D28D9"/>
+              <a:defRPr sz="950" b="1">
+                <a:solidFill>
+                  <a:srgbClr val="000000"/>
                 </a:solidFill>
                 <a:latin typeface="Arial"/>
               </a:defRPr>
             </a:pPr>
             <a:r>
-              <a:t>ThermoShield</a:t>
+              <a:t>Team</a:t>
+            </a:r>
+          </a:p>
+          <a:p>
+            <a:pPr algn="ctr">
+              <a:defRPr sz="950" b="1">
+                <a:solidFill>
+                  <a:srgbClr val="000000"/>
+                </a:solidFill>
+                <a:latin typeface="Arial"/>
+              </a:defRPr>
+            </a:pPr>
+            <a:r>
+              <a:t>Thermo-</a:t>
+            </a:r>
+          </a:p>
+          <a:p>
+            <a:pPr algn="ctr">
+              <a:defRPr sz="950" b="1">
+                <a:solidFill>
+                  <a:srgbClr val="000000"/>
+                </a:solidFill>
+                <a:latin typeface="Arial"/>
+              </a:defRPr>
+            </a:pPr>
+            <a:r>
+              <a:t>Shield</a:t>
             </a:r>
           </a:p>
         </p:txBody>
@@ -7702,8 +7356,8 @@
         </p:nvSpPr>
         <p:spPr>
           <a:xfrm>
-            <a:off x="2651760" y="164592"/>
-            <a:ext cx="6858000" cy="548640"/>
+            <a:off x="2286000" y="228600"/>
+            <a:ext cx="7619695" cy="594360"/>
           </a:xfrm>
           <a:prstGeom prst="rect">
             <a:avLst/>
@@ -7717,11 +7371,11 @@
           <a:lstStyle/>
           <a:p>
             <a:pPr algn="ctr">
-              <a:defRPr sz="1700" b="1">
-                <a:solidFill>
-                  <a:srgbClr val="0F172A"/>
-                </a:solidFill>
-                <a:latin typeface="Georgia"/>
+              <a:defRPr sz="1800" b="1">
+                <a:solidFill>
+                  <a:srgbClr val="000000"/>
+                </a:solidFill>
+                <a:latin typeface="Times New Roman"/>
               </a:defRPr>
             </a:pPr>
             <a:r>
@@ -7730,26 +7384,266 @@
           </a:p>
         </p:txBody>
       </p:sp>
-      <p:sp>
-        <p:nvSpPr>
-          <p:cNvPr id="4" name="Rounded Rectangle 3"/>
+      <p:pic>
+        <p:nvPicPr>
+          <p:cNvPr id="4" name="Picture 3" descr="sih_logo_extracted.png"/>
+          <p:cNvPicPr>
+            <a:picLocks noChangeAspect="1"/>
+          </p:cNvPicPr>
+          <p:nvPr/>
+        </p:nvPicPr>
+        <p:blipFill>
+          <a:blip r:embed="rId2"/>
+          <a:stretch>
+            <a:fillRect/>
+          </a:stretch>
+        </p:blipFill>
+        <p:spPr>
+          <a:xfrm>
+            <a:off x="9875520" y="164592"/>
+            <a:ext cx="1920240" cy="722376"/>
+          </a:xfrm>
+          <a:prstGeom prst="rect">
+            <a:avLst/>
+          </a:prstGeom>
+        </p:spPr>
+      </p:pic>
+      <p:sp>
+        <p:nvSpPr>
+          <p:cNvPr id="5" name="TextBox 4"/>
+          <p:cNvSpPr txBox="1"/>
+          <p:nvPr/>
+        </p:nvSpPr>
+        <p:spPr>
+          <a:xfrm>
+            <a:off x="731520" y="914400"/>
+            <a:ext cx="10728655" cy="320040"/>
+          </a:xfrm>
+          <a:prstGeom prst="rect">
+            <a:avLst/>
+          </a:prstGeom>
+          <a:noFill/>
+        </p:spPr>
+        <p:txBody>
+          <a:bodyPr wrap="none" lIns="0" tIns="0" rIns="0" bIns="0">
+            <a:spAutoFit/>
+          </a:bodyPr>
+          <a:lstStyle/>
+          <a:p>
+            <a:pPr>
+              <a:defRPr sz="1150" b="1">
+                <a:solidFill>
+                  <a:srgbClr val="1D4E89"/>
+                </a:solidFill>
+              </a:defRPr>
+            </a:pPr>
+            <a:r>
+              <a:t>• Details / Links of the Reference and Research Work</a:t>
+            </a:r>
+          </a:p>
+        </p:txBody>
+      </p:sp>
+      <p:sp>
+        <p:nvSpPr>
+          <p:cNvPr id="6" name="TextBox 5"/>
+          <p:cNvSpPr txBox="1"/>
+          <p:nvPr/>
+        </p:nvSpPr>
+        <p:spPr>
+          <a:xfrm>
+            <a:off x="731520" y="1234440"/>
+            <a:ext cx="10728655" cy="4297680"/>
+          </a:xfrm>
+          <a:prstGeom prst="rect">
+            <a:avLst/>
+          </a:prstGeom>
+          <a:noFill/>
+        </p:spPr>
+        <p:txBody>
+          <a:bodyPr wrap="square" lIns="0" tIns="0" rIns="0" bIns="0">
+            <a:spAutoFit/>
+          </a:bodyPr>
+          <a:lstStyle/>
+          <a:p>
+            <a:pPr>
+              <a:defRPr sz="950" b="1">
+                <a:solidFill>
+                  <a:srgbClr val="1D4E89"/>
+                </a:solidFill>
+              </a:defRPr>
+            </a:pPr>
+            <a:r>
+              <a:t>• Universal Thermal Climate Index (UTCI) Consortium (WMO / COST Action 730): </a:t>
+            </a:r>
+            <a:r>
+              <a:rPr b="0">
+                <a:solidFill>
+                  <a:srgbClr val="1E293B"/>
+                </a:solidFill>
+              </a:rPr>
+              <a:t>"Development of the Universal Thermal Climate Index (UTCI)", Bröde, Fiala, Błażejczyk et al., Int J Biometeorol (2012). Multi-node thermophysiological polynomial.</a:t>
+            </a:r>
+          </a:p>
+          <a:p>
+            <a:pPr>
+              <a:spcBef>
+                <a:spcPts val="350"/>
+              </a:spcBef>
+              <a:defRPr sz="950" b="1">
+                <a:solidFill>
+                  <a:srgbClr val="1D4E89"/>
+                </a:solidFill>
+              </a:defRPr>
+            </a:pPr>
+            <a:r>
+              <a:t>• Occupational Heat Stress Standards (ISO 7243:2017 &amp; NIOSH): </a:t>
+            </a:r>
+            <a:r>
+              <a:rPr b="0">
+                <a:solidFill>
+                  <a:srgbClr val="1E293B"/>
+                </a:solidFill>
+              </a:rPr>
+              <a:t>"Criteria for a Recommended Standard: Occupational Exposure to Heat and Hot Environments", CDC / NIOSH Publication No. 2016-106. Standard for WBGT thresholds &amp; work-rest cycles.</a:t>
+            </a:r>
+          </a:p>
+          <a:p>
+            <a:pPr>
+              <a:spcBef>
+                <a:spcPts val="350"/>
+              </a:spcBef>
+              <a:defRPr sz="950" b="1">
+                <a:solidFill>
+                  <a:srgbClr val="1D4E89"/>
+                </a:solidFill>
+              </a:defRPr>
+            </a:pPr>
+            <a:r>
+              <a:t>• Epidemiological Heat-Health Grounding in Indian Cities (Ahmedabad 2010): </a:t>
+            </a:r>
+            <a:r>
+              <a:rPr b="0">
+                <a:solidFill>
+                  <a:srgbClr val="1E293B"/>
+                </a:solidFill>
+              </a:rPr>
+              <a:t>"The 2010 Ahmedabad Heat Wave: Impact on Mortality and Strategy for Resilient Cities", Azhar et al., PLoS ONE (2014). Documented 1,344 excess deaths (43.1% surge) validating humidity-heat risk.</a:t>
+            </a:r>
+          </a:p>
+          <a:p>
+            <a:pPr>
+              <a:spcBef>
+                <a:spcPts val="350"/>
+              </a:spcBef>
+              <a:defRPr sz="950" b="1">
+                <a:solidFill>
+                  <a:srgbClr val="1D4E89"/>
+                </a:solidFill>
+              </a:defRPr>
+            </a:pPr>
+            <a:r>
+              <a:t>• 50-Year Multi-Decadal Heat Impact in India (PNAS Reference): </a:t>
+            </a:r>
+            <a:r>
+              <a:rPr b="0">
+                <a:solidFill>
+                  <a:srgbClr val="1E293B"/>
+                </a:solidFill>
+              </a:rPr>
+              <a:t>"Increasing probability of mass-fatality heatwaves in India", Mazdiyasni et al., Proceedings of the National Academy of Sciences (PNAS, 2017). Proving +0.5°C threshold triggers 146% rise in mass mortality events.</a:t>
+            </a:r>
+          </a:p>
+          <a:p>
+            <a:pPr>
+              <a:spcBef>
+                <a:spcPts val="350"/>
+              </a:spcBef>
+              <a:defRPr sz="950" b="1">
+                <a:solidFill>
+                  <a:srgbClr val="1D4E89"/>
+                </a:solidFill>
+              </a:defRPr>
+            </a:pPr>
+            <a:r>
+              <a:t>• National Disaster &amp; Health Policy Guidelines (NDMA &amp; MoHFW NCDC): </a:t>
+            </a:r>
+            <a:r>
+              <a:rPr b="0">
+                <a:solidFill>
+                  <a:srgbClr val="1E293B"/>
+                </a:solidFill>
+              </a:rPr>
+              <a:t>"National Action Plan for Heat-Related Illnesses (NAP-HRI)", National Programme on Climate Change and Human Health (NPCCHH, 2024) &amp; NDMA National Heatwave Guidelines.</a:t>
+            </a:r>
+          </a:p>
+          <a:p>
+            <a:pPr>
+              <a:spcBef>
+                <a:spcPts val="350"/>
+              </a:spcBef>
+              <a:defRPr sz="950" b="1">
+                <a:solidFill>
+                  <a:srgbClr val="1D4E89"/>
+                </a:solidFill>
+              </a:defRPr>
+            </a:pPr>
+            <a:r>
+              <a:t>• NWP &amp; Satellite Climatology Portals: </a:t>
+            </a:r>
+            <a:r>
+              <a:rPr b="0">
+                <a:solidFill>
+                  <a:srgbClr val="1E293B"/>
+                </a:solidFill>
+              </a:rPr>
+              <a:t>National Centre for Medium Range Weather Forecasting (NCMRWF) NWP Portal, IMD Geospatial Bulletins &amp; NASA POWER MERRA-2 (LaRC) 40-Year Climatological Baseline.</a:t>
+            </a:r>
+          </a:p>
+          <a:p>
+            <a:pPr>
+              <a:spcBef>
+                <a:spcPts val="350"/>
+              </a:spcBef>
+              <a:defRPr sz="950" b="1">
+                <a:solidFill>
+                  <a:srgbClr val="1D4E89"/>
+                </a:solidFill>
+              </a:defRPr>
+            </a:pPr>
+            <a:r>
+              <a:t>• Demographic Spatial Vulnerability: </a:t>
+            </a:r>
+            <a:r>
+              <a:rPr b="0">
+                <a:solidFill>
+                  <a:srgbClr val="1E293B"/>
+                </a:solidFill>
+              </a:rPr>
+              <a:t>Census of India 2011 Primary Census Abstract (PCA) Ward Demographics &amp; Open-Meteo High-Resolution Numerical Weather Prediction API.</a:t>
+            </a:r>
+          </a:p>
+        </p:txBody>
+      </p:sp>
+      <p:sp>
+        <p:nvSpPr>
+          <p:cNvPr id="7" name="Rounded Rectangle 6"/>
           <p:cNvSpPr/>
           <p:nvPr/>
         </p:nvSpPr>
         <p:spPr>
           <a:xfrm>
-            <a:off x="9601200" y="137160"/>
-            <a:ext cx="2011680" cy="594360"/>
+            <a:off x="731520" y="5623560"/>
+            <a:ext cx="10728655" cy="731520"/>
           </a:xfrm>
           <a:prstGeom prst="roundRect">
             <a:avLst/>
           </a:prstGeom>
           <a:solidFill>
-            <a:srgbClr val="FEF3C7"/>
+            <a:srgbClr val="F0F9FF"/>
           </a:solidFill>
-          <a:ln w="19050">
+          <a:ln w="15240">
             <a:solidFill>
-              <a:srgbClr val="EA580C"/>
+              <a:srgbClr val="0284C7"/>
             </a:solidFill>
           </a:ln>
         </p:spPr>
@@ -7768,246 +7662,25 @@
           </a:fontRef>
         </p:style>
         <p:txBody>
-          <a:bodyPr rtlCol="0" anchor="ctr"/>
+          <a:bodyPr rtlCol="0" anchor="ctr" wrap="square"/>
           <a:lstStyle/>
           <a:p>
             <a:pPr algn="ctr">
               <a:defRPr sz="950" b="1">
                 <a:solidFill>
-                  <a:srgbClr val="0F2C59"/>
-                </a:solidFill>
-                <a:latin typeface="Arial"/>
-              </a:defRPr>
-            </a:pPr>
-            <a:r>
-              <a:t>SMART INDIA</a:t>
-            </a:r>
-          </a:p>
-          <a:p>
-            <a:pPr algn="ctr">
-              <a:defRPr sz="950" b="1">
-                <a:solidFill>
-                  <a:srgbClr val="EA580C"/>
-                </a:solidFill>
-                <a:latin typeface="Arial"/>
-              </a:defRPr>
-            </a:pPr>
-            <a:r>
-              <a:t>HACKATHON 2026</a:t>
-            </a:r>
-          </a:p>
-        </p:txBody>
-      </p:sp>
-      <p:sp>
-        <p:nvSpPr>
-          <p:cNvPr id="5" name="TextBox 4"/>
-          <p:cNvSpPr txBox="1"/>
-          <p:nvPr/>
-        </p:nvSpPr>
-        <p:spPr>
-          <a:xfrm>
-            <a:off x="731520" y="914400"/>
-            <a:ext cx="10728655" cy="5394960"/>
-          </a:xfrm>
-          <a:prstGeom prst="rect">
-            <a:avLst/>
-          </a:prstGeom>
-          <a:noFill/>
-        </p:spPr>
-        <p:txBody>
-          <a:bodyPr wrap="square" lIns="0" tIns="0" rIns="0" bIns="0">
-            <a:spAutoFit/>
-          </a:bodyPr>
-          <a:lstStyle/>
-          <a:p>
-            <a:pPr>
-              <a:spcBef>
-                <a:spcPts val="350"/>
-              </a:spcBef>
-              <a:defRPr sz="950" b="1">
-                <a:solidFill>
-                  <a:srgbClr val="0F2C59"/>
-                </a:solidFill>
-              </a:defRPr>
-            </a:pPr>
-            <a:r>
-              <a:t>●  Universal Thermal Climate Index (UTCI) Consortium (WMO / COST Action 730): </a:t>
-            </a:r>
-            <a:r>
-              <a:rPr b="0">
-                <a:solidFill>
-                  <a:srgbClr val="0F172A"/>
-                </a:solidFill>
-              </a:rPr>
-              <a:t>"Development of the Universal Thermal Climate Index (UTCI)", Bröde, Fiala, Błażejczyk et al., Int J Biometeorol (2012). Multi-node thermophysiological polynomial.</a:t>
-            </a:r>
-          </a:p>
-          <a:p>
-            <a:pPr>
-              <a:spcBef>
-                <a:spcPts val="350"/>
-              </a:spcBef>
-              <a:defRPr sz="950" b="1">
-                <a:solidFill>
-                  <a:srgbClr val="0F2C59"/>
-                </a:solidFill>
-              </a:defRPr>
-            </a:pPr>
-            <a:r>
-              <a:t>●  Occupational Heat Stress Standards (ISO 7243:2017 &amp; NIOSH): </a:t>
-            </a:r>
-            <a:r>
-              <a:rPr b="0">
-                <a:solidFill>
-                  <a:srgbClr val="0F172A"/>
-                </a:solidFill>
-              </a:rPr>
-              <a:t>"Criteria for a Recommended Standard: Occupational Exposure to Heat and Hot Environments", CDC / NIOSH Publication No. 2016-106. Standard for WBGT thresholds &amp; work-rest cycles.</a:t>
-            </a:r>
-          </a:p>
-          <a:p>
-            <a:pPr>
-              <a:spcBef>
-                <a:spcPts val="350"/>
-              </a:spcBef>
-              <a:defRPr sz="950" b="1">
-                <a:solidFill>
-                  <a:srgbClr val="0F2C59"/>
-                </a:solidFill>
-              </a:defRPr>
-            </a:pPr>
-            <a:r>
-              <a:t>●  Epidemiological Heat-Health Grounding in Indian Cities (Ahmedabad 2010): </a:t>
-            </a:r>
-            <a:r>
-              <a:rPr b="0">
-                <a:solidFill>
-                  <a:srgbClr val="0F172A"/>
-                </a:solidFill>
-              </a:rPr>
-              <a:t>"The 2010 Ahmedabad Heat Wave: Impact on Mortality and Strategy for Resilient Cities", Azhar et al., PLoS ONE (2014). Documented 1,344 excess deaths (43.1% surge) validating humidity-heat risk.</a:t>
-            </a:r>
-          </a:p>
-          <a:p>
-            <a:pPr>
-              <a:spcBef>
-                <a:spcPts val="350"/>
-              </a:spcBef>
-              <a:defRPr sz="950" b="1">
-                <a:solidFill>
-                  <a:srgbClr val="0F2C59"/>
-                </a:solidFill>
-              </a:defRPr>
-            </a:pPr>
-            <a:r>
-              <a:t>●  50-Year Multi-Decadal Heat Impact in India (PNAS Reference): </a:t>
-            </a:r>
-            <a:r>
-              <a:rPr b="0">
-                <a:solidFill>
-                  <a:srgbClr val="0F172A"/>
-                </a:solidFill>
-              </a:rPr>
-              <a:t>"Increasing probability of mass-fatality heatwaves in India", Mazdiyasni et al., Proceedings of the National Academy of Sciences (PNAS, 2017). Proving +0.5°C threshold triggers 146% rise in mass mortality events.</a:t>
-            </a:r>
-          </a:p>
-          <a:p>
-            <a:pPr>
-              <a:spcBef>
-                <a:spcPts val="350"/>
-              </a:spcBef>
-              <a:defRPr sz="950" b="1">
-                <a:solidFill>
-                  <a:srgbClr val="0F2C59"/>
-                </a:solidFill>
-              </a:defRPr>
-            </a:pPr>
-            <a:r>
-              <a:t>●  National Disaster &amp; Health Policy Guidelines (NDMA &amp; MoHFW NCDC): </a:t>
-            </a:r>
-            <a:r>
-              <a:rPr b="0">
-                <a:solidFill>
-                  <a:srgbClr val="0F172A"/>
-                </a:solidFill>
-              </a:rPr>
-              <a:t>"National Action Plan for Heat-Related Illnesses (NAP-HRI)", National Programme on Climate Change and Human Health (NPCCHH, 2024) &amp; NDMA National Heatwave Guidelines.</a:t>
-            </a:r>
-          </a:p>
-          <a:p>
-            <a:pPr>
-              <a:spcBef>
-                <a:spcPts val="350"/>
-              </a:spcBef>
-              <a:defRPr sz="950" b="1">
-                <a:solidFill>
-                  <a:srgbClr val="0F2C59"/>
-                </a:solidFill>
-              </a:defRPr>
-            </a:pPr>
-            <a:r>
-              <a:t>●  NWP &amp; Satellite Climatology Portals: </a:t>
-            </a:r>
-            <a:r>
-              <a:rPr b="0">
-                <a:solidFill>
-                  <a:srgbClr val="0F172A"/>
-                </a:solidFill>
-              </a:rPr>
-              <a:t>National Centre for Medium Range Weather Forecasting (NCMRWF) NWP Portal, IMD Geospatial Bulletins &amp; NASA POWER MERRA-2 (LaRC) 40-Year Climatological Baseline.</a:t>
-            </a:r>
-          </a:p>
-          <a:p>
-            <a:pPr>
-              <a:spcBef>
-                <a:spcPts val="350"/>
-              </a:spcBef>
-              <a:defRPr sz="950" b="1">
-                <a:solidFill>
-                  <a:srgbClr val="0F2C59"/>
-                </a:solidFill>
-              </a:defRPr>
-            </a:pPr>
-            <a:r>
-              <a:t>●  Demographic Spatial Vulnerability: </a:t>
-            </a:r>
-            <a:r>
-              <a:rPr b="0">
-                <a:solidFill>
-                  <a:srgbClr val="0F172A"/>
-                </a:solidFill>
-              </a:rPr>
-              <a:t>Census of India 2011 Primary Census Abstract (PCA) Ward Demographics &amp; Open-Meteo High-Resolution Numerical Weather Prediction API.</a:t>
-            </a:r>
-          </a:p>
-          <a:p>
-            <a:pPr>
-              <a:spcBef>
-                <a:spcPts val="350"/>
-              </a:spcBef>
-              <a:defRPr sz="950" b="1">
-                <a:solidFill>
-                  <a:srgbClr val="0F2C59"/>
-                </a:solidFill>
-              </a:defRPr>
-            </a:pPr>
-            <a:r>
-              <a:t>●  Research Gap Addressed: </a:t>
-            </a:r>
-            <a:r>
-              <a:rPr b="0">
-                <a:solidFill>
-                  <a:srgbClr val="0F172A"/>
-                </a:solidFill>
-              </a:rPr>
-              <a:t>Bridges the operational gap between macro-scale meteorological forecasts and actionable, localized public health interventions by providing an automated impact-to-action intelligence OS.</a:t>
-            </a:r>
-          </a:p>
-        </p:txBody>
-      </p:sp>
-      <p:sp>
-        <p:nvSpPr>
-          <p:cNvPr id="6" name="Rectangle 5"/>
+                  <a:srgbClr val="1D4E89"/>
+                </a:solidFill>
+              </a:defRPr>
+            </a:pPr>
+            <a:r>
+              <a:t>RESEARCH GAP SOLVED: Existing systems provide either macro-weather forecasts OR static vulnerability maps. ThermoShield operationalizes the complete unified pipeline: Forecast → Physiological Thermal Stress → Demographic Vulnerability → Ward Risk → Automated Action.</a:t>
+            </a:r>
+          </a:p>
+        </p:txBody>
+      </p:sp>
+      <p:sp>
+        <p:nvSpPr>
+          <p:cNvPr id="8" name="Rectangle 7"/>
           <p:cNvSpPr/>
           <p:nvPr/>
         </p:nvSpPr>
@@ -8020,7 +7693,7 @@
             <a:avLst/>
           </a:prstGeom>
           <a:solidFill>
-            <a:srgbClr val="0F2C59"/>
+            <a:srgbClr val="0073C6"/>
           </a:solidFill>
           <a:ln>
             <a:noFill/>
@@ -8050,7 +7723,7 @@
       </p:sp>
       <p:sp>
         <p:nvSpPr>
-          <p:cNvPr id="7" name="TextBox 6"/>
+          <p:cNvPr id="9" name="TextBox 8"/>
           <p:cNvSpPr txBox="1"/>
           <p:nvPr/>
         </p:nvSpPr>
@@ -8086,7 +7759,7 @@
       </p:sp>
       <p:sp>
         <p:nvSpPr>
-          <p:cNvPr id="8" name="TextBox 7"/>
+          <p:cNvPr id="10" name="TextBox 9"/>
           <p:cNvSpPr txBox="1"/>
           <p:nvPr/>
         </p:nvSpPr>

</xml_diff>

<commit_message>
docs: finalize master 6-slide SIH2026 presentation deck with high-res architecture diagrams and working prototype figures
</commit_message>
<xml_diff>
--- a/docs/sih/SIH2026_IDEA_Presentation_SIH26083_Official.pptx
+++ b/docs/sih/SIH2026_IDEA_Presentation_SIH26083_Official.pptx
@@ -3153,7 +3153,7 @@
         </p:blipFill>
         <p:spPr>
           <a:xfrm>
-            <a:off x="9875520" y="228600"/>
+            <a:off x="9875520" y="201168"/>
             <a:ext cx="1920240" cy="722376"/>
           </a:xfrm>
           <a:prstGeom prst="rect">
@@ -3230,7 +3230,7 @@
         <p:spPr>
           <a:xfrm>
             <a:off x="731520" y="1645920"/>
-            <a:ext cx="6217920" cy="4572000"/>
+            <a:ext cx="6217920" cy="4114800"/>
           </a:xfrm>
           <a:prstGeom prst="rect">
             <a:avLst/>
@@ -3244,7 +3244,7 @@
           <a:lstStyle/>
           <a:p>
             <a:pPr>
-              <a:defRPr sz="1200" b="1">
+              <a:defRPr sz="1150" b="1">
                 <a:solidFill>
                   <a:srgbClr val="000000"/>
                 </a:solidFill>
@@ -3266,9 +3266,9 @@
           <a:p>
             <a:pPr>
               <a:spcBef>
-                <a:spcPts val="800"/>
+                <a:spcPts val="700"/>
               </a:spcBef>
-              <a:defRPr sz="1200" b="1">
+              <a:defRPr sz="1150" b="1">
                 <a:solidFill>
                   <a:srgbClr val="000000"/>
                 </a:solidFill>
@@ -3290,9 +3290,9 @@
           <a:p>
             <a:pPr>
               <a:spcBef>
-                <a:spcPts val="800"/>
+                <a:spcPts val="700"/>
               </a:spcBef>
-              <a:defRPr sz="1200" b="1">
+              <a:defRPr sz="1150" b="1">
                 <a:solidFill>
                   <a:srgbClr val="000000"/>
                 </a:solidFill>
@@ -3314,9 +3314,9 @@
           <a:p>
             <a:pPr>
               <a:spcBef>
-                <a:spcPts val="800"/>
+                <a:spcPts val="700"/>
               </a:spcBef>
-              <a:defRPr sz="1200" b="1">
+              <a:defRPr sz="1150" b="1">
                 <a:solidFill>
                   <a:srgbClr val="000000"/>
                 </a:solidFill>
@@ -3338,9 +3338,9 @@
           <a:p>
             <a:pPr>
               <a:spcBef>
-                <a:spcPts val="800"/>
+                <a:spcPts val="700"/>
               </a:spcBef>
-              <a:defRPr sz="1200" b="1">
+              <a:defRPr sz="1150" b="1">
                 <a:solidFill>
                   <a:srgbClr val="000000"/>
                 </a:solidFill>
@@ -3362,9 +3362,9 @@
           <a:p>
             <a:pPr>
               <a:spcBef>
-                <a:spcPts val="800"/>
+                <a:spcPts val="700"/>
               </a:spcBef>
-              <a:defRPr sz="1200" b="1">
+              <a:defRPr sz="1150" b="1">
                 <a:solidFill>
                   <a:srgbClr val="000000"/>
                 </a:solidFill>
@@ -3386,9 +3386,9 @@
           <a:p>
             <a:pPr>
               <a:spcBef>
-                <a:spcPts val="800"/>
+                <a:spcPts val="700"/>
               </a:spcBef>
-              <a:defRPr sz="1200" b="1">
+              <a:defRPr sz="1150" b="1">
                 <a:solidFill>
                   <a:srgbClr val="000000"/>
                 </a:solidFill>
@@ -3417,7 +3417,7 @@
         </p:nvSpPr>
         <p:spPr>
           <a:xfrm>
-            <a:off x="731520" y="5212080"/>
+            <a:off x="731520" y="5166360"/>
             <a:ext cx="6035040" cy="1188720"/>
           </a:xfrm>
           <a:prstGeom prst="roundRect">
@@ -3516,8 +3516,8 @@
         </p:nvSpPr>
         <p:spPr>
           <a:xfrm>
-            <a:off x="548640" y="182880"/>
-            <a:ext cx="1371600" cy="731520"/>
+            <a:off x="548640" y="164592"/>
+            <a:ext cx="1371600" cy="685800"/>
           </a:xfrm>
           <a:prstGeom prst="ellipse">
             <a:avLst/>
@@ -3550,7 +3550,7 @@
           <a:lstStyle/>
           <a:p>
             <a:pPr algn="ctr">
-              <a:defRPr sz="950" b="1">
+              <a:defRPr sz="900" b="1">
                 <a:solidFill>
                   <a:srgbClr val="000000"/>
                 </a:solidFill>
@@ -3563,7 +3563,7 @@
           </a:p>
           <a:p>
             <a:pPr algn="ctr">
-              <a:defRPr sz="950" b="1">
+              <a:defRPr sz="900" b="1">
                 <a:solidFill>
                   <a:srgbClr val="000000"/>
                 </a:solidFill>
@@ -3576,7 +3576,7 @@
           </a:p>
           <a:p>
             <a:pPr algn="ctr">
-              <a:defRPr sz="950" b="1">
+              <a:defRPr sz="900" b="1">
                 <a:solidFill>
                   <a:srgbClr val="000000"/>
                 </a:solidFill>
@@ -3597,8 +3597,8 @@
         </p:nvSpPr>
         <p:spPr>
           <a:xfrm>
-            <a:off x="2286000" y="228600"/>
-            <a:ext cx="7619695" cy="594360"/>
+            <a:off x="2194560" y="182880"/>
+            <a:ext cx="7589520" cy="594360"/>
           </a:xfrm>
           <a:prstGeom prst="rect">
             <a:avLst/>
@@ -3612,7 +3612,7 @@
           <a:lstStyle/>
           <a:p>
             <a:pPr algn="ctr">
-              <a:defRPr sz="1800" b="1">
+              <a:defRPr sz="1700" b="1">
                 <a:solidFill>
                   <a:srgbClr val="000000"/>
                 </a:solidFill>
@@ -3641,7 +3641,7 @@
         </p:blipFill>
         <p:spPr>
           <a:xfrm>
-            <a:off x="9875520" y="164592"/>
+            <a:off x="9875520" y="137160"/>
             <a:ext cx="1920240" cy="722376"/>
           </a:xfrm>
           <a:prstGeom prst="rect">
@@ -3657,8 +3657,8 @@
         </p:nvSpPr>
         <p:spPr>
           <a:xfrm>
-            <a:off x="731520" y="1051560"/>
-            <a:ext cx="10728655" cy="411480"/>
+            <a:off x="731520" y="960120"/>
+            <a:ext cx="10728655" cy="320040"/>
           </a:xfrm>
           <a:prstGeom prst="rect">
             <a:avLst/>
@@ -3672,7 +3672,7 @@
           <a:lstStyle/>
           <a:p>
             <a:pPr>
-              <a:defRPr sz="1200" b="1" u="sng">
+              <a:defRPr sz="1100" b="1" u="sng">
                 <a:solidFill>
                   <a:srgbClr val="1D4E89"/>
                 </a:solidFill>
@@ -3685,16 +3685,40 @@
           </a:p>
         </p:txBody>
       </p:sp>
-      <p:sp>
-        <p:nvSpPr>
-          <p:cNvPr id="6" name="Rounded Rectangle 5"/>
+      <p:pic>
+        <p:nvPicPr>
+          <p:cNvPr id="6" name="Picture 5" descr="slide2_flowchart.png"/>
+          <p:cNvPicPr>
+            <a:picLocks noChangeAspect="1"/>
+          </p:cNvPicPr>
+          <p:nvPr/>
+        </p:nvPicPr>
+        <p:blipFill>
+          <a:blip r:embed="rId3"/>
+          <a:stretch>
+            <a:fillRect/>
+          </a:stretch>
+        </p:blipFill>
+        <p:spPr>
+          <a:xfrm>
+            <a:off x="731520" y="1298448"/>
+            <a:ext cx="10728655" cy="1691640"/>
+          </a:xfrm>
+          <a:prstGeom prst="rect">
+            <a:avLst/>
+          </a:prstGeom>
+        </p:spPr>
+      </p:pic>
+      <p:sp>
+        <p:nvSpPr>
+          <p:cNvPr id="7" name="Rounded Rectangle 6"/>
           <p:cNvSpPr/>
           <p:nvPr/>
         </p:nvSpPr>
         <p:spPr>
           <a:xfrm>
-            <a:off x="731520" y="1508760"/>
-            <a:ext cx="3429000" cy="4297680"/>
+            <a:off x="731520" y="3063240"/>
+            <a:ext cx="3429000" cy="3246120"/>
           </a:xfrm>
           <a:prstGeom prst="roundRect">
             <a:avLst/>
@@ -3732,14 +3756,14 @@
       </p:sp>
       <p:sp>
         <p:nvSpPr>
-          <p:cNvPr id="7" name="Rounded Rectangle 6"/>
+          <p:cNvPr id="8" name="Rounded Rectangle 7"/>
           <p:cNvSpPr/>
           <p:nvPr/>
         </p:nvSpPr>
         <p:spPr>
           <a:xfrm>
-            <a:off x="804672" y="1581912"/>
-            <a:ext cx="3282696" cy="384048"/>
+            <a:off x="786384" y="3127248"/>
+            <a:ext cx="3319272" cy="320040"/>
           </a:xfrm>
           <a:prstGeom prst="roundRect">
             <a:avLst/>
@@ -3772,7 +3796,7 @@
           <a:lstStyle/>
           <a:p>
             <a:pPr algn="ctr">
-              <a:defRPr sz="1000" b="1">
+              <a:defRPr sz="950" b="1">
                 <a:solidFill>
                   <a:srgbClr val="1D4E89"/>
                 </a:solidFill>
@@ -3786,14 +3810,14 @@
       </p:sp>
       <p:sp>
         <p:nvSpPr>
-          <p:cNvPr id="8" name="TextBox 7"/>
+          <p:cNvPr id="9" name="TextBox 8"/>
           <p:cNvSpPr txBox="1"/>
           <p:nvPr/>
         </p:nvSpPr>
         <p:spPr>
           <a:xfrm>
-            <a:off x="868680" y="2057400"/>
-            <a:ext cx="3154680" cy="3566160"/>
+            <a:off x="841248" y="3520440"/>
+            <a:ext cx="3209544" cy="2743200"/>
           </a:xfrm>
           <a:prstGeom prst="rect">
             <a:avLst/>
@@ -3807,7 +3831,7 @@
           <a:lstStyle/>
           <a:p>
             <a:pPr>
-              <a:defRPr sz="900" b="1">
+              <a:defRPr sz="850" b="1">
                 <a:solidFill>
                   <a:srgbClr val="1D4E89"/>
                 </a:solidFill>
@@ -3822,15 +3846,15 @@
                   <a:srgbClr val="1E293B"/>
                 </a:solidFill>
               </a:rPr>
-              <a:t>Fuses 5-Day hourly NWP forecasts (T, RH, Wind, Solar Radiation) with Census 2011 PCA ward demographics.</a:t>
+              <a:t>Fuses 5-Day hourly NWP forecasts (T, RH, Wind, Rad) with Census 2011 PCA demographics.</a:t>
             </a:r>
           </a:p>
           <a:p>
             <a:pPr>
               <a:spcBef>
-                <a:spcPts val="400"/>
+                <a:spcPts val="300"/>
               </a:spcBef>
-              <a:defRPr sz="900" b="1">
+              <a:defRPr sz="850" b="1">
                 <a:solidFill>
                   <a:srgbClr val="1D4E89"/>
                 </a:solidFill>
@@ -3845,15 +3869,15 @@
                   <a:srgbClr val="1E293B"/>
                 </a:solidFill>
               </a:rPr>
-              <a:t>Universal Thermal Climate Index (6th-order polynomial based on Fiala 187-node human body model).</a:t>
+              <a:t>Universal Thermal Climate Index (6th-order polynomial based on Fiala 187-node model).</a:t>
             </a:r>
           </a:p>
           <a:p>
             <a:pPr>
               <a:spcBef>
-                <a:spcPts val="400"/>
+                <a:spcPts val="300"/>
               </a:spcBef>
-              <a:defRPr sz="900" b="1">
+              <a:defRPr sz="850" b="1">
                 <a:solidFill>
                   <a:srgbClr val="1D4E89"/>
                 </a:solidFill>
@@ -3868,22 +3892,22 @@
                   <a:srgbClr val="1E293B"/>
                 </a:solidFill>
               </a:rPr>
-              <a:t>Natural wet bulb (Stull) and globe temperature (Liljegren) for occupational and outdoor labor heat stress.</a:t>
+              <a:t>Natural wet bulb (Stull) and globe temp (Liljegren) for occupational and outdoor labor stress.</a:t>
             </a:r>
           </a:p>
           <a:p>
             <a:pPr>
               <a:spcBef>
-                <a:spcPts val="400"/>
+                <a:spcPts val="300"/>
               </a:spcBef>
-              <a:defRPr sz="900" b="1">
+              <a:defRPr sz="850" b="1">
                 <a:solidFill>
                   <a:srgbClr val="1D4E89"/>
                 </a:solidFill>
               </a:defRPr>
             </a:pPr>
             <a:r>
-              <a:t>❖  Multi-Day Persistence Penalty: </a:t>
+              <a:t>❖  Multi-Day Persistence: </a:t>
             </a:r>
             <a:r>
               <a:rPr b="0">
@@ -3891,21 +3915,21 @@
                   <a:srgbClr val="1E293B"/>
                 </a:solidFill>
               </a:rPr>
-              <a:t>Applies exponential duration multiplier (Dmult) and uncooled night penalty (Tmin &gt; 28°C).</a:t>
-            </a:r>
-          </a:p>
-        </p:txBody>
-      </p:sp>
-      <p:sp>
-        <p:nvSpPr>
-          <p:cNvPr id="9" name="Rounded Rectangle 8"/>
+              <a:t>Exponential duration multiplier (Dmult) and uncooled night penalty (Tmin &gt; 28°C).</a:t>
+            </a:r>
+          </a:p>
+        </p:txBody>
+      </p:sp>
+      <p:sp>
+        <p:nvSpPr>
+          <p:cNvPr id="10" name="Rounded Rectangle 9"/>
           <p:cNvSpPr/>
           <p:nvPr/>
         </p:nvSpPr>
         <p:spPr>
           <a:xfrm>
-            <a:off x="4379976" y="1508760"/>
-            <a:ext cx="3429000" cy="4297680"/>
+            <a:off x="4379976" y="3063240"/>
+            <a:ext cx="3429000" cy="3246120"/>
           </a:xfrm>
           <a:prstGeom prst="roundRect">
             <a:avLst/>
@@ -3943,14 +3967,14 @@
       </p:sp>
       <p:sp>
         <p:nvSpPr>
-          <p:cNvPr id="10" name="Rounded Rectangle 9"/>
+          <p:cNvPr id="11" name="Rounded Rectangle 10"/>
           <p:cNvSpPr/>
           <p:nvPr/>
         </p:nvSpPr>
         <p:spPr>
           <a:xfrm>
-            <a:off x="4453128" y="1581912"/>
-            <a:ext cx="3282696" cy="384048"/>
+            <a:off x="4434840" y="3127248"/>
+            <a:ext cx="3319272" cy="320040"/>
           </a:xfrm>
           <a:prstGeom prst="roundRect">
             <a:avLst/>
@@ -3983,7 +4007,7 @@
           <a:lstStyle/>
           <a:p>
             <a:pPr algn="ctr">
-              <a:defRPr sz="1000" b="1">
+              <a:defRPr sz="950" b="1">
                 <a:solidFill>
                   <a:srgbClr val="1D4E89"/>
                 </a:solidFill>
@@ -3997,14 +4021,14 @@
       </p:sp>
       <p:sp>
         <p:nvSpPr>
-          <p:cNvPr id="11" name="TextBox 10"/>
+          <p:cNvPr id="12" name="TextBox 11"/>
           <p:cNvSpPr txBox="1"/>
           <p:nvPr/>
         </p:nvSpPr>
         <p:spPr>
           <a:xfrm>
-            <a:off x="4517136" y="2057400"/>
-            <a:ext cx="3154680" cy="3566160"/>
+            <a:off x="4489704" y="3520440"/>
+            <a:ext cx="3209544" cy="2743200"/>
           </a:xfrm>
           <a:prstGeom prst="rect">
             <a:avLst/>
@@ -4018,14 +4042,14 @@
           <a:lstStyle/>
           <a:p>
             <a:pPr>
-              <a:defRPr sz="900" b="1">
+              <a:defRPr sz="850" b="1">
                 <a:solidFill>
                   <a:srgbClr val="1D4E89"/>
                 </a:solidFill>
               </a:defRPr>
             </a:pPr>
             <a:r>
-              <a:t>❖  Human Impact vs Raw Weather: </a:t>
+              <a:t>❖  Human Impact vs Weather: </a:t>
             </a:r>
             <a:r>
               <a:rPr b="0">
@@ -4033,15 +4057,15 @@
                   <a:srgbClr val="1E293B"/>
                 </a:solidFill>
               </a:rPr>
-              <a:t>Overcomes the deadly flaw of dry-bulb warnings where 40°C with high humidity breaks thermoregulation.</a:t>
+              <a:t>Overcomes dry-bulb limitations where 40°C with high humidity breaks thermoregulation.</a:t>
             </a:r>
           </a:p>
           <a:p>
             <a:pPr>
               <a:spcBef>
-                <a:spcPts val="400"/>
+                <a:spcPts val="300"/>
               </a:spcBef>
-              <a:defRPr sz="900" b="1">
+              <a:defRPr sz="850" b="1">
                 <a:solidFill>
                   <a:srgbClr val="1D4E89"/>
                 </a:solidFill>
@@ -4056,15 +4080,15 @@
                   <a:srgbClr val="1E293B"/>
                 </a:solidFill>
               </a:rPr>
-              <a:t>Differentiates shaded affluent residential areas from informal settlements with tin roofs and high worker density.</a:t>
+              <a:t>Differentiates shaded affluent zones from informal settlements with tin roofs.</a:t>
             </a:r>
           </a:p>
           <a:p>
             <a:pPr>
               <a:spcBef>
-                <a:spcPts val="400"/>
+                <a:spcPts val="300"/>
               </a:spcBef>
-              <a:defRPr sz="900" b="1">
+              <a:defRPr sz="850" b="1">
                 <a:solidFill>
                   <a:srgbClr val="1D4E89"/>
                 </a:solidFill>
@@ -4079,15 +4103,15 @@
                   <a:srgbClr val="1E293B"/>
                 </a:solidFill>
               </a:rPr>
-              <a:t>Calibrated against Indian heat-mortality literature (Azhar et al. 2014 &amp; Mazdiyasni et al. 2017).</a:t>
+              <a:t>Calibrated against Indian empirical studies (Azhar 2014 &amp; Mazdiyasni 2017).</a:t>
             </a:r>
           </a:p>
           <a:p>
             <a:pPr>
               <a:spcBef>
-                <a:spcPts val="400"/>
+                <a:spcPts val="300"/>
               </a:spcBef>
-              <a:defRPr sz="900" b="1">
+              <a:defRPr sz="850" b="1">
                 <a:solidFill>
                   <a:srgbClr val="1D4E89"/>
                 </a:solidFill>
@@ -4109,14 +4133,14 @@
       </p:sp>
       <p:sp>
         <p:nvSpPr>
-          <p:cNvPr id="12" name="Rounded Rectangle 11"/>
+          <p:cNvPr id="13" name="Rounded Rectangle 12"/>
           <p:cNvSpPr/>
           <p:nvPr/>
         </p:nvSpPr>
         <p:spPr>
           <a:xfrm>
-            <a:off x="8028432" y="1508760"/>
-            <a:ext cx="3429000" cy="4297680"/>
+            <a:off x="8028432" y="3063240"/>
+            <a:ext cx="3429000" cy="3246120"/>
           </a:xfrm>
           <a:prstGeom prst="roundRect">
             <a:avLst/>
@@ -4154,14 +4178,14 @@
       </p:sp>
       <p:sp>
         <p:nvSpPr>
-          <p:cNvPr id="13" name="Rounded Rectangle 12"/>
+          <p:cNvPr id="14" name="Rounded Rectangle 13"/>
           <p:cNvSpPr/>
           <p:nvPr/>
         </p:nvSpPr>
         <p:spPr>
           <a:xfrm>
-            <a:off x="8101584" y="1581912"/>
-            <a:ext cx="3282696" cy="384048"/>
+            <a:off x="8083296" y="3127248"/>
+            <a:ext cx="3319272" cy="320040"/>
           </a:xfrm>
           <a:prstGeom prst="roundRect">
             <a:avLst/>
@@ -4194,7 +4218,7 @@
           <a:lstStyle/>
           <a:p>
             <a:pPr algn="ctr">
-              <a:defRPr sz="1000" b="1">
+              <a:defRPr sz="950" b="1">
                 <a:solidFill>
                   <a:srgbClr val="1D4E89"/>
                 </a:solidFill>
@@ -4208,14 +4232,14 @@
       </p:sp>
       <p:sp>
         <p:nvSpPr>
-          <p:cNvPr id="14" name="TextBox 13"/>
+          <p:cNvPr id="15" name="TextBox 14"/>
           <p:cNvSpPr txBox="1"/>
           <p:nvPr/>
         </p:nvSpPr>
         <p:spPr>
           <a:xfrm>
-            <a:off x="8165592" y="2057400"/>
-            <a:ext cx="3154680" cy="3566160"/>
+            <a:off x="8138160" y="3520440"/>
+            <a:ext cx="3209544" cy="2743200"/>
           </a:xfrm>
           <a:prstGeom prst="rect">
             <a:avLst/>
@@ -4229,14 +4253,14 @@
           <a:lstStyle/>
           <a:p>
             <a:pPr>
-              <a:defRPr sz="900" b="1">
+              <a:defRPr sz="850" b="1">
                 <a:solidFill>
                   <a:srgbClr val="1D4E89"/>
                 </a:solidFill>
               </a:defRPr>
             </a:pPr>
             <a:r>
-              <a:t>❖  72h–120h Pre-Emptive Lead Time: </a:t>
+              <a:t>❖  72h–120h Pre-Emptive Window: </a:t>
             </a:r>
             <a:r>
               <a:rPr b="0">
@@ -4244,15 +4268,15 @@
                   <a:srgbClr val="1E293B"/>
                 </a:solidFill>
               </a:rPr>
-              <a:t>3–5 day anticipation enabling municipal water tankers and cooling shelters to be prepositioned.</a:t>
+              <a:t>3–5 day anticipation enabling municipal water tankers and cooling shelters to be staged.</a:t>
             </a:r>
           </a:p>
           <a:p>
             <a:pPr>
               <a:spcBef>
-                <a:spcPts val="400"/>
+                <a:spcPts val="300"/>
               </a:spcBef>
-              <a:defRPr sz="900" b="1">
+              <a:defRPr sz="850" b="1">
                 <a:solidFill>
                   <a:srgbClr val="1D4E89"/>
                 </a:solidFill>
@@ -4267,15 +4291,15 @@
                   <a:srgbClr val="1E293B"/>
                 </a:solidFill>
               </a:rPr>
-              <a:t>Converts risk into hospital surge bed alerts, DISCOM load warnings, and NIOSH labor halts (11 AM–4 PM).</a:t>
+              <a:t>Converts risk into hospital surge beds, DISCOM load warnings, and NIOSH labor halts.</a:t>
             </a:r>
           </a:p>
           <a:p>
             <a:pPr>
               <a:spcBef>
-                <a:spcPts val="400"/>
+                <a:spcPts val="300"/>
               </a:spcBef>
-              <a:defRPr sz="900" b="1">
+              <a:defRPr sz="850" b="1">
                 <a:solidFill>
                   <a:srgbClr val="1D4E89"/>
                 </a:solidFill>
@@ -4296,16 +4320,16 @@
           <a:p>
             <a:pPr>
               <a:spcBef>
-                <a:spcPts val="400"/>
+                <a:spcPts val="300"/>
               </a:spcBef>
-              <a:defRPr sz="900" b="1">
+              <a:defRPr sz="850" b="1">
                 <a:solidFill>
                   <a:srgbClr val="1D4E89"/>
                 </a:solidFill>
               </a:defRPr>
             </a:pPr>
             <a:r>
-              <a:t>❖  High-Performance Open Stack: </a:t>
+              <a:t>❖  Production Open Stack: </a:t>
             </a:r>
             <a:r>
               <a:rPr b="0">
@@ -4313,61 +4337,7 @@
                   <a:srgbClr val="1E293B"/>
                 </a:solidFill>
               </a:rPr>
-              <a:t>25 production REST APIs with sub-second latency and zero proprietary software licensing.</a:t>
-            </a:r>
-          </a:p>
-        </p:txBody>
-      </p:sp>
-      <p:sp>
-        <p:nvSpPr>
-          <p:cNvPr id="15" name="Rounded Rectangle 14"/>
-          <p:cNvSpPr/>
-          <p:nvPr/>
-        </p:nvSpPr>
-        <p:spPr>
-          <a:xfrm>
-            <a:off x="731520" y="5897880"/>
-            <a:ext cx="10728655" cy="457200"/>
-          </a:xfrm>
-          <a:prstGeom prst="roundRect">
-            <a:avLst/>
-          </a:prstGeom>
-          <a:solidFill>
-            <a:srgbClr val="F0F9FF"/>
-          </a:solidFill>
-          <a:ln w="15240">
-            <a:solidFill>
-              <a:srgbClr val="0284C7"/>
-            </a:solidFill>
-          </a:ln>
-        </p:spPr>
-        <p:style>
-          <a:lnRef idx="1">
-            <a:schemeClr val="accent1"/>
-          </a:lnRef>
-          <a:fillRef idx="3">
-            <a:schemeClr val="accent1"/>
-          </a:fillRef>
-          <a:effectRef idx="2">
-            <a:schemeClr val="accent1"/>
-          </a:effectRef>
-          <a:fontRef idx="minor">
-            <a:schemeClr val="lt1"/>
-          </a:fontRef>
-        </p:style>
-        <p:txBody>
-          <a:bodyPr rtlCol="0" anchor="ctr"/>
-          <a:lstStyle/>
-          <a:p>
-            <a:pPr algn="ctr">
-              <a:defRPr sz="1000" b="1">
-                <a:solidFill>
-                  <a:srgbClr val="1D4E89"/>
-                </a:solidFill>
-              </a:defRPr>
-            </a:pPr>
-            <a:r>
-              <a:t>KEY USP: Not another static heat map — an automated, end-to-end impact-to-action intelligence OS for heatwave resilience.</a:t>
+              <a:t>25 REST APIs with sub-second latency and zero proprietary software licensing.</a:t>
             </a:r>
           </a:p>
         </p:txBody>
@@ -4520,8 +4490,8 @@
         </p:nvSpPr>
         <p:spPr>
           <a:xfrm>
-            <a:off x="548640" y="182880"/>
-            <a:ext cx="1371600" cy="731520"/>
+            <a:off x="548640" y="164592"/>
+            <a:ext cx="1371600" cy="685800"/>
           </a:xfrm>
           <a:prstGeom prst="ellipse">
             <a:avLst/>
@@ -4554,7 +4524,7 @@
           <a:lstStyle/>
           <a:p>
             <a:pPr algn="ctr">
-              <a:defRPr sz="950" b="1">
+              <a:defRPr sz="900" b="1">
                 <a:solidFill>
                   <a:srgbClr val="000000"/>
                 </a:solidFill>
@@ -4567,7 +4537,7 @@
           </a:p>
           <a:p>
             <a:pPr algn="ctr">
-              <a:defRPr sz="950" b="1">
+              <a:defRPr sz="900" b="1">
                 <a:solidFill>
                   <a:srgbClr val="000000"/>
                 </a:solidFill>
@@ -4580,7 +4550,7 @@
           </a:p>
           <a:p>
             <a:pPr algn="ctr">
-              <a:defRPr sz="950" b="1">
+              <a:defRPr sz="900" b="1">
                 <a:solidFill>
                   <a:srgbClr val="000000"/>
                 </a:solidFill>
@@ -4601,8 +4571,8 @@
         </p:nvSpPr>
         <p:spPr>
           <a:xfrm>
-            <a:off x="2286000" y="228600"/>
-            <a:ext cx="7619695" cy="594360"/>
+            <a:off x="2194560" y="182880"/>
+            <a:ext cx="7589520" cy="594360"/>
           </a:xfrm>
           <a:prstGeom prst="rect">
             <a:avLst/>
@@ -4616,7 +4586,7 @@
           <a:lstStyle/>
           <a:p>
             <a:pPr algn="ctr">
-              <a:defRPr sz="1800" b="1">
+              <a:defRPr sz="1700" b="1">
                 <a:solidFill>
                   <a:srgbClr val="000000"/>
                 </a:solidFill>
@@ -4645,7 +4615,7 @@
         </p:blipFill>
         <p:spPr>
           <a:xfrm>
-            <a:off x="9875520" y="164592"/>
+            <a:off x="9875520" y="137160"/>
             <a:ext cx="1920240" cy="722376"/>
           </a:xfrm>
           <a:prstGeom prst="rect">
@@ -4661,8 +4631,8 @@
         </p:nvSpPr>
         <p:spPr>
           <a:xfrm>
-            <a:off x="731520" y="1051560"/>
-            <a:ext cx="10728655" cy="320040"/>
+            <a:off x="731520" y="960120"/>
+            <a:ext cx="10728655" cy="274320"/>
           </a:xfrm>
           <a:prstGeom prst="rect">
             <a:avLst/>
@@ -4676,7 +4646,7 @@
           <a:lstStyle/>
           <a:p>
             <a:pPr>
-              <a:defRPr sz="1150" b="1">
+              <a:defRPr sz="1100" b="1">
                 <a:solidFill>
                   <a:srgbClr val="1D4E89"/>
                 </a:solidFill>
@@ -4684,7 +4654,7 @@
               </a:defRPr>
             </a:pPr>
             <a:r>
-              <a:t>• Methodology and Process for Implementation (Flow Chart &amp; Working Prototype Architecture)</a:t>
+              <a:t>• Methodology &amp; Implementation Process (Working Prototype Architecture &amp; Live GIS Output)</a:t>
             </a:r>
           </a:p>
         </p:txBody>
@@ -4697,8 +4667,8 @@
         </p:nvSpPr>
         <p:spPr>
           <a:xfrm>
-            <a:off x="731520" y="1417320"/>
-            <a:ext cx="2542032" cy="3154680"/>
+            <a:off x="731520" y="1280160"/>
+            <a:ext cx="5120640" cy="3200400"/>
           </a:xfrm>
           <a:prstGeom prst="roundRect">
             <a:avLst/>
@@ -4708,7 +4678,7 @@
           </a:solidFill>
           <a:ln w="19050">
             <a:solidFill>
-              <a:srgbClr val="EA580C"/>
+              <a:srgbClr val="0284C7"/>
             </a:solidFill>
           </a:ln>
         </p:spPr>
@@ -4727,33 +4697,158 @@
           </a:fontRef>
         </p:style>
         <p:txBody>
-          <a:bodyPr rtlCol="0" anchor="ctr"/>
-          <a:lstStyle/>
-          <a:p>
-            <a:pPr algn="ctr"/>
-          </a:p>
-        </p:txBody>
-      </p:sp>
-      <p:sp>
-        <p:nvSpPr>
-          <p:cNvPr id="7" name="Rounded Rectangle 6"/>
+          <a:bodyPr rtlCol="0" anchor="ctr" wrap="square" lIns="0" tIns="0" rIns="0" bIns="0"/>
+          <a:lstStyle/>
+          <a:p>
+            <a:pPr algn="ctr">
+              <a:defRPr sz="1000" b="1">
+                <a:solidFill>
+                  <a:srgbClr val="1D4E89"/>
+                </a:solidFill>
+              </a:defRPr>
+            </a:pPr>
+            <a:r>
+              <a:t>4-STAGE COMPUTATIONAL PIPELINE</a:t>
+            </a:r>
+          </a:p>
+          <a:p>
+            <a:pPr>
+              <a:spcBef>
+                <a:spcPts val="300"/>
+              </a:spcBef>
+              <a:defRPr sz="850" b="1">
+                <a:solidFill>
+                  <a:srgbClr val="1D4E89"/>
+                </a:solidFill>
+              </a:defRPr>
+            </a:pPr>
+            <a:r>
+              <a:t>• 1. Ingestion: </a:t>
+            </a:r>
+            <a:r>
+              <a:rPr b="0">
+                <a:solidFill>
+                  <a:srgbClr val="1E293B"/>
+                </a:solidFill>
+              </a:rPr>
+              <a:t>Open-Meteo 0.1° NWP 5-day hourly weather + NASA POWER 40-yr baseline + Census 2011 PCA demographics.</a:t>
+            </a:r>
+          </a:p>
+          <a:p>
+            <a:pPr>
+              <a:spcBef>
+                <a:spcPts val="300"/>
+              </a:spcBef>
+              <a:defRPr sz="850" b="1">
+                <a:solidFill>
+                  <a:srgbClr val="1D4E89"/>
+                </a:solidFill>
+              </a:defRPr>
+            </a:pPr>
+            <a:r>
+              <a:t>• 2. Thermal Engine: </a:t>
+            </a:r>
+            <a:r>
+              <a:rPr b="0">
+                <a:solidFill>
+                  <a:srgbClr val="1E293B"/>
+                </a:solidFill>
+              </a:rPr>
+              <a:t>UTCI 6th-order polynomial (Fiala) + ISO 7243 WBGT psychrometrics + Multi-day persistence penalty (Dmult).</a:t>
+            </a:r>
+          </a:p>
+          <a:p>
+            <a:pPr>
+              <a:spcBef>
+                <a:spcPts val="300"/>
+              </a:spcBef>
+              <a:defRPr sz="850" b="1">
+                <a:solidFill>
+                  <a:srgbClr val="1D4E89"/>
+                </a:solidFill>
+              </a:defRPr>
+            </a:pPr>
+            <a:r>
+              <a:t>• 3. AI &amp; HVI Synthesis: </a:t>
+            </a:r>
+            <a:r>
+              <a:rPr b="0">
+                <a:solidFill>
+                  <a:srgbClr val="1E293B"/>
+                </a:solidFill>
+              </a:rPr>
+              <a:t>PCA Demographic Vulnerability Index (slums, elderly, gig labor, canopy deficit) → 0–100 Heat-Health Score.</a:t>
+            </a:r>
+          </a:p>
+          <a:p>
+            <a:pPr>
+              <a:spcBef>
+                <a:spcPts val="300"/>
+              </a:spcBef>
+              <a:defRPr sz="850" b="1">
+                <a:solidFill>
+                  <a:srgbClr val="1D4E89"/>
+                </a:solidFill>
+              </a:defRPr>
+            </a:pPr>
+            <a:r>
+              <a:t>• 4. Automated Action: </a:t>
+            </a:r>
+            <a:r>
+              <a:rPr b="0">
+                <a:solidFill>
+                  <a:srgbClr val="1E293B"/>
+                </a:solidFill>
+              </a:rPr>
+              <a:t>Interactive Leaflet GIS map, 25 REST APIs, NDMA playbooks, hospital cooling beds, NIOSH labor halts.</a:t>
+            </a:r>
+          </a:p>
+        </p:txBody>
+      </p:sp>
+      <p:pic>
+        <p:nvPicPr>
+          <p:cNvPr id="7" name="Picture 6" descr="slide3_gis_curves.png"/>
+          <p:cNvPicPr>
+            <a:picLocks noChangeAspect="1"/>
+          </p:cNvPicPr>
+          <p:nvPr/>
+        </p:nvPicPr>
+        <p:blipFill>
+          <a:blip r:embed="rId3"/>
+          <a:stretch>
+            <a:fillRect/>
+          </a:stretch>
+        </p:blipFill>
+        <p:spPr>
+          <a:xfrm>
+            <a:off x="6035040" y="1280160"/>
+            <a:ext cx="5425135" cy="3200400"/>
+          </a:xfrm>
+          <a:prstGeom prst="rect">
+            <a:avLst/>
+          </a:prstGeom>
+        </p:spPr>
+      </p:pic>
+      <p:sp>
+        <p:nvSpPr>
+          <p:cNvPr id="8" name="Rounded Rectangle 7"/>
           <p:cNvSpPr/>
           <p:nvPr/>
         </p:nvSpPr>
         <p:spPr>
           <a:xfrm>
-            <a:off x="804672" y="1490472"/>
-            <a:ext cx="2395728" cy="347472"/>
+            <a:off x="731520" y="4617720"/>
+            <a:ext cx="10728655" cy="1691640"/>
           </a:xfrm>
           <a:prstGeom prst="roundRect">
             <a:avLst/>
           </a:prstGeom>
           <a:solidFill>
-            <a:srgbClr val="FEF3C7"/>
+            <a:srgbClr val="F8FAFC"/>
           </a:solidFill>
-          <a:ln w="12700">
+          <a:ln w="15240">
             <a:solidFill>
-              <a:srgbClr val="EA580C"/>
+              <a:srgbClr val="CBD5E1"/>
             </a:solidFill>
           </a:ln>
         </p:spPr>
@@ -4772,123 +4867,133 @@
           </a:fontRef>
         </p:style>
         <p:txBody>
-          <a:bodyPr rtlCol="0" anchor="ctr"/>
+          <a:bodyPr rtlCol="0" anchor="ctr" wrap="square"/>
           <a:lstStyle/>
           <a:p>
             <a:pPr algn="ctr">
-              <a:defRPr sz="1000" b="1">
-                <a:solidFill>
-                  <a:srgbClr val="EA580C"/>
-                </a:solidFill>
-              </a:defRPr>
-            </a:pPr>
-            <a:r>
-              <a:t>1. DATA INGESTION</a:t>
-            </a:r>
-          </a:p>
-        </p:txBody>
-      </p:sp>
-      <p:sp>
-        <p:nvSpPr>
-          <p:cNvPr id="8" name="TextBox 7"/>
-          <p:cNvSpPr txBox="1"/>
+              <a:defRPr sz="1050" b="1">
+                <a:solidFill>
+                  <a:srgbClr val="1D4E89"/>
+                </a:solidFill>
+              </a:defRPr>
+            </a:pPr>
+            <a:r>
+              <a:t>• Technologies to be used (Programming Languages, Frameworks, GIS &amp; Deployment):</a:t>
+            </a:r>
+          </a:p>
+          <a:p>
+            <a:pPr>
+              <a:spcBef>
+                <a:spcPts val="200"/>
+              </a:spcBef>
+              <a:defRPr sz="900" b="1">
+                <a:solidFill>
+                  <a:srgbClr val="1D4E89"/>
+                </a:solidFill>
+              </a:defRPr>
+            </a:pPr>
+            <a:r>
+              <a:t>❖  Backend &amp; REST APIs: </a:t>
+            </a:r>
+            <a:r>
+              <a:rPr b="0">
+                <a:solidFill>
+                  <a:srgbClr val="1E293B"/>
+                </a:solidFill>
+              </a:rPr>
+              <a:t>Python 3.11, FastAPI, Pydantic v2, Uvicorn, AsyncIO (25 REST production endpoints)</a:t>
+            </a:r>
+          </a:p>
+          <a:p>
+            <a:pPr>
+              <a:spcBef>
+                <a:spcPts val="200"/>
+              </a:spcBef>
+              <a:defRPr sz="900" b="1">
+                <a:solidFill>
+                  <a:srgbClr val="1D4E89"/>
+                </a:solidFill>
+              </a:defRPr>
+            </a:pPr>
+            <a:r>
+              <a:t>❖  Biometeorology &amp; GIS Engine: </a:t>
+            </a:r>
+            <a:r>
+              <a:rPr b="0">
+                <a:solidFill>
+                  <a:srgbClr val="1E293B"/>
+                </a:solidFill>
+              </a:rPr>
+              <a:t>NumPy, Pandas, GeoPandas, Shapely, Scipy (UTCI 6th-order polynomial &amp; ISO 7243 psychrometrics)</a:t>
+            </a:r>
+          </a:p>
+          <a:p>
+            <a:pPr>
+              <a:spcBef>
+                <a:spcPts val="200"/>
+              </a:spcBef>
+              <a:defRPr sz="900" b="1">
+                <a:solidFill>
+                  <a:srgbClr val="1D4E89"/>
+                </a:solidFill>
+              </a:defRPr>
+            </a:pPr>
+            <a:r>
+              <a:t>❖  Web GIS &amp; Visualization: </a:t>
+            </a:r>
+            <a:r>
+              <a:rPr b="0">
+                <a:solidFill>
+                  <a:srgbClr val="1E293B"/>
+                </a:solidFill>
+              </a:rPr>
+              <a:t>Leaflet.js (Choropleth GIS), Chart.js (5-Day Trend Curves), HTML5/CSS3 Responsive UI</a:t>
+            </a:r>
+          </a:p>
+          <a:p>
+            <a:pPr>
+              <a:spcBef>
+                <a:spcPts val="200"/>
+              </a:spcBef>
+              <a:defRPr sz="900" b="1">
+                <a:solidFill>
+                  <a:srgbClr val="1D4E89"/>
+                </a:solidFill>
+              </a:defRPr>
+            </a:pPr>
+            <a:r>
+              <a:t>❖  Data Ingestion &amp; Deployment: </a:t>
+            </a:r>
+            <a:r>
+              <a:rPr b="0">
+                <a:solidFill>
+                  <a:srgbClr val="1E293B"/>
+                </a:solidFill>
+              </a:rPr>
+              <a:t>Open-Meteo NWP, NASA POWER MERRA-2, Census India PCA, Docker, Linux VPS (Oracle Linux)</a:t>
+            </a:r>
+          </a:p>
+        </p:txBody>
+      </p:sp>
+      <p:sp>
+        <p:nvSpPr>
+          <p:cNvPr id="9" name="Rectangle 8"/>
+          <p:cNvSpPr/>
           <p:nvPr/>
         </p:nvSpPr>
         <p:spPr>
           <a:xfrm>
-            <a:off x="841248" y="1920240"/>
-            <a:ext cx="2322576" cy="2560320"/>
+            <a:off x="0" y="6446520"/>
+            <a:ext cx="12191695" cy="411480"/>
           </a:xfrm>
           <a:prstGeom prst="rect">
             <a:avLst/>
           </a:prstGeom>
-          <a:noFill/>
-        </p:spPr>
-        <p:txBody>
-          <a:bodyPr wrap="square" lIns="0" tIns="0" rIns="0" bIns="0">
-            <a:spAutoFit/>
-          </a:bodyPr>
-          <a:lstStyle/>
-          <a:p>
-            <a:pPr>
-              <a:defRPr sz="850">
-                <a:solidFill>
-                  <a:srgbClr val="1E293B"/>
-                </a:solidFill>
-              </a:defRPr>
-            </a:pPr>
-            <a:r>
-              <a:t>• Open-Meteo 0.1° NWP 5-Day Hourly Forecasts</a:t>
-            </a:r>
-          </a:p>
-          <a:p>
-            <a:pPr>
-              <a:spcBef>
-                <a:spcPts val="300"/>
-              </a:spcBef>
-              <a:defRPr sz="850">
-                <a:solidFill>
-                  <a:srgbClr val="1E293B"/>
-                </a:solidFill>
-              </a:defRPr>
-            </a:pPr>
-            <a:r>
-              <a:t>• NASA POWER 40-Yr Climatology Normal</a:t>
-            </a:r>
-          </a:p>
-          <a:p>
-            <a:pPr>
-              <a:spcBef>
-                <a:spcPts val="300"/>
-              </a:spcBef>
-              <a:defRPr sz="850">
-                <a:solidFill>
-                  <a:srgbClr val="1E293B"/>
-                </a:solidFill>
-              </a:defRPr>
-            </a:pPr>
-            <a:r>
-              <a:t>• Census 2011 PCA Ward Demographics</a:t>
-            </a:r>
-          </a:p>
-          <a:p>
-            <a:pPr>
-              <a:spcBef>
-                <a:spcPts val="300"/>
-              </a:spcBef>
-              <a:defRPr sz="850">
-                <a:solidFill>
-                  <a:srgbClr val="1E293B"/>
-                </a:solidFill>
-              </a:defRPr>
-            </a:pPr>
-            <a:r>
-              <a:t>• Satellite LST &amp; NDVI Surface Grid</a:t>
-            </a:r>
-          </a:p>
-        </p:txBody>
-      </p:sp>
-      <p:sp>
-        <p:nvSpPr>
-          <p:cNvPr id="9" name="Rounded Rectangle 8"/>
-          <p:cNvSpPr/>
-          <p:nvPr/>
-        </p:nvSpPr>
-        <p:spPr>
-          <a:xfrm>
-            <a:off x="3456432" y="1417320"/>
-            <a:ext cx="2542032" cy="3154680"/>
-          </a:xfrm>
-          <a:prstGeom prst="roundRect">
-            <a:avLst/>
-          </a:prstGeom>
           <a:solidFill>
-            <a:srgbClr val="FFFFFF"/>
+            <a:srgbClr val="0073C6"/>
           </a:solidFill>
-          <a:ln w="19050">
-            <a:solidFill>
-              <a:srgbClr val="16A34A"/>
-            </a:solidFill>
+          <a:ln>
+            <a:noFill/>
           </a:ln>
         </p:spPr>
         <p:style>
@@ -4915,68 +5020,14 @@
       </p:sp>
       <p:sp>
         <p:nvSpPr>
-          <p:cNvPr id="10" name="Rounded Rectangle 9"/>
-          <p:cNvSpPr/>
-          <p:nvPr/>
-        </p:nvSpPr>
-        <p:spPr>
-          <a:xfrm>
-            <a:off x="3529584" y="1490472"/>
-            <a:ext cx="2395728" cy="347472"/>
-          </a:xfrm>
-          <a:prstGeom prst="roundRect">
-            <a:avLst/>
-          </a:prstGeom>
-          <a:solidFill>
-            <a:srgbClr val="F0FDF4"/>
-          </a:solidFill>
-          <a:ln w="12700">
-            <a:solidFill>
-              <a:srgbClr val="16A34A"/>
-            </a:solidFill>
-          </a:ln>
-        </p:spPr>
-        <p:style>
-          <a:lnRef idx="1">
-            <a:schemeClr val="accent1"/>
-          </a:lnRef>
-          <a:fillRef idx="3">
-            <a:schemeClr val="accent1"/>
-          </a:fillRef>
-          <a:effectRef idx="2">
-            <a:schemeClr val="accent1"/>
-          </a:effectRef>
-          <a:fontRef idx="minor">
-            <a:schemeClr val="lt1"/>
-          </a:fontRef>
-        </p:style>
-        <p:txBody>
-          <a:bodyPr rtlCol="0" anchor="ctr"/>
-          <a:lstStyle/>
-          <a:p>
-            <a:pPr algn="ctr">
-              <a:defRPr sz="1000" b="1">
-                <a:solidFill>
-                  <a:srgbClr val="16A34A"/>
-                </a:solidFill>
-              </a:defRPr>
-            </a:pPr>
-            <a:r>
-              <a:t>2. THERMAL ENGINE</a:t>
-            </a:r>
-          </a:p>
-        </p:txBody>
-      </p:sp>
-      <p:sp>
-        <p:nvSpPr>
-          <p:cNvPr id="11" name="TextBox 10"/>
+          <p:cNvPr id="10" name="TextBox 9"/>
           <p:cNvSpPr txBox="1"/>
           <p:nvPr/>
         </p:nvSpPr>
         <p:spPr>
           <a:xfrm>
-            <a:off x="3566160" y="1920240"/>
-            <a:ext cx="2322576" cy="2560320"/>
+            <a:off x="731520" y="6510528"/>
+            <a:ext cx="10728655" cy="320040"/>
           </a:xfrm>
           <a:prstGeom prst="rect">
             <a:avLst/>
@@ -4984,633 +5035,6 @@
           <a:noFill/>
         </p:spPr>
         <p:txBody>
-          <a:bodyPr wrap="square" lIns="0" tIns="0" rIns="0" bIns="0">
-            <a:spAutoFit/>
-          </a:bodyPr>
-          <a:lstStyle/>
-          <a:p>
-            <a:pPr>
-              <a:defRPr sz="850">
-                <a:solidFill>
-                  <a:srgbClr val="1E293B"/>
-                </a:solidFill>
-              </a:defRPr>
-            </a:pPr>
-            <a:r>
-              <a:t>• UTCI 6th-Order Polynomial (Fiala 187-Node)</a:t>
-            </a:r>
-          </a:p>
-          <a:p>
-            <a:pPr>
-              <a:spcBef>
-                <a:spcPts val="300"/>
-              </a:spcBef>
-              <a:defRPr sz="850">
-                <a:solidFill>
-                  <a:srgbClr val="1E293B"/>
-                </a:solidFill>
-              </a:defRPr>
-            </a:pPr>
-            <a:r>
-              <a:t>• ISO 7243 WBGT Psychrometrics</a:t>
-            </a:r>
-          </a:p>
-          <a:p>
-            <a:pPr>
-              <a:spcBef>
-                <a:spcPts val="300"/>
-              </a:spcBef>
-              <a:defRPr sz="850">
-                <a:solidFill>
-                  <a:srgbClr val="1E293B"/>
-                </a:solidFill>
-              </a:defRPr>
-            </a:pPr>
-            <a:r>
-              <a:t>• Stull Tw &amp; Liljegren Tg Equations</a:t>
-            </a:r>
-          </a:p>
-          <a:p>
-            <a:pPr>
-              <a:spcBef>
-                <a:spcPts val="300"/>
-              </a:spcBef>
-              <a:defRPr sz="850">
-                <a:solidFill>
-                  <a:srgbClr val="1E293B"/>
-                </a:solidFill>
-              </a:defRPr>
-            </a:pPr>
-            <a:r>
-              <a:t>• Multi-Day Persistence Multiplier (Dmult)</a:t>
-            </a:r>
-          </a:p>
-        </p:txBody>
-      </p:sp>
-      <p:sp>
-        <p:nvSpPr>
-          <p:cNvPr id="12" name="Rounded Rectangle 11"/>
-          <p:cNvSpPr/>
-          <p:nvPr/>
-        </p:nvSpPr>
-        <p:spPr>
-          <a:xfrm>
-            <a:off x="6181344" y="1417320"/>
-            <a:ext cx="2542032" cy="3154680"/>
-          </a:xfrm>
-          <a:prstGeom prst="roundRect">
-            <a:avLst/>
-          </a:prstGeom>
-          <a:solidFill>
-            <a:srgbClr val="FFFFFF"/>
-          </a:solidFill>
-          <a:ln w="19050">
-            <a:solidFill>
-              <a:srgbClr val="DC2626"/>
-            </a:solidFill>
-          </a:ln>
-        </p:spPr>
-        <p:style>
-          <a:lnRef idx="1">
-            <a:schemeClr val="accent1"/>
-          </a:lnRef>
-          <a:fillRef idx="3">
-            <a:schemeClr val="accent1"/>
-          </a:fillRef>
-          <a:effectRef idx="2">
-            <a:schemeClr val="accent1"/>
-          </a:effectRef>
-          <a:fontRef idx="minor">
-            <a:schemeClr val="lt1"/>
-          </a:fontRef>
-        </p:style>
-        <p:txBody>
-          <a:bodyPr rtlCol="0" anchor="ctr"/>
-          <a:lstStyle/>
-          <a:p>
-            <a:pPr algn="ctr"/>
-          </a:p>
-        </p:txBody>
-      </p:sp>
-      <p:sp>
-        <p:nvSpPr>
-          <p:cNvPr id="13" name="Rounded Rectangle 12"/>
-          <p:cNvSpPr/>
-          <p:nvPr/>
-        </p:nvSpPr>
-        <p:spPr>
-          <a:xfrm>
-            <a:off x="6254496" y="1490472"/>
-            <a:ext cx="2395728" cy="347472"/>
-          </a:xfrm>
-          <a:prstGeom prst="roundRect">
-            <a:avLst/>
-          </a:prstGeom>
-          <a:solidFill>
-            <a:srgbClr val="FEF2F2"/>
-          </a:solidFill>
-          <a:ln w="12700">
-            <a:solidFill>
-              <a:srgbClr val="DC2626"/>
-            </a:solidFill>
-          </a:ln>
-        </p:spPr>
-        <p:style>
-          <a:lnRef idx="1">
-            <a:schemeClr val="accent1"/>
-          </a:lnRef>
-          <a:fillRef idx="3">
-            <a:schemeClr val="accent1"/>
-          </a:fillRef>
-          <a:effectRef idx="2">
-            <a:schemeClr val="accent1"/>
-          </a:effectRef>
-          <a:fontRef idx="minor">
-            <a:schemeClr val="lt1"/>
-          </a:fontRef>
-        </p:style>
-        <p:txBody>
-          <a:bodyPr rtlCol="0" anchor="ctr"/>
-          <a:lstStyle/>
-          <a:p>
-            <a:pPr algn="ctr">
-              <a:defRPr sz="1000" b="1">
-                <a:solidFill>
-                  <a:srgbClr val="DC2626"/>
-                </a:solidFill>
-              </a:defRPr>
-            </a:pPr>
-            <a:r>
-              <a:t>3. AI RISK &amp; HVI MODEL</a:t>
-            </a:r>
-          </a:p>
-        </p:txBody>
-      </p:sp>
-      <p:sp>
-        <p:nvSpPr>
-          <p:cNvPr id="14" name="TextBox 13"/>
-          <p:cNvSpPr txBox="1"/>
-          <p:nvPr/>
-        </p:nvSpPr>
-        <p:spPr>
-          <a:xfrm>
-            <a:off x="6291072" y="1920240"/>
-            <a:ext cx="2322576" cy="2560320"/>
-          </a:xfrm>
-          <a:prstGeom prst="rect">
-            <a:avLst/>
-          </a:prstGeom>
-          <a:noFill/>
-        </p:spPr>
-        <p:txBody>
-          <a:bodyPr wrap="square" lIns="0" tIns="0" rIns="0" bIns="0">
-            <a:spAutoFit/>
-          </a:bodyPr>
-          <a:lstStyle/>
-          <a:p>
-            <a:pPr>
-              <a:defRPr sz="850">
-                <a:solidFill>
-                  <a:srgbClr val="1E293B"/>
-                </a:solidFill>
-              </a:defRPr>
-            </a:pPr>
-            <a:r>
-              <a:t>• Demographic Vulnerability (HVI)</a:t>
-            </a:r>
-          </a:p>
-          <a:p>
-            <a:pPr>
-              <a:spcBef>
-                <a:spcPts val="300"/>
-              </a:spcBef>
-              <a:defRPr sz="850">
-                <a:solidFill>
-                  <a:srgbClr val="1E293B"/>
-                </a:solidFill>
-              </a:defRPr>
-            </a:pPr>
-            <a:r>
-              <a:t>• Elderly &amp; Outdoor Labor Density</a:t>
-            </a:r>
-          </a:p>
-          <a:p>
-            <a:pPr>
-              <a:spcBef>
-                <a:spcPts val="300"/>
-              </a:spcBef>
-              <a:defRPr sz="850">
-                <a:solidFill>
-                  <a:srgbClr val="1E293B"/>
-                </a:solidFill>
-              </a:defRPr>
-            </a:pPr>
-            <a:r>
-              <a:t>• Slum Housing &amp; Canopy Deficit</a:t>
-            </a:r>
-          </a:p>
-          <a:p>
-            <a:pPr>
-              <a:spcBef>
-                <a:spcPts val="300"/>
-              </a:spcBef>
-              <a:defRPr sz="850">
-                <a:solidFill>
-                  <a:srgbClr val="1E293B"/>
-                </a:solidFill>
-              </a:defRPr>
-            </a:pPr>
-            <a:r>
-              <a:t>• Normalized 0–100 Heat-Health Score</a:t>
-            </a:r>
-          </a:p>
-        </p:txBody>
-      </p:sp>
-      <p:sp>
-        <p:nvSpPr>
-          <p:cNvPr id="15" name="Rounded Rectangle 14"/>
-          <p:cNvSpPr/>
-          <p:nvPr/>
-        </p:nvSpPr>
-        <p:spPr>
-          <a:xfrm>
-            <a:off x="8906256" y="1417320"/>
-            <a:ext cx="2542032" cy="3154680"/>
-          </a:xfrm>
-          <a:prstGeom prst="roundRect">
-            <a:avLst/>
-          </a:prstGeom>
-          <a:solidFill>
-            <a:srgbClr val="FFFFFF"/>
-          </a:solidFill>
-          <a:ln w="19050">
-            <a:solidFill>
-              <a:srgbClr val="1D4E89"/>
-            </a:solidFill>
-          </a:ln>
-        </p:spPr>
-        <p:style>
-          <a:lnRef idx="1">
-            <a:schemeClr val="accent1"/>
-          </a:lnRef>
-          <a:fillRef idx="3">
-            <a:schemeClr val="accent1"/>
-          </a:fillRef>
-          <a:effectRef idx="2">
-            <a:schemeClr val="accent1"/>
-          </a:effectRef>
-          <a:fontRef idx="minor">
-            <a:schemeClr val="lt1"/>
-          </a:fontRef>
-        </p:style>
-        <p:txBody>
-          <a:bodyPr rtlCol="0" anchor="ctr"/>
-          <a:lstStyle/>
-          <a:p>
-            <a:pPr algn="ctr"/>
-          </a:p>
-        </p:txBody>
-      </p:sp>
-      <p:sp>
-        <p:nvSpPr>
-          <p:cNvPr id="16" name="Rounded Rectangle 15"/>
-          <p:cNvSpPr/>
-          <p:nvPr/>
-        </p:nvSpPr>
-        <p:spPr>
-          <a:xfrm>
-            <a:off x="8979408" y="1490472"/>
-            <a:ext cx="2395728" cy="347472"/>
-          </a:xfrm>
-          <a:prstGeom prst="roundRect">
-            <a:avLst/>
-          </a:prstGeom>
-          <a:solidFill>
-            <a:srgbClr val="F0F9FF"/>
-          </a:solidFill>
-          <a:ln w="12700">
-            <a:solidFill>
-              <a:srgbClr val="1D4E89"/>
-            </a:solidFill>
-          </a:ln>
-        </p:spPr>
-        <p:style>
-          <a:lnRef idx="1">
-            <a:schemeClr val="accent1"/>
-          </a:lnRef>
-          <a:fillRef idx="3">
-            <a:schemeClr val="accent1"/>
-          </a:fillRef>
-          <a:effectRef idx="2">
-            <a:schemeClr val="accent1"/>
-          </a:effectRef>
-          <a:fontRef idx="minor">
-            <a:schemeClr val="lt1"/>
-          </a:fontRef>
-        </p:style>
-        <p:txBody>
-          <a:bodyPr rtlCol="0" anchor="ctr"/>
-          <a:lstStyle/>
-          <a:p>
-            <a:pPr algn="ctr">
-              <a:defRPr sz="1000" b="1">
-                <a:solidFill>
-                  <a:srgbClr val="1D4E89"/>
-                </a:solidFill>
-              </a:defRPr>
-            </a:pPr>
-            <a:r>
-              <a:t>4. ACTION &amp; GIS DELIVERY</a:t>
-            </a:r>
-          </a:p>
-        </p:txBody>
-      </p:sp>
-      <p:sp>
-        <p:nvSpPr>
-          <p:cNvPr id="17" name="TextBox 16"/>
-          <p:cNvSpPr txBox="1"/>
-          <p:nvPr/>
-        </p:nvSpPr>
-        <p:spPr>
-          <a:xfrm>
-            <a:off x="9015984" y="1920240"/>
-            <a:ext cx="2322576" cy="2560320"/>
-          </a:xfrm>
-          <a:prstGeom prst="rect">
-            <a:avLst/>
-          </a:prstGeom>
-          <a:noFill/>
-        </p:spPr>
-        <p:txBody>
-          <a:bodyPr wrap="square" lIns="0" tIns="0" rIns="0" bIns="0">
-            <a:spAutoFit/>
-          </a:bodyPr>
-          <a:lstStyle/>
-          <a:p>
-            <a:pPr>
-              <a:defRPr sz="850">
-                <a:solidFill>
-                  <a:srgbClr val="1E293B"/>
-                </a:solidFill>
-              </a:defRPr>
-            </a:pPr>
-            <a:r>
-              <a:t>• Interactive Leaflet GIS Choropleth</a:t>
-            </a:r>
-          </a:p>
-          <a:p>
-            <a:pPr>
-              <a:spcBef>
-                <a:spcPts val="300"/>
-              </a:spcBef>
-              <a:defRPr sz="850">
-                <a:solidFill>
-                  <a:srgbClr val="1E293B"/>
-                </a:solidFill>
-              </a:defRPr>
-            </a:pPr>
-            <a:r>
-              <a:t>• 25 Production REST APIs</a:t>
-            </a:r>
-          </a:p>
-          <a:p>
-            <a:pPr>
-              <a:spcBef>
-                <a:spcPts val="300"/>
-              </a:spcBef>
-              <a:defRPr sz="850">
-                <a:solidFill>
-                  <a:srgbClr val="1E293B"/>
-                </a:solidFill>
-              </a:defRPr>
-            </a:pPr>
-            <a:r>
-              <a:t>• Automated NDMA Action Playbooks</a:t>
-            </a:r>
-          </a:p>
-          <a:p>
-            <a:pPr>
-              <a:spcBef>
-                <a:spcPts val="300"/>
-              </a:spcBef>
-              <a:defRPr sz="850">
-                <a:solidFill>
-                  <a:srgbClr val="1E293B"/>
-                </a:solidFill>
-              </a:defRPr>
-            </a:pPr>
-            <a:r>
-              <a:t>• Hospital Surge Bed Triggers</a:t>
-            </a:r>
-          </a:p>
-        </p:txBody>
-      </p:sp>
-      <p:sp>
-        <p:nvSpPr>
-          <p:cNvPr id="18" name="Rounded Rectangle 17"/>
-          <p:cNvSpPr/>
-          <p:nvPr/>
-        </p:nvSpPr>
-        <p:spPr>
-          <a:xfrm>
-            <a:off x="731520" y="4709160"/>
-            <a:ext cx="10728655" cy="1645920"/>
-          </a:xfrm>
-          <a:prstGeom prst="roundRect">
-            <a:avLst/>
-          </a:prstGeom>
-          <a:solidFill>
-            <a:srgbClr val="F8FAFC"/>
-          </a:solidFill>
-          <a:ln w="15240">
-            <a:solidFill>
-              <a:srgbClr val="CBD5E1"/>
-            </a:solidFill>
-          </a:ln>
-        </p:spPr>
-        <p:style>
-          <a:lnRef idx="1">
-            <a:schemeClr val="accent1"/>
-          </a:lnRef>
-          <a:fillRef idx="3">
-            <a:schemeClr val="accent1"/>
-          </a:fillRef>
-          <a:effectRef idx="2">
-            <a:schemeClr val="accent1"/>
-          </a:effectRef>
-          <a:fontRef idx="minor">
-            <a:schemeClr val="lt1"/>
-          </a:fontRef>
-        </p:style>
-        <p:txBody>
-          <a:bodyPr rtlCol="0" anchor="ctr" wrap="square"/>
-          <a:lstStyle/>
-          <a:p>
-            <a:pPr algn="ctr">
-              <a:defRPr sz="1100" b="1">
-                <a:solidFill>
-                  <a:srgbClr val="1D4E89"/>
-                </a:solidFill>
-              </a:defRPr>
-            </a:pPr>
-            <a:r>
-              <a:t>• Technologies to be used (Languages, Frameworks, Libraries &amp; Infrastructure):</a:t>
-            </a:r>
-          </a:p>
-          <a:p>
-            <a:pPr>
-              <a:spcBef>
-                <a:spcPts val="200"/>
-              </a:spcBef>
-              <a:defRPr sz="900" b="1">
-                <a:solidFill>
-                  <a:srgbClr val="1D4E89"/>
-                </a:solidFill>
-              </a:defRPr>
-            </a:pPr>
-            <a:r>
-              <a:t>❖  Backend &amp; REST APIs: </a:t>
-            </a:r>
-            <a:r>
-              <a:rPr b="0">
-                <a:solidFill>
-                  <a:srgbClr val="1E293B"/>
-                </a:solidFill>
-              </a:rPr>
-              <a:t>Python 3.11, FastAPI, Pydantic v2, Uvicorn, AsyncIO (25 REST production endpoints)</a:t>
-            </a:r>
-          </a:p>
-          <a:p>
-            <a:pPr>
-              <a:spcBef>
-                <a:spcPts val="200"/>
-              </a:spcBef>
-              <a:defRPr sz="900" b="1">
-                <a:solidFill>
-                  <a:srgbClr val="1D4E89"/>
-                </a:solidFill>
-              </a:defRPr>
-            </a:pPr>
-            <a:r>
-              <a:t>❖  Biometeorological &amp; GIS Engine: </a:t>
-            </a:r>
-            <a:r>
-              <a:rPr b="0">
-                <a:solidFill>
-                  <a:srgbClr val="1E293B"/>
-                </a:solidFill>
-              </a:rPr>
-              <a:t>NumPy, Pandas, GeoPandas, Shapely, Scipy (UTCI 6th-order polynomial &amp; ISO 7243 psychrometrics)</a:t>
-            </a:r>
-          </a:p>
-          <a:p>
-            <a:pPr>
-              <a:spcBef>
-                <a:spcPts val="200"/>
-              </a:spcBef>
-              <a:defRPr sz="900" b="1">
-                <a:solidFill>
-                  <a:srgbClr val="1D4E89"/>
-                </a:solidFill>
-              </a:defRPr>
-            </a:pPr>
-            <a:r>
-              <a:t>❖  Web GIS &amp; Visualization: </a:t>
-            </a:r>
-            <a:r>
-              <a:rPr b="0">
-                <a:solidFill>
-                  <a:srgbClr val="1E293B"/>
-                </a:solidFill>
-              </a:rPr>
-              <a:t>Leaflet.js (Choropleth GIS), Chart.js (5-Day Trend Curves), HTML5/CSS3 Responsive UI</a:t>
-            </a:r>
-          </a:p>
-          <a:p>
-            <a:pPr>
-              <a:spcBef>
-                <a:spcPts val="200"/>
-              </a:spcBef>
-              <a:defRPr sz="900" b="1">
-                <a:solidFill>
-                  <a:srgbClr val="1D4E89"/>
-                </a:solidFill>
-              </a:defRPr>
-            </a:pPr>
-            <a:r>
-              <a:t>❖  Data Ingestion &amp; Deployment: </a:t>
-            </a:r>
-            <a:r>
-              <a:rPr b="0">
-                <a:solidFill>
-                  <a:srgbClr val="1E293B"/>
-                </a:solidFill>
-              </a:rPr>
-              <a:t>Open-Meteo NWP, NASA POWER MERRA-2, Census India PCA, Docker, Linux VPS (Oracle Linux)</a:t>
-            </a:r>
-          </a:p>
-        </p:txBody>
-      </p:sp>
-      <p:sp>
-        <p:nvSpPr>
-          <p:cNvPr id="19" name="Rectangle 18"/>
-          <p:cNvSpPr/>
-          <p:nvPr/>
-        </p:nvSpPr>
-        <p:spPr>
-          <a:xfrm>
-            <a:off x="0" y="6446520"/>
-            <a:ext cx="12191695" cy="411480"/>
-          </a:xfrm>
-          <a:prstGeom prst="rect">
-            <a:avLst/>
-          </a:prstGeom>
-          <a:solidFill>
-            <a:srgbClr val="0073C6"/>
-          </a:solidFill>
-          <a:ln>
-            <a:noFill/>
-          </a:ln>
-        </p:spPr>
-        <p:style>
-          <a:lnRef idx="1">
-            <a:schemeClr val="accent1"/>
-          </a:lnRef>
-          <a:fillRef idx="3">
-            <a:schemeClr val="accent1"/>
-          </a:fillRef>
-          <a:effectRef idx="2">
-            <a:schemeClr val="accent1"/>
-          </a:effectRef>
-          <a:fontRef idx="minor">
-            <a:schemeClr val="lt1"/>
-          </a:fontRef>
-        </p:style>
-        <p:txBody>
-          <a:bodyPr rtlCol="0" anchor="ctr"/>
-          <a:lstStyle/>
-          <a:p>
-            <a:pPr algn="ctr"/>
-          </a:p>
-        </p:txBody>
-      </p:sp>
-      <p:sp>
-        <p:nvSpPr>
-          <p:cNvPr id="20" name="TextBox 19"/>
-          <p:cNvSpPr txBox="1"/>
-          <p:nvPr/>
-        </p:nvSpPr>
-        <p:spPr>
-          <a:xfrm>
-            <a:off x="731520" y="6510528"/>
-            <a:ext cx="10728655" cy="320040"/>
-          </a:xfrm>
-          <a:prstGeom prst="rect">
-            <a:avLst/>
-          </a:prstGeom>
-          <a:noFill/>
-        </p:spPr>
-        <p:txBody>
           <a:bodyPr wrap="none" lIns="0" tIns="0" rIns="0" bIns="0">
             <a:spAutoFit/>
           </a:bodyPr>
@@ -5632,7 +5056,7 @@
       </p:sp>
       <p:sp>
         <p:nvSpPr>
-          <p:cNvPr id="21" name="TextBox 20"/>
+          <p:cNvPr id="11" name="TextBox 10"/>
           <p:cNvSpPr txBox="1"/>
           <p:nvPr/>
         </p:nvSpPr>
@@ -5699,8 +5123,8 @@
         </p:nvSpPr>
         <p:spPr>
           <a:xfrm>
-            <a:off x="548640" y="182880"/>
-            <a:ext cx="1371600" cy="731520"/>
+            <a:off x="548640" y="164592"/>
+            <a:ext cx="1371600" cy="685800"/>
           </a:xfrm>
           <a:prstGeom prst="ellipse">
             <a:avLst/>
@@ -5733,7 +5157,7 @@
           <a:lstStyle/>
           <a:p>
             <a:pPr algn="ctr">
-              <a:defRPr sz="950" b="1">
+              <a:defRPr sz="900" b="1">
                 <a:solidFill>
                   <a:srgbClr val="000000"/>
                 </a:solidFill>
@@ -5746,7 +5170,7 @@
           </a:p>
           <a:p>
             <a:pPr algn="ctr">
-              <a:defRPr sz="950" b="1">
+              <a:defRPr sz="900" b="1">
                 <a:solidFill>
                   <a:srgbClr val="000000"/>
                 </a:solidFill>
@@ -5759,7 +5183,7 @@
           </a:p>
           <a:p>
             <a:pPr algn="ctr">
-              <a:defRPr sz="950" b="1">
+              <a:defRPr sz="900" b="1">
                 <a:solidFill>
                   <a:srgbClr val="000000"/>
                 </a:solidFill>
@@ -5780,8 +5204,8 @@
         </p:nvSpPr>
         <p:spPr>
           <a:xfrm>
-            <a:off x="2286000" y="228600"/>
-            <a:ext cx="7619695" cy="594360"/>
+            <a:off x="2194560" y="182880"/>
+            <a:ext cx="7589520" cy="594360"/>
           </a:xfrm>
           <a:prstGeom prst="rect">
             <a:avLst/>
@@ -5795,7 +5219,7 @@
           <a:lstStyle/>
           <a:p>
             <a:pPr algn="ctr">
-              <a:defRPr sz="1800" b="1">
+              <a:defRPr sz="1700" b="1">
                 <a:solidFill>
                   <a:srgbClr val="000000"/>
                 </a:solidFill>
@@ -5824,7 +5248,7 @@
         </p:blipFill>
         <p:spPr>
           <a:xfrm>
-            <a:off x="9875520" y="164592"/>
+            <a:off x="9875520" y="137160"/>
             <a:ext cx="1920240" cy="722376"/>
           </a:xfrm>
           <a:prstGeom prst="rect">
@@ -5840,7 +5264,7 @@
         </p:nvSpPr>
         <p:spPr>
           <a:xfrm>
-            <a:off x="731520" y="1005840"/>
+            <a:off x="731520" y="960120"/>
             <a:ext cx="10728655" cy="1371600"/>
           </a:xfrm>
           <a:prstGeom prst="rect">
@@ -5855,7 +5279,7 @@
           <a:lstStyle/>
           <a:p>
             <a:pPr>
-              <a:defRPr sz="1150" b="1">
+              <a:defRPr sz="1100" b="1">
                 <a:solidFill>
                   <a:srgbClr val="1D4E89"/>
                 </a:solidFill>
@@ -5890,8 +5314,8 @@
         </p:nvSpPr>
         <p:spPr>
           <a:xfrm>
-            <a:off x="731520" y="2468880"/>
-            <a:ext cx="6858000" cy="3886200"/>
+            <a:off x="731520" y="2423160"/>
+            <a:ext cx="6858000" cy="3931920"/>
           </a:xfrm>
           <a:prstGeom prst="roundRect">
             <a:avLst/>
@@ -5935,8 +5359,8 @@
         </p:nvSpPr>
         <p:spPr>
           <a:xfrm>
-            <a:off x="914400" y="2560320"/>
-            <a:ext cx="6492240" cy="365760"/>
+            <a:off x="914400" y="2514600"/>
+            <a:ext cx="6492240" cy="320040"/>
           </a:xfrm>
           <a:prstGeom prst="rect">
             <a:avLst/>
@@ -5970,7 +5394,7 @@
         </p:nvSpPr>
         <p:spPr>
           <a:xfrm>
-            <a:off x="914400" y="2971800"/>
+            <a:off x="914400" y="2907792"/>
             <a:ext cx="6492240" cy="594360"/>
           </a:xfrm>
           <a:prstGeom prst="rect">
@@ -6012,7 +5436,7 @@
         </p:nvSpPr>
         <p:spPr>
           <a:xfrm>
-            <a:off x="914400" y="3630168"/>
+            <a:off x="914400" y="3566160"/>
             <a:ext cx="6492240" cy="594360"/>
           </a:xfrm>
           <a:prstGeom prst="rect">
@@ -6054,7 +5478,7 @@
         </p:nvSpPr>
         <p:spPr>
           <a:xfrm>
-            <a:off x="914400" y="4288536"/>
+            <a:off x="914400" y="4224528"/>
             <a:ext cx="6492240" cy="594360"/>
           </a:xfrm>
           <a:prstGeom prst="rect">
@@ -6096,7 +5520,7 @@
         </p:nvSpPr>
         <p:spPr>
           <a:xfrm>
-            <a:off x="914400" y="4946904"/>
+            <a:off x="914400" y="4882896"/>
             <a:ext cx="6492240" cy="594360"/>
           </a:xfrm>
           <a:prstGeom prst="rect">
@@ -6138,7 +5562,7 @@
         </p:nvSpPr>
         <p:spPr>
           <a:xfrm>
-            <a:off x="914400" y="5605272"/>
+            <a:off x="914400" y="5541264"/>
             <a:ext cx="6492240" cy="594360"/>
           </a:xfrm>
           <a:prstGeom prst="rect">
@@ -6180,8 +5604,8 @@
         </p:nvSpPr>
         <p:spPr>
           <a:xfrm>
-            <a:off x="7772400" y="2468880"/>
-            <a:ext cx="3687775" cy="3886200"/>
+            <a:off x="7772400" y="2423160"/>
+            <a:ext cx="3687775" cy="3931920"/>
           </a:xfrm>
           <a:prstGeom prst="roundRect">
             <a:avLst/>
@@ -6509,8 +5933,8 @@
         </p:nvSpPr>
         <p:spPr>
           <a:xfrm>
-            <a:off x="548640" y="182880"/>
-            <a:ext cx="1371600" cy="731520"/>
+            <a:off x="548640" y="164592"/>
+            <a:ext cx="1371600" cy="685800"/>
           </a:xfrm>
           <a:prstGeom prst="ellipse">
             <a:avLst/>
@@ -6543,7 +5967,7 @@
           <a:lstStyle/>
           <a:p>
             <a:pPr algn="ctr">
-              <a:defRPr sz="950" b="1">
+              <a:defRPr sz="900" b="1">
                 <a:solidFill>
                   <a:srgbClr val="000000"/>
                 </a:solidFill>
@@ -6556,7 +5980,7 @@
           </a:p>
           <a:p>
             <a:pPr algn="ctr">
-              <a:defRPr sz="950" b="1">
+              <a:defRPr sz="900" b="1">
                 <a:solidFill>
                   <a:srgbClr val="000000"/>
                 </a:solidFill>
@@ -6569,7 +5993,7 @@
           </a:p>
           <a:p>
             <a:pPr algn="ctr">
-              <a:defRPr sz="950" b="1">
+              <a:defRPr sz="900" b="1">
                 <a:solidFill>
                   <a:srgbClr val="000000"/>
                 </a:solidFill>
@@ -6590,8 +6014,8 @@
         </p:nvSpPr>
         <p:spPr>
           <a:xfrm>
-            <a:off x="2286000" y="228600"/>
-            <a:ext cx="7619695" cy="594360"/>
+            <a:off x="2194560" y="182880"/>
+            <a:ext cx="7589520" cy="594360"/>
           </a:xfrm>
           <a:prstGeom prst="rect">
             <a:avLst/>
@@ -6605,7 +6029,7 @@
           <a:lstStyle/>
           <a:p>
             <a:pPr algn="ctr">
-              <a:defRPr sz="1800" b="1">
+              <a:defRPr sz="1700" b="1">
                 <a:solidFill>
                   <a:srgbClr val="000000"/>
                 </a:solidFill>
@@ -6634,7 +6058,7 @@
         </p:blipFill>
         <p:spPr>
           <a:xfrm>
-            <a:off x="9875520" y="164592"/>
+            <a:off x="9875520" y="137160"/>
             <a:ext cx="1920240" cy="722376"/>
           </a:xfrm>
           <a:prstGeom prst="rect">
@@ -6650,8 +6074,8 @@
         </p:nvSpPr>
         <p:spPr>
           <a:xfrm>
-            <a:off x="731520" y="914400"/>
-            <a:ext cx="10728655" cy="685800"/>
+            <a:off x="731520" y="960120"/>
+            <a:ext cx="10728655" cy="274320"/>
           </a:xfrm>
           <a:prstGeom prst="rect">
             <a:avLst/>
@@ -6672,29 +6096,53 @@
               </a:defRPr>
             </a:pPr>
             <a:r>
-              <a:t>• Potential Impact on the Target Audience (Municipalities, Hospitals, Gig Workers &amp; Vulnerable Citizens)</a:t>
-            </a:r>
-          </a:p>
-        </p:txBody>
-      </p:sp>
-      <p:sp>
-        <p:nvSpPr>
-          <p:cNvPr id="6" name="Rounded Rectangle 5"/>
+              <a:t>• Potential Impact on the Target Audience (72h–120h Pre-Emptive Intervention Timeline)</a:t>
+            </a:r>
+          </a:p>
+        </p:txBody>
+      </p:sp>
+      <p:pic>
+        <p:nvPicPr>
+          <p:cNvPr id="6" name="Picture 5" descr="slide5_timeline.png"/>
+          <p:cNvPicPr>
+            <a:picLocks noChangeAspect="1"/>
+          </p:cNvPicPr>
+          <p:nvPr/>
+        </p:nvPicPr>
+        <p:blipFill>
+          <a:blip r:embed="rId3"/>
+          <a:stretch>
+            <a:fillRect/>
+          </a:stretch>
+        </p:blipFill>
+        <p:spPr>
+          <a:xfrm>
+            <a:off x="731520" y="1280160"/>
+            <a:ext cx="10728655" cy="1645920"/>
+          </a:xfrm>
+          <a:prstGeom prst="rect">
+            <a:avLst/>
+          </a:prstGeom>
+        </p:spPr>
+      </p:pic>
+      <p:sp>
+        <p:nvSpPr>
+          <p:cNvPr id="7" name="Rounded Rectangle 6"/>
           <p:cNvSpPr/>
           <p:nvPr/>
         </p:nvSpPr>
         <p:spPr>
           <a:xfrm>
-            <a:off x="731520" y="1371600"/>
-            <a:ext cx="10728655" cy="1371600"/>
+            <a:off x="731520" y="3017520"/>
+            <a:ext cx="3429000" cy="3337560"/>
           </a:xfrm>
           <a:prstGeom prst="roundRect">
             <a:avLst/>
           </a:prstGeom>
           <a:solidFill>
-            <a:srgbClr val="F0F9FF"/>
+            <a:srgbClr val="FFFFFF"/>
           </a:solidFill>
-          <a:ln w="15240">
+          <a:ln w="19050">
             <a:solidFill>
               <a:srgbClr val="0284C7"/>
             </a:solidFill>
@@ -6715,59 +6163,101 @@
           </a:fontRef>
         </p:style>
         <p:txBody>
-          <a:bodyPr rtlCol="0" anchor="ctr" wrap="square"/>
+          <a:bodyPr rtlCol="0" anchor="ctr" wrap="square" lIns="0" tIns="0" rIns="0" bIns="0"/>
           <a:lstStyle/>
           <a:p>
             <a:pPr algn="ctr">
-              <a:defRPr sz="1000" b="1">
-                <a:solidFill>
-                  <a:srgbClr val="1D4E89"/>
-                </a:solidFill>
-              </a:defRPr>
-            </a:pPr>
-            <a:r>
-              <a:t>72h–120h (3–5 DAY) PRE-EMPTIVE HEAT ACTION TIMELINE:</a:t>
+              <a:defRPr sz="1050" b="1">
+                <a:solidFill>
+                  <a:srgbClr val="0284C7"/>
+                </a:solidFill>
+              </a:defRPr>
+            </a:pPr>
+            <a:r>
+              <a:t>• Social Benefits</a:t>
             </a:r>
           </a:p>
           <a:p>
             <a:pPr>
               <a:spcBef>
-                <a:spcPts val="200"/>
+                <a:spcPts val="300"/>
               </a:spcBef>
-              <a:defRPr sz="850">
+              <a:defRPr sz="850" b="1">
+                <a:solidFill>
+                  <a:srgbClr val="1D4E89"/>
+                </a:solidFill>
+              </a:defRPr>
+            </a:pPr>
+            <a:r>
+              <a:t>▪  Protects Vulnerable Citizens: </a:t>
+            </a:r>
+            <a:r>
+              <a:rPr b="0">
                 <a:solidFill>
                   <a:srgbClr val="1E293B"/>
                 </a:solidFill>
-              </a:defRPr>
-            </a:pPr>
-            <a:r>
-              <a:t>• 120h (D-5): NWP model flags thermal moisture surge → Early municipal advisory &amp; DISCOM grid warnings issued</a:t>
-            </a:r>
-            <a:br/>
-            <a:r>
-              <a:t>• 72h (D-3): Cumulative heat persistence detected → Water tankers and mobile misting units dispatched to high-risk slums</a:t>
-            </a:r>
-            <a:br/>
-            <a:r>
-              <a:t>• 48h (D-2): Hospital surge beds &amp; ice-bath cooling centers staged; emergency ORS supplies prepositioned</a:t>
-            </a:r>
-            <a:br/>
-            <a:r>
-              <a:t>• 24h (D-1): Mandatory NIOSH labor halts mandated for construction &amp; delivery workers during peak hours (11 AM–4 PM)</a:t>
-            </a:r>
-          </a:p>
-        </p:txBody>
-      </p:sp>
-      <p:sp>
-        <p:nvSpPr>
-          <p:cNvPr id="7" name="Rounded Rectangle 6"/>
+              </a:rPr>
+              <a:t>Dramatically reduces heatstroke morbidity among elderly, infants, and chronic disease patients.</a:t>
+            </a:r>
+          </a:p>
+          <a:p>
+            <a:pPr>
+              <a:spcBef>
+                <a:spcPts val="300"/>
+              </a:spcBef>
+              <a:defRPr sz="850" b="1">
+                <a:solidFill>
+                  <a:srgbClr val="1D4E89"/>
+                </a:solidFill>
+              </a:defRPr>
+            </a:pPr>
+            <a:r>
+              <a:t>▪  Protects Informal Laborers: </a:t>
+            </a:r>
+            <a:r>
+              <a:rPr b="0">
+                <a:solidFill>
+                  <a:srgbClr val="1E293B"/>
+                </a:solidFill>
+              </a:rPr>
+              <a:t>Enforces humane work-rest cycles for delivery and construction workers.</a:t>
+            </a:r>
+          </a:p>
+          <a:p>
+            <a:pPr>
+              <a:spcBef>
+                <a:spcPts val="300"/>
+              </a:spcBef>
+              <a:defRPr sz="850" b="1">
+                <a:solidFill>
+                  <a:srgbClr val="1D4E89"/>
+                </a:solidFill>
+              </a:defRPr>
+            </a:pPr>
+            <a:r>
+              <a:t>▪  Bilingual Public Alerts: </a:t>
+            </a:r>
+            <a:r>
+              <a:rPr b="0">
+                <a:solidFill>
+                  <a:srgbClr val="1E293B"/>
+                </a:solidFill>
+              </a:rPr>
+              <a:t>Delivers plain-language vernacular guidance via SMS/WhatsApp to eliminate technical barriers.</a:t>
+            </a:r>
+          </a:p>
+        </p:txBody>
+      </p:sp>
+      <p:sp>
+        <p:nvSpPr>
+          <p:cNvPr id="8" name="Rounded Rectangle 7"/>
           <p:cNvSpPr/>
           <p:nvPr/>
         </p:nvSpPr>
         <p:spPr>
           <a:xfrm>
-            <a:off x="731520" y="2880360"/>
-            <a:ext cx="3429000" cy="3474720"/>
+            <a:off x="4379976" y="3017520"/>
+            <a:ext cx="3429000" cy="3337560"/>
           </a:xfrm>
           <a:prstGeom prst="roundRect">
             <a:avLst/>
@@ -6777,7 +6267,7 @@
           </a:solidFill>
           <a:ln w="19050">
             <a:solidFill>
-              <a:srgbClr val="0284C7"/>
+              <a:srgbClr val="16A34A"/>
             </a:solidFill>
           </a:ln>
         </p:spPr>
@@ -6800,20 +6290,20 @@
           <a:lstStyle/>
           <a:p>
             <a:pPr algn="ctr">
-              <a:defRPr sz="1100" b="1">
-                <a:solidFill>
-                  <a:srgbClr val="0284C7"/>
-                </a:solidFill>
-              </a:defRPr>
-            </a:pPr>
-            <a:r>
-              <a:t>• Social Benefits</a:t>
+              <a:defRPr sz="1050" b="1">
+                <a:solidFill>
+                  <a:srgbClr val="16A34A"/>
+                </a:solidFill>
+              </a:defRPr>
+            </a:pPr>
+            <a:r>
+              <a:t>• Economic Benefits</a:t>
             </a:r>
           </a:p>
           <a:p>
             <a:pPr>
               <a:spcBef>
-                <a:spcPts val="400"/>
+                <a:spcPts val="300"/>
               </a:spcBef>
               <a:defRPr sz="850" b="1">
                 <a:solidFill>
@@ -6822,7 +6312,7 @@
               </a:defRPr>
             </a:pPr>
             <a:r>
-              <a:t>▪  Protects Vulnerable Citizens: </a:t>
+              <a:t>▪  Prevents Productivity Loss: </a:t>
             </a:r>
             <a:r>
               <a:rPr b="0">
@@ -6830,13 +6320,13 @@
                   <a:srgbClr val="1E293B"/>
                 </a:solidFill>
               </a:rPr>
-              <a:t>Dramatically reduces heatstroke morbidity among elderly, children, and chronic disease patients.</a:t>
+              <a:t>Mitigates lost labor hours through scheduled morning/evening shifts ($3.8B/yr India heat loss).</a:t>
             </a:r>
           </a:p>
           <a:p>
             <a:pPr>
               <a:spcBef>
-                <a:spcPts val="400"/>
+                <a:spcPts val="300"/>
               </a:spcBef>
               <a:defRPr sz="850" b="1">
                 <a:solidFill>
@@ -6845,7 +6335,7 @@
               </a:defRPr>
             </a:pPr>
             <a:r>
-              <a:t>▪  Protects Informal Laborers: </a:t>
+              <a:t>▪  Optimized Relief Routing: </a:t>
             </a:r>
             <a:r>
               <a:rPr b="0">
@@ -6853,13 +6343,13 @@
                   <a:srgbClr val="1E293B"/>
                 </a:solidFill>
               </a:rPr>
-              <a:t>Enforces humane work-rest cycles for delivery and construction workers.</a:t>
+              <a:t>Avoids wasteful blanket relief by targeting water tankers to high-vulnerability wards.</a:t>
             </a:r>
           </a:p>
           <a:p>
             <a:pPr>
               <a:spcBef>
-                <a:spcPts val="400"/>
+                <a:spcPts val="300"/>
               </a:spcBef>
               <a:defRPr sz="850" b="1">
                 <a:solidFill>
@@ -6868,7 +6358,7 @@
               </a:defRPr>
             </a:pPr>
             <a:r>
-              <a:t>▪  Bilingual Public Alerts: </a:t>
+              <a:t>▪  Reduces Emergency Care Costs: </a:t>
             </a:r>
             <a:r>
               <a:rPr b="0">
@@ -6876,21 +6366,21 @@
                   <a:srgbClr val="1E293B"/>
                 </a:solidFill>
               </a:rPr>
-              <a:t>Delivers plain-language vernacular guidance via SMS/WhatsApp to eliminate technical barriers.</a:t>
-            </a:r>
-          </a:p>
-        </p:txBody>
-      </p:sp>
-      <p:sp>
-        <p:nvSpPr>
-          <p:cNvPr id="8" name="Rounded Rectangle 7"/>
+              <a:t>Pre-empts severe multi-organ failure and ICU hospitalization surges.</a:t>
+            </a:r>
+          </a:p>
+        </p:txBody>
+      </p:sp>
+      <p:sp>
+        <p:nvSpPr>
+          <p:cNvPr id="9" name="Rounded Rectangle 8"/>
           <p:cNvSpPr/>
           <p:nvPr/>
         </p:nvSpPr>
         <p:spPr>
           <a:xfrm>
-            <a:off x="4379976" y="2880360"/>
-            <a:ext cx="3429000" cy="3474720"/>
+            <a:off x="8028432" y="3017520"/>
+            <a:ext cx="3429000" cy="3337560"/>
           </a:xfrm>
           <a:prstGeom prst="roundRect">
             <a:avLst/>
@@ -6900,7 +6390,7 @@
           </a:solidFill>
           <a:ln w="19050">
             <a:solidFill>
-              <a:srgbClr val="16A34A"/>
+              <a:srgbClr val="EA580C"/>
             </a:solidFill>
           </a:ln>
         </p:spPr>
@@ -6923,20 +6413,20 @@
           <a:lstStyle/>
           <a:p>
             <a:pPr algn="ctr">
-              <a:defRPr sz="1100" b="1">
-                <a:solidFill>
-                  <a:srgbClr val="16A34A"/>
-                </a:solidFill>
-              </a:defRPr>
-            </a:pPr>
-            <a:r>
-              <a:t>• Economic Benefits</a:t>
+              <a:defRPr sz="1050" b="1">
+                <a:solidFill>
+                  <a:srgbClr val="EA580C"/>
+                </a:solidFill>
+              </a:defRPr>
+            </a:pPr>
+            <a:r>
+              <a:t>• Environmental &amp; Urban Benefits</a:t>
             </a:r>
           </a:p>
           <a:p>
             <a:pPr>
               <a:spcBef>
-                <a:spcPts val="400"/>
+                <a:spcPts val="300"/>
               </a:spcBef>
               <a:defRPr sz="850" b="1">
                 <a:solidFill>
@@ -6945,7 +6435,7 @@
               </a:defRPr>
             </a:pPr>
             <a:r>
-              <a:t>▪  Prevents Productivity Loss: </a:t>
+              <a:t>▪  Urban Heat Island (UHI) Mapping: </a:t>
             </a:r>
             <a:r>
               <a:rPr b="0">
@@ -6953,13 +6443,13 @@
                   <a:srgbClr val="1E293B"/>
                 </a:solidFill>
               </a:rPr>
-              <a:t>Mitigates lost labor hours through scheduled morning/evening shifts ($3.8B/yr India heat loss).</a:t>
+              <a:t>Identifies micro-urban hot spots and green canopy deficits.</a:t>
             </a:r>
           </a:p>
           <a:p>
             <a:pPr>
               <a:spcBef>
-                <a:spcPts val="400"/>
+                <a:spcPts val="300"/>
               </a:spcBef>
               <a:defRPr sz="850" b="1">
                 <a:solidFill>
@@ -6968,7 +6458,7 @@
               </a:defRPr>
             </a:pPr>
             <a:r>
-              <a:t>▪  Optimized Relief Routing: </a:t>
+              <a:t>▪  Sustainable Urban Planning: </a:t>
             </a:r>
             <a:r>
               <a:rPr b="0">
@@ -6976,136 +6466,13 @@
                   <a:srgbClr val="1E293B"/>
                 </a:solidFill>
               </a:rPr>
-              <a:t>Avoids wasteful blanket relief by targeting water tankers to high-vulnerability wards.</a:t>
+              <a:t>Guides long-term municipal cool roof installations and tree planting programs.</a:t>
             </a:r>
           </a:p>
           <a:p>
             <a:pPr>
               <a:spcBef>
-                <a:spcPts val="400"/>
-              </a:spcBef>
-              <a:defRPr sz="850" b="1">
-                <a:solidFill>
-                  <a:srgbClr val="1D4E89"/>
-                </a:solidFill>
-              </a:defRPr>
-            </a:pPr>
-            <a:r>
-              <a:t>▪  Reduces Emergency Care Costs: </a:t>
-            </a:r>
-            <a:r>
-              <a:rPr b="0">
-                <a:solidFill>
-                  <a:srgbClr val="1E293B"/>
-                </a:solidFill>
-              </a:rPr>
-              <a:t>Pre-empts severe multi-organ failure and ICU hospitalization surges.</a:t>
-            </a:r>
-          </a:p>
-        </p:txBody>
-      </p:sp>
-      <p:sp>
-        <p:nvSpPr>
-          <p:cNvPr id="9" name="Rounded Rectangle 8"/>
-          <p:cNvSpPr/>
-          <p:nvPr/>
-        </p:nvSpPr>
-        <p:spPr>
-          <a:xfrm>
-            <a:off x="8028432" y="2880360"/>
-            <a:ext cx="3429000" cy="3474720"/>
-          </a:xfrm>
-          <a:prstGeom prst="roundRect">
-            <a:avLst/>
-          </a:prstGeom>
-          <a:solidFill>
-            <a:srgbClr val="FFFFFF"/>
-          </a:solidFill>
-          <a:ln w="19050">
-            <a:solidFill>
-              <a:srgbClr val="EA580C"/>
-            </a:solidFill>
-          </a:ln>
-        </p:spPr>
-        <p:style>
-          <a:lnRef idx="1">
-            <a:schemeClr val="accent1"/>
-          </a:lnRef>
-          <a:fillRef idx="3">
-            <a:schemeClr val="accent1"/>
-          </a:fillRef>
-          <a:effectRef idx="2">
-            <a:schemeClr val="accent1"/>
-          </a:effectRef>
-          <a:fontRef idx="minor">
-            <a:schemeClr val="lt1"/>
-          </a:fontRef>
-        </p:style>
-        <p:txBody>
-          <a:bodyPr rtlCol="0" anchor="ctr" wrap="square" lIns="0" tIns="0" rIns="0" bIns="0"/>
-          <a:lstStyle/>
-          <a:p>
-            <a:pPr algn="ctr">
-              <a:defRPr sz="1100" b="1">
-                <a:solidFill>
-                  <a:srgbClr val="EA580C"/>
-                </a:solidFill>
-              </a:defRPr>
-            </a:pPr>
-            <a:r>
-              <a:t>• Environmental &amp; Urban Benefits</a:t>
-            </a:r>
-          </a:p>
-          <a:p>
-            <a:pPr>
-              <a:spcBef>
-                <a:spcPts val="400"/>
-              </a:spcBef>
-              <a:defRPr sz="850" b="1">
-                <a:solidFill>
-                  <a:srgbClr val="1D4E89"/>
-                </a:solidFill>
-              </a:defRPr>
-            </a:pPr>
-            <a:r>
-              <a:t>▪  Urban Heat Island (UHI) Mapping: </a:t>
-            </a:r>
-            <a:r>
-              <a:rPr b="0">
-                <a:solidFill>
-                  <a:srgbClr val="1E293B"/>
-                </a:solidFill>
-              </a:rPr>
-              <a:t>Identifies micro-urban hot spots and green canopy deficits.</a:t>
-            </a:r>
-          </a:p>
-          <a:p>
-            <a:pPr>
-              <a:spcBef>
-                <a:spcPts val="400"/>
-              </a:spcBef>
-              <a:defRPr sz="850" b="1">
-                <a:solidFill>
-                  <a:srgbClr val="1D4E89"/>
-                </a:solidFill>
-              </a:defRPr>
-            </a:pPr>
-            <a:r>
-              <a:t>▪  Sustainable Urban Planning: </a:t>
-            </a:r>
-            <a:r>
-              <a:rPr b="0">
-                <a:solidFill>
-                  <a:srgbClr val="1E293B"/>
-                </a:solidFill>
-              </a:rPr>
-              <a:t>Guides long-term municipal cool roof installations and tree planting programs.</a:t>
-            </a:r>
-          </a:p>
-          <a:p>
-            <a:pPr>
-              <a:spcBef>
-                <a:spcPts val="400"/>
+                <a:spcPts val="300"/>
               </a:spcBef>
               <a:defRPr sz="850" b="1">
                 <a:solidFill>
@@ -7275,8 +6642,8 @@
         </p:nvSpPr>
         <p:spPr>
           <a:xfrm>
-            <a:off x="548640" y="182880"/>
-            <a:ext cx="1371600" cy="731520"/>
+            <a:off x="548640" y="164592"/>
+            <a:ext cx="1371600" cy="685800"/>
           </a:xfrm>
           <a:prstGeom prst="ellipse">
             <a:avLst/>
@@ -7309,7 +6676,7 @@
           <a:lstStyle/>
           <a:p>
             <a:pPr algn="ctr">
-              <a:defRPr sz="950" b="1">
+              <a:defRPr sz="900" b="1">
                 <a:solidFill>
                   <a:srgbClr val="000000"/>
                 </a:solidFill>
@@ -7322,7 +6689,7 @@
           </a:p>
           <a:p>
             <a:pPr algn="ctr">
-              <a:defRPr sz="950" b="1">
+              <a:defRPr sz="900" b="1">
                 <a:solidFill>
                   <a:srgbClr val="000000"/>
                 </a:solidFill>
@@ -7335,7 +6702,7 @@
           </a:p>
           <a:p>
             <a:pPr algn="ctr">
-              <a:defRPr sz="950" b="1">
+              <a:defRPr sz="900" b="1">
                 <a:solidFill>
                   <a:srgbClr val="000000"/>
                 </a:solidFill>
@@ -7356,8 +6723,8 @@
         </p:nvSpPr>
         <p:spPr>
           <a:xfrm>
-            <a:off x="2286000" y="228600"/>
-            <a:ext cx="7619695" cy="594360"/>
+            <a:off x="2194560" y="182880"/>
+            <a:ext cx="7589520" cy="594360"/>
           </a:xfrm>
           <a:prstGeom prst="rect">
             <a:avLst/>
@@ -7371,7 +6738,7 @@
           <a:lstStyle/>
           <a:p>
             <a:pPr algn="ctr">
-              <a:defRPr sz="1800" b="1">
+              <a:defRPr sz="1700" b="1">
                 <a:solidFill>
                   <a:srgbClr val="000000"/>
                 </a:solidFill>
@@ -7400,7 +6767,7 @@
         </p:blipFill>
         <p:spPr>
           <a:xfrm>
-            <a:off x="9875520" y="164592"/>
+            <a:off x="9875520" y="137160"/>
             <a:ext cx="1920240" cy="722376"/>
           </a:xfrm>
           <a:prstGeom prst="rect">

</xml_diff>